<commit_message>
Decks: re-exported with QR codes and AI accuracy; render cleanly in PowerPoint
- New exports of both decks: measured AI accuracy on slide 6, QR codes
  for the app and the product tour on slide 16
- Text set in Arial instead of Be Vietnam Pro: the web font is not
  embedded and, where it is not installed, PowerPoint mis-wrapped
  Vietnamese lines (a repeated word at line ends) and spaced titles
- Slide 15: the two text columns no longer overlap and the second row
  no longer touches the first
- Shorter Vietnamese accuracy line so it fits its box

Co-Authored-By: Claude Opus 5.5 <noreply@anthropic.com>
</commit_message>
<xml_diff>
--- a/FlyBot – Giới thiệu ứng dụng (link).pptx
+++ b/FlyBot – Giới thiệu ứng dụng (link).pptx
@@ -1133,7 +1133,7 @@
           <a:p>
             <a:r>
               <a:rPr lang="en-US" dirty="0"/>
-              <a:t>Ba bước: lắp camera EZVIZ trước tấm bẫy, thêm camera bằng số serial và mã xác minh rồi chọn loại bẫy, đặt ngưỡng cảnh báo và kênh nhận. Liên hệ contact@agrhub.com hoặc truy cập https://ezviz.agrhub.com.</a:t>
+              <a:t>Ba bước: lắp camera EZVIZ trước tấm bẫy, thêm camera bằng số serial và mã xác thực rồi chọn loại bẫy, đặt ngưỡng cảnh báo và kênh nhận. Liên hệ contact@agrhub.com hoặc truy cập https://ezviz.agrhub.com. Hai mã QR mở ứng dụng và video giới thiệu trên điện thoại.</a:t>
             </a:r>
             <a:endParaRPr lang="en-US" dirty="0"/>
           </a:p>
@@ -1573,7 +1573,7 @@
           <a:p>
             <a:r>
               <a:rPr lang="en-US" dirty="0"/>
-              <a:t>AI khoanh từng con côn trùng trên ảnh, ghi tên loài và độ tin cậy. Người dùng có thể xác nhận hoặc sửa số đếm; các ảnh đã duyệt được dùng để huấn luyện lại AI. Ảnh lỗi nhận dạng được tự động thử lại.</a:t>
+              <a:t>AI khoanh từng con côn trùng trên ảnh, ghi tên loài và độ tin cậy. Người dùng có thể xác nhận hoặc sửa số đếm; các ảnh đã duyệt được dùng để huấn luyện lại AI. Ảnh lỗi nhận dạng được tự động thử lại. Mô hình RF-DETR huấn luyện trên 1.573 ảnh với hơn 85.000 con ruồi đánh dấu; trên 76 ảnh kiểm thử, độ nhạy 92%, độ chính xác 93%, mAP@50 96%.</a:t>
             </a:r>
             <a:endParaRPr lang="en-US" dirty="0"/>
           </a:p>
@@ -1960,13 +1960,13 @@
                 <a:spcPct val="115000"/>
               </a:lnSpc>
               <a:buNone/>
-              <a:defRPr lang="en-US" sz="3190" dirty="0">
+              <a:defRPr lang="vi-VN" sz="3190" dirty="0">
                 <a:solidFill>
                   <a:srgbClr val="13261D"/>
                 </a:solidFill>
-                <a:latin typeface="Be Vietnam Pro" pitchFamily="34" charset="0"/>
-                <a:ea typeface="Be Vietnam Pro" pitchFamily="34" charset="-122"/>
-                <a:cs typeface="Be Vietnam Pro" pitchFamily="34" charset="-120"/>
+                <a:latin typeface="Arial" pitchFamily="34" charset="0"/>
+                <a:ea typeface="Arial" pitchFamily="34" charset="-122"/>
+                <a:cs typeface="Arial" pitchFamily="34" charset="-120"/>
               </a:defRPr>
             </a:lvl1pPr>
           </a:lstStyle>
@@ -1977,7 +1977,7 @@
               </a:lnSpc>
               <a:buNone/>
             </a:pPr>
-            <a:endParaRPr lang="en-US" sz="3190" dirty="0"/>
+            <a:endParaRPr lang="vi-VN" sz="3190" dirty="0"/>
           </a:p>
         </p:txBody>
       </p:sp>
@@ -2008,13 +2008,13 @@
                 <a:spcPct val="140000"/>
               </a:lnSpc>
               <a:buNone/>
-              <a:defRPr lang="en-US" sz="1600" dirty="0">
+              <a:defRPr lang="vi-VN" sz="1600" dirty="0">
                 <a:solidFill>
                   <a:srgbClr val="13261D"/>
                 </a:solidFill>
-                <a:latin typeface="Be Vietnam Pro" pitchFamily="34" charset="0"/>
-                <a:ea typeface="Be Vietnam Pro" pitchFamily="34" charset="-122"/>
-                <a:cs typeface="Be Vietnam Pro" pitchFamily="34" charset="-120"/>
+                <a:latin typeface="Arial" pitchFamily="34" charset="0"/>
+                <a:ea typeface="Arial" pitchFamily="34" charset="-122"/>
+                <a:cs typeface="Arial" pitchFamily="34" charset="-120"/>
               </a:defRPr>
             </a:lvl1pPr>
           </a:lstStyle>
@@ -2025,7 +2025,7 @@
               </a:lnSpc>
               <a:buNone/>
             </a:pPr>
-            <a:endParaRPr lang="en-US" sz="1600" dirty="0"/>
+            <a:endParaRPr lang="vi-VN" sz="1600" dirty="0"/>
           </a:p>
         </p:txBody>
       </p:sp>
@@ -2088,13 +2088,13 @@
                 <a:spcPct val="115000"/>
               </a:lnSpc>
               <a:buNone/>
-              <a:defRPr lang="en-US" sz="3190" dirty="0">
+              <a:defRPr lang="vi-VN" sz="3190" dirty="0">
                 <a:solidFill>
                   <a:srgbClr val="13261D"/>
                 </a:solidFill>
-                <a:latin typeface="Be Vietnam Pro" pitchFamily="34" charset="0"/>
-                <a:ea typeface="Be Vietnam Pro" pitchFamily="34" charset="-122"/>
-                <a:cs typeface="Be Vietnam Pro" pitchFamily="34" charset="-120"/>
+                <a:latin typeface="Arial" pitchFamily="34" charset="0"/>
+                <a:ea typeface="Arial" pitchFamily="34" charset="-122"/>
+                <a:cs typeface="Arial" pitchFamily="34" charset="-120"/>
               </a:defRPr>
             </a:lvl1pPr>
           </a:lstStyle>
@@ -2105,7 +2105,7 @@
               </a:lnSpc>
               <a:buNone/>
             </a:pPr>
-            <a:endParaRPr lang="en-US" sz="3190" dirty="0"/>
+            <a:endParaRPr lang="vi-VN" sz="3190" dirty="0"/>
           </a:p>
         </p:txBody>
       </p:sp>
@@ -2136,13 +2136,13 @@
                 <a:spcPct val="140000"/>
               </a:lnSpc>
               <a:buNone/>
-              <a:defRPr lang="en-US" sz="1600" dirty="0">
+              <a:defRPr lang="vi-VN" sz="1600" dirty="0">
                 <a:solidFill>
                   <a:srgbClr val="13261D"/>
                 </a:solidFill>
-                <a:latin typeface="Be Vietnam Pro" pitchFamily="34" charset="0"/>
-                <a:ea typeface="Be Vietnam Pro" pitchFamily="34" charset="-122"/>
-                <a:cs typeface="Be Vietnam Pro" pitchFamily="34" charset="-120"/>
+                <a:latin typeface="Arial" pitchFamily="34" charset="0"/>
+                <a:ea typeface="Arial" pitchFamily="34" charset="-122"/>
+                <a:cs typeface="Arial" pitchFamily="34" charset="-120"/>
               </a:defRPr>
             </a:lvl1pPr>
           </a:lstStyle>
@@ -2153,7 +2153,7 @@
               </a:lnSpc>
               <a:buNone/>
             </a:pPr>
-            <a:endParaRPr lang="en-US" sz="1600" dirty="0"/>
+            <a:endParaRPr lang="vi-VN" sz="1600" dirty="0"/>
           </a:p>
         </p:txBody>
       </p:sp>
@@ -2321,7 +2321,7 @@
     </p:bodyStyle>
     <p:otherStyle>
       <a:defPPr>
-        <a:defRPr lang="en-US"/>
+        <a:defRPr lang="vi-VN"/>
       </a:defPPr>
       <a:lvl1pPr marL="0" algn="l" defTabSz="914400" rtl="0" eaLnBrk="1" latinLnBrk="0" hangingPunct="1">
         <a:defRPr sz="1800" kern="1200">
@@ -2495,17 +2495,17 @@
               <a:buNone/>
             </a:pPr>
             <a:r>
-              <a:rPr lang="en-US" sz="2200" b="1" dirty="0">
+              <a:rPr lang="vi-VN" sz="2200" b="1" dirty="0">
                 <a:solidFill>
                   <a:srgbClr val="F5F7F1"/>
                 </a:solidFill>
-                <a:latin typeface="Be Vietnam Pro" pitchFamily="34" charset="0"/>
-                <a:ea typeface="Be Vietnam Pro" pitchFamily="34" charset="-122"/>
-                <a:cs typeface="Be Vietnam Pro" pitchFamily="34" charset="-120"/>
+                <a:latin typeface="Arial" pitchFamily="34" charset="0"/>
+                <a:ea typeface="Arial" pitchFamily="34" charset="-122"/>
+                <a:cs typeface="Arial" pitchFamily="34" charset="-120"/>
               </a:rPr>
               <a:t>FlyBot</a:t>
             </a:r>
-            <a:endParaRPr lang="en-US" sz="2200" dirty="0"/>
+            <a:endParaRPr lang="vi-VN" sz="2200" dirty="0"/>
           </a:p>
         </p:txBody>
       </p:sp>
@@ -2541,17 +2541,17 @@
               <a:buNone/>
             </a:pPr>
             <a:r>
-              <a:rPr lang="en-US" sz="3800" b="1" i="0" dirty="0">
+              <a:rPr lang="vi-VN" sz="3800" b="1" i="0" dirty="0">
                 <a:solidFill>
                   <a:srgbClr val="F5F7F1"/>
                 </a:solidFill>
-                <a:latin typeface="Be Vietnam Pro" pitchFamily="34" charset="0"/>
-                <a:ea typeface="Be Vietnam Pro" pitchFamily="34" charset="-122"/>
-                <a:cs typeface="Be Vietnam Pro" pitchFamily="34" charset="-120"/>
+                <a:latin typeface="Arial" pitchFamily="34" charset="0"/>
+                <a:ea typeface="Arial" pitchFamily="34" charset="-122"/>
+                <a:cs typeface="Arial" pitchFamily="34" charset="-120"/>
               </a:rPr>
               <a:t>Bẫy côn trùng thông minh: camera chụp, AI đếm</a:t>
             </a:r>
-            <a:endParaRPr lang="en-US" sz="3800" dirty="0"/>
+            <a:endParaRPr lang="vi-VN" sz="3800" dirty="0"/>
           </a:p>
         </p:txBody>
       </p:sp>
@@ -2585,17 +2585,17 @@
               <a:buNone/>
             </a:pPr>
             <a:r>
-              <a:rPr lang="en-US" sz="1600" dirty="0">
+              <a:rPr lang="vi-VN" sz="1600" dirty="0">
                 <a:solidFill>
                   <a:srgbClr val="BFD3C6"/>
                 </a:solidFill>
-                <a:latin typeface="Be Vietnam Pro" pitchFamily="34" charset="0"/>
-                <a:ea typeface="Be Vietnam Pro" pitchFamily="34" charset="-122"/>
-                <a:cs typeface="Be Vietnam Pro" pitchFamily="34" charset="-120"/>
+                <a:latin typeface="Arial" pitchFamily="34" charset="0"/>
+                <a:ea typeface="Arial" pitchFamily="34" charset="-122"/>
+                <a:cs typeface="Arial" pitchFamily="34" charset="-120"/>
               </a:rPr>
               <a:t>Theo dõi ruồi vàng và côn trùng gây hại trên từng bẫy, mỗi ngày, ngay trên điện thoại.</a:t>
             </a:r>
-            <a:endParaRPr lang="en-US" sz="1600" dirty="0"/>
+            <a:endParaRPr lang="vi-VN" sz="1600" dirty="0"/>
           </a:p>
         </p:txBody>
       </p:sp>
@@ -2633,17 +2633,17 @@
               <a:buNone/>
             </a:pPr>
             <a:r>
-              <a:rPr lang="en-US" sz="1200" b="1" dirty="0">
+              <a:rPr lang="vi-VN" sz="1200" b="1" dirty="0">
                 <a:solidFill>
                   <a:srgbClr val="13261D"/>
                 </a:solidFill>
-                <a:latin typeface="Be Vietnam Pro" pitchFamily="34" charset="0"/>
-                <a:ea typeface="Be Vietnam Pro" pitchFamily="34" charset="-122"/>
-                <a:cs typeface="Be Vietnam Pro" pitchFamily="34" charset="-120"/>
+                <a:latin typeface="Arial" pitchFamily="34" charset="0"/>
+                <a:ea typeface="Arial" pitchFamily="34" charset="-122"/>
+                <a:cs typeface="Arial" pitchFamily="34" charset="-120"/>
               </a:rPr>
               <a:t>Web · Điện thoại · Tiếng Việt và English</a:t>
             </a:r>
-            <a:endParaRPr lang="en-US" sz="1200" dirty="0"/>
+            <a:endParaRPr lang="vi-VN" sz="1200" dirty="0"/>
           </a:p>
         </p:txBody>
       </p:sp>
@@ -2677,13 +2677,13 @@
               <a:buNone/>
             </a:pPr>
             <a:r>
-              <a:rPr lang="en-US" sz="1400" b="1" u="sng" dirty="0">
+              <a:rPr lang="vi-VN" sz="1400" b="1" u="sng" dirty="0">
                 <a:solidFill>
                   <a:srgbClr val="F2C230"/>
                 </a:solidFill>
-                <a:latin typeface="Be Vietnam Pro" pitchFamily="34" charset="0"/>
-                <a:ea typeface="Be Vietnam Pro" pitchFamily="34" charset="-122"/>
-                <a:cs typeface="Be Vietnam Pro" pitchFamily="34" charset="-120"/>
+                <a:latin typeface="Arial" pitchFamily="34" charset="0"/>
+                <a:ea typeface="Arial" pitchFamily="34" charset="-122"/>
+                <a:cs typeface="Arial" pitchFamily="34" charset="-120"/>
                 <a:hlinkClick r:id="rId2" invalidUrl="" action="" tgtFrame="" tooltip="" history="1" highlightClick="0" endSnd="0">
                   <a:extLst>
                     <a:ext uri="{A12FA001-AC4F-418D-AE19-62706E023703}">
@@ -2694,7 +2694,7 @@
               </a:rPr>
               <a:t>ezviz.agrhub.com</a:t>
             </a:r>
-            <a:endParaRPr lang="en-US" sz="1400" dirty="0"/>
+            <a:endParaRPr lang="vi-VN" sz="1400" dirty="0"/>
           </a:p>
         </p:txBody>
       </p:sp>
@@ -2817,17 +2817,17 @@
               <a:buNone/>
             </a:pPr>
             <a:r>
-              <a:rPr lang="en-US" sz="1196" b="1" spc="150" kern="0" dirty="0">
+              <a:rPr lang="vi-VN" sz="1196" b="1" spc="150" kern="0" dirty="0">
                 <a:solidFill>
                   <a:srgbClr val="1D7A50"/>
                 </a:solidFill>
-                <a:latin typeface="Be Vietnam Pro" pitchFamily="34" charset="0"/>
-                <a:ea typeface="Be Vietnam Pro" pitchFamily="34" charset="-122"/>
-                <a:cs typeface="Be Vietnam Pro" pitchFamily="34" charset="-120"/>
+                <a:latin typeface="Arial" pitchFamily="34" charset="0"/>
+                <a:ea typeface="Arial" pitchFamily="34" charset="-122"/>
+                <a:cs typeface="Arial" pitchFamily="34" charset="-120"/>
               </a:rPr>
               <a:t>PHÂN TÍCH VÀ LỊCH SỬ</a:t>
             </a:r>
-            <a:endParaRPr lang="en-US" sz="1196" dirty="0"/>
+            <a:endParaRPr lang="vi-VN" sz="1196" dirty="0"/>
           </a:p>
         </p:txBody>
       </p:sp>
@@ -2863,17 +2863,17 @@
               <a:buNone/>
             </a:pPr>
             <a:r>
-              <a:rPr lang="en-US" sz="3190" b="1" i="0" dirty="0">
+              <a:rPr lang="vi-VN" sz="3190" b="1" i="0" dirty="0">
                 <a:solidFill>
                   <a:srgbClr val="13261D"/>
                 </a:solidFill>
-                <a:latin typeface="Be Vietnam Pro" pitchFamily="34" charset="0"/>
-                <a:ea typeface="Be Vietnam Pro" pitchFamily="34" charset="-122"/>
-                <a:cs typeface="Be Vietnam Pro" pitchFamily="34" charset="-120"/>
+                <a:latin typeface="Arial" pitchFamily="34" charset="0"/>
+                <a:ea typeface="Arial" pitchFamily="34" charset="-122"/>
+                <a:cs typeface="Arial" pitchFamily="34" charset="-120"/>
               </a:rPr>
               <a:t>Mọi ảnh đã phân tích, lọc và xuất khi cần</a:t>
             </a:r>
-            <a:endParaRPr lang="en-US" sz="3190" dirty="0"/>
+            <a:endParaRPr lang="vi-VN" sz="3190" dirty="0"/>
           </a:p>
         </p:txBody>
       </p:sp>
@@ -2986,17 +2986,17 @@
               <a:buNone/>
             </a:pPr>
             <a:r>
-              <a:rPr lang="en-US" sz="1600" b="1" dirty="0">
+              <a:rPr lang="vi-VN" sz="1600" b="1" dirty="0">
                 <a:solidFill>
                   <a:srgbClr val="13261D"/>
                 </a:solidFill>
-                <a:latin typeface="Be Vietnam Pro" pitchFamily="34" charset="0"/>
-                <a:ea typeface="Be Vietnam Pro" pitchFamily="34" charset="-122"/>
-                <a:cs typeface="Be Vietnam Pro" pitchFamily="34" charset="-120"/>
+                <a:latin typeface="Arial" pitchFamily="34" charset="0"/>
+                <a:ea typeface="Arial" pitchFamily="34" charset="-122"/>
+                <a:cs typeface="Arial" pitchFamily="34" charset="-120"/>
               </a:rPr>
               <a:t>Phân tích chuyên sâu</a:t>
             </a:r>
-            <a:endParaRPr lang="en-US" sz="1600" dirty="0"/>
+            <a:endParaRPr lang="vi-VN" sz="1600" dirty="0"/>
           </a:p>
         </p:txBody>
       </p:sp>
@@ -3030,17 +3030,17 @@
               <a:buNone/>
             </a:pPr>
             <a:r>
-              <a:rPr lang="en-US" sz="1300" dirty="0">
+              <a:rPr lang="vi-VN" sz="1300" dirty="0">
                 <a:solidFill>
                   <a:srgbClr val="4A5A50"/>
                 </a:solidFill>
-                <a:latin typeface="Be Vietnam Pro" pitchFamily="34" charset="0"/>
-                <a:ea typeface="Be Vietnam Pro" pitchFamily="34" charset="-122"/>
-                <a:cs typeface="Be Vietnam Pro" pitchFamily="34" charset="-120"/>
+                <a:latin typeface="Arial" pitchFamily="34" charset="0"/>
+                <a:ea typeface="Arial" pitchFamily="34" charset="-122"/>
+                <a:cs typeface="Arial" pitchFamily="34" charset="-120"/>
               </a:rPr>
               <a:t>So sánh bẫy, nhiệt độ so với số ruồi, khung giờ ruồi vào nhiều.</a:t>
             </a:r>
-            <a:endParaRPr lang="en-US" sz="1300" dirty="0"/>
+            <a:endParaRPr lang="vi-VN" sz="1300" dirty="0"/>
           </a:p>
         </p:txBody>
       </p:sp>
@@ -3074,17 +3074,17 @@
               <a:buNone/>
             </a:pPr>
             <a:r>
-              <a:rPr lang="en-US" sz="1600" b="1" dirty="0">
+              <a:rPr lang="vi-VN" sz="1600" b="1" dirty="0">
                 <a:solidFill>
                   <a:srgbClr val="13261D"/>
                 </a:solidFill>
-                <a:latin typeface="Be Vietnam Pro" pitchFamily="34" charset="0"/>
-                <a:ea typeface="Be Vietnam Pro" pitchFamily="34" charset="-122"/>
-                <a:cs typeface="Be Vietnam Pro" pitchFamily="34" charset="-120"/>
+                <a:latin typeface="Arial" pitchFamily="34" charset="0"/>
+                <a:ea typeface="Arial" pitchFamily="34" charset="-122"/>
+                <a:cs typeface="Arial" pitchFamily="34" charset="-120"/>
               </a:rPr>
               <a:t>Lọc theo nhu cầu</a:t>
             </a:r>
-            <a:endParaRPr lang="en-US" sz="1600" dirty="0"/>
+            <a:endParaRPr lang="vi-VN" sz="1600" dirty="0"/>
           </a:p>
         </p:txBody>
       </p:sp>
@@ -3118,17 +3118,17 @@
               <a:buNone/>
             </a:pPr>
             <a:r>
-              <a:rPr lang="en-US" sz="1300" dirty="0">
+              <a:rPr lang="vi-VN" sz="1300" dirty="0">
                 <a:solidFill>
                   <a:srgbClr val="4A5A50"/>
                 </a:solidFill>
-                <a:latin typeface="Be Vietnam Pro" pitchFamily="34" charset="0"/>
-                <a:ea typeface="Be Vietnam Pro" pitchFamily="34" charset="-122"/>
-                <a:cs typeface="Be Vietnam Pro" pitchFamily="34" charset="-120"/>
+                <a:latin typeface="Arial" pitchFamily="34" charset="0"/>
+                <a:ea typeface="Arial" pitchFamily="34" charset="-122"/>
+                <a:cs typeface="Arial" pitchFamily="34" charset="-120"/>
               </a:rPr>
               <a:t>Theo camera, thời gian, mức cảnh báo, trạng thái duyệt.</a:t>
             </a:r>
-            <a:endParaRPr lang="en-US" sz="1300" dirty="0"/>
+            <a:endParaRPr lang="vi-VN" sz="1300" dirty="0"/>
           </a:p>
         </p:txBody>
       </p:sp>
@@ -3162,17 +3162,17 @@
               <a:buNone/>
             </a:pPr>
             <a:r>
-              <a:rPr lang="en-US" sz="1600" b="1" dirty="0">
+              <a:rPr lang="vi-VN" sz="1600" b="1" dirty="0">
                 <a:solidFill>
                   <a:srgbClr val="13261D"/>
                 </a:solidFill>
-                <a:latin typeface="Be Vietnam Pro" pitchFamily="34" charset="0"/>
-                <a:ea typeface="Be Vietnam Pro" pitchFamily="34" charset="-122"/>
-                <a:cs typeface="Be Vietnam Pro" pitchFamily="34" charset="-120"/>
+                <a:latin typeface="Arial" pitchFamily="34" charset="0"/>
+                <a:ea typeface="Arial" pitchFamily="34" charset="-122"/>
+                <a:cs typeface="Arial" pitchFamily="34" charset="-120"/>
               </a:rPr>
               <a:t>Xuất kèm ảnh</a:t>
             </a:r>
-            <a:endParaRPr lang="en-US" sz="1600" dirty="0"/>
+            <a:endParaRPr lang="vi-VN" sz="1600" dirty="0"/>
           </a:p>
         </p:txBody>
       </p:sp>
@@ -3206,17 +3206,17 @@
               <a:buNone/>
             </a:pPr>
             <a:r>
-              <a:rPr lang="en-US" sz="1300" dirty="0">
+              <a:rPr lang="vi-VN" sz="1300" dirty="0">
                 <a:solidFill>
                   <a:srgbClr val="4A5A50"/>
                 </a:solidFill>
-                <a:latin typeface="Be Vietnam Pro" pitchFamily="34" charset="0"/>
-                <a:ea typeface="Be Vietnam Pro" pitchFamily="34" charset="-122"/>
-                <a:cs typeface="Be Vietnam Pro" pitchFamily="34" charset="-120"/>
+                <a:latin typeface="Arial" pitchFamily="34" charset="0"/>
+                <a:ea typeface="Arial" pitchFamily="34" charset="-122"/>
+                <a:cs typeface="Arial" pitchFamily="34" charset="-120"/>
               </a:rPr>
               <a:t>PDF và Excel kèm ảnh có khung nhận dạng, mỗi camera một sheet.</a:t>
             </a:r>
-            <a:endParaRPr lang="en-US" sz="1300" dirty="0"/>
+            <a:endParaRPr lang="vi-VN" sz="1300" dirty="0"/>
           </a:p>
         </p:txBody>
       </p:sp>
@@ -3250,17 +3250,17 @@
               <a:buNone/>
             </a:pPr>
             <a:r>
-              <a:rPr lang="en-US" sz="1200" dirty="0">
+              <a:rPr lang="vi-VN" sz="1200" dirty="0">
                 <a:solidFill>
                   <a:srgbClr val="6B7B70"/>
                 </a:solidFill>
-                <a:latin typeface="Be Vietnam Pro" pitchFamily="34" charset="0"/>
-                <a:ea typeface="Be Vietnam Pro" pitchFamily="34" charset="-122"/>
-                <a:cs typeface="Be Vietnam Pro" pitchFamily="34" charset="-120"/>
+                <a:latin typeface="Arial" pitchFamily="34" charset="0"/>
+                <a:ea typeface="Arial" pitchFamily="34" charset="-122"/>
+                <a:cs typeface="Arial" pitchFamily="34" charset="-120"/>
               </a:rPr>
               <a:t>FlyBot · 10</a:t>
             </a:r>
-            <a:endParaRPr lang="en-US" sz="1200" dirty="0"/>
+            <a:endParaRPr lang="vi-VN" sz="1200" dirty="0"/>
           </a:p>
         </p:txBody>
       </p:sp>
@@ -3326,17 +3326,17 @@
               <a:buNone/>
             </a:pPr>
             <a:r>
-              <a:rPr lang="en-US" sz="1196" b="1" spc="150" kern="0" dirty="0">
+              <a:rPr lang="vi-VN" sz="1196" b="1" spc="150" kern="0" dirty="0">
                 <a:solidFill>
                   <a:srgbClr val="1D7A50"/>
                 </a:solidFill>
-                <a:latin typeface="Be Vietnam Pro" pitchFamily="34" charset="0"/>
-                <a:ea typeface="Be Vietnam Pro" pitchFamily="34" charset="-122"/>
-                <a:cs typeface="Be Vietnam Pro" pitchFamily="34" charset="-120"/>
+                <a:latin typeface="Arial" pitchFamily="34" charset="0"/>
+                <a:ea typeface="Arial" pitchFamily="34" charset="-122"/>
+                <a:cs typeface="Arial" pitchFamily="34" charset="-120"/>
               </a:rPr>
               <a:t>BÁO CÁO</a:t>
             </a:r>
-            <a:endParaRPr lang="en-US" sz="1196" dirty="0"/>
+            <a:endParaRPr lang="vi-VN" sz="1196" dirty="0"/>
           </a:p>
         </p:txBody>
       </p:sp>
@@ -3372,17 +3372,17 @@
               <a:buNone/>
             </a:pPr>
             <a:r>
-              <a:rPr lang="en-US" sz="3190" b="1" i="0" dirty="0">
+              <a:rPr lang="vi-VN" sz="3190" b="1" i="0" dirty="0">
                 <a:solidFill>
                   <a:srgbClr val="13261D"/>
                 </a:solidFill>
-                <a:latin typeface="Be Vietnam Pro" pitchFamily="34" charset="0"/>
-                <a:ea typeface="Be Vietnam Pro" pitchFamily="34" charset="-122"/>
-                <a:cs typeface="Be Vietnam Pro" pitchFamily="34" charset="-120"/>
+                <a:latin typeface="Arial" pitchFamily="34" charset="0"/>
+                <a:ea typeface="Arial" pitchFamily="34" charset="-122"/>
+                <a:cs typeface="Arial" pitchFamily="34" charset="-120"/>
               </a:rPr>
               <a:t>Báo cáo tự thiết kế, tự gửi đến người cần</a:t>
             </a:r>
-            <a:endParaRPr lang="en-US" sz="3190" dirty="0"/>
+            <a:endParaRPr lang="vi-VN" sz="3190" dirty="0"/>
           </a:p>
         </p:txBody>
       </p:sp>
@@ -3495,17 +3495,17 @@
               <a:buNone/>
             </a:pPr>
             <a:r>
-              <a:rPr lang="en-US" sz="1600" b="1" dirty="0">
+              <a:rPr lang="vi-VN" sz="1600" b="1" dirty="0">
                 <a:solidFill>
                   <a:srgbClr val="13261D"/>
                 </a:solidFill>
-                <a:latin typeface="Be Vietnam Pro" pitchFamily="34" charset="0"/>
-                <a:ea typeface="Be Vietnam Pro" pitchFamily="34" charset="-122"/>
-                <a:cs typeface="Be Vietnam Pro" pitchFamily="34" charset="-120"/>
+                <a:latin typeface="Arial" pitchFamily="34" charset="0"/>
+                <a:ea typeface="Arial" pitchFamily="34" charset="-122"/>
+                <a:cs typeface="Arial" pitchFamily="34" charset="-120"/>
               </a:rPr>
               <a:t>Chọn các khối</a:t>
             </a:r>
-            <a:endParaRPr lang="en-US" sz="1600" dirty="0"/>
+            <a:endParaRPr lang="vi-VN" sz="1600" dirty="0"/>
           </a:p>
         </p:txBody>
       </p:sp>
@@ -3539,17 +3539,17 @@
               <a:buNone/>
             </a:pPr>
             <a:r>
-              <a:rPr lang="en-US" sz="1300" dirty="0">
+              <a:rPr lang="vi-VN" sz="1300" dirty="0">
                 <a:solidFill>
                   <a:srgbClr val="4A5A50"/>
                 </a:solidFill>
-                <a:latin typeface="Be Vietnam Pro" pitchFamily="34" charset="0"/>
-                <a:ea typeface="Be Vietnam Pro" pitchFamily="34" charset="-122"/>
-                <a:cs typeface="Be Vietnam Pro" pitchFamily="34" charset="-120"/>
+                <a:latin typeface="Arial" pitchFamily="34" charset="0"/>
+                <a:ea typeface="Arial" pitchFamily="34" charset="-122"/>
+                <a:cs typeface="Arial" pitchFamily="34" charset="-120"/>
               </a:rPr>
               <a:t>Chỉ số, biểu đồ, bảng; 7 ngày đến 12 tháng, so với kỳ trước.</a:t>
             </a:r>
-            <a:endParaRPr lang="en-US" sz="1300" dirty="0"/>
+            <a:endParaRPr lang="vi-VN" sz="1300" dirty="0"/>
           </a:p>
         </p:txBody>
       </p:sp>
@@ -3583,17 +3583,17 @@
               <a:buNone/>
             </a:pPr>
             <a:r>
-              <a:rPr lang="en-US" sz="1600" b="1" dirty="0">
+              <a:rPr lang="vi-VN" sz="1600" b="1" dirty="0">
                 <a:solidFill>
                   <a:srgbClr val="13261D"/>
                 </a:solidFill>
-                <a:latin typeface="Be Vietnam Pro" pitchFamily="34" charset="0"/>
-                <a:ea typeface="Be Vietnam Pro" pitchFamily="34" charset="-122"/>
-                <a:cs typeface="Be Vietnam Pro" pitchFamily="34" charset="-120"/>
+                <a:latin typeface="Arial" pitchFamily="34" charset="0"/>
+                <a:ea typeface="Arial" pitchFamily="34" charset="-122"/>
+                <a:cs typeface="Arial" pitchFamily="34" charset="-120"/>
               </a:rPr>
               <a:t>Gửi định kỳ</a:t>
             </a:r>
-            <a:endParaRPr lang="en-US" sz="1600" dirty="0"/>
+            <a:endParaRPr lang="vi-VN" sz="1600" dirty="0"/>
           </a:p>
         </p:txBody>
       </p:sp>
@@ -3627,17 +3627,17 @@
               <a:buNone/>
             </a:pPr>
             <a:r>
-              <a:rPr lang="en-US" sz="1300" dirty="0">
+              <a:rPr lang="vi-VN" sz="1300" dirty="0">
                 <a:solidFill>
                   <a:srgbClr val="4A5A50"/>
                 </a:solidFill>
-                <a:latin typeface="Be Vietnam Pro" pitchFamily="34" charset="0"/>
-                <a:ea typeface="Be Vietnam Pro" pitchFamily="34" charset="-122"/>
-                <a:cs typeface="Be Vietnam Pro" pitchFamily="34" charset="-120"/>
+                <a:latin typeface="Arial" pitchFamily="34" charset="0"/>
+                <a:ea typeface="Arial" pitchFamily="34" charset="-122"/>
+                <a:cs typeface="Arial" pitchFamily="34" charset="-120"/>
               </a:rPr>
               <a:t>Hằng tuần hoặc hằng tháng, kèm PDF, qua email và Telegram.</a:t>
             </a:r>
-            <a:endParaRPr lang="en-US" sz="1300" dirty="0"/>
+            <a:endParaRPr lang="vi-VN" sz="1300" dirty="0"/>
           </a:p>
         </p:txBody>
       </p:sp>
@@ -3671,17 +3671,17 @@
               <a:buNone/>
             </a:pPr>
             <a:r>
-              <a:rPr lang="en-US" sz="1600" b="1" dirty="0">
+              <a:rPr lang="vi-VN" sz="1600" b="1" dirty="0">
                 <a:solidFill>
                   <a:srgbClr val="13261D"/>
                 </a:solidFill>
-                <a:latin typeface="Be Vietnam Pro" pitchFamily="34" charset="0"/>
-                <a:ea typeface="Be Vietnam Pro" pitchFamily="34" charset="-122"/>
-                <a:cs typeface="Be Vietnam Pro" pitchFamily="34" charset="-120"/>
+                <a:latin typeface="Arial" pitchFamily="34" charset="0"/>
+                <a:ea typeface="Arial" pitchFamily="34" charset="-122"/>
+                <a:cs typeface="Arial" pitchFamily="34" charset="-120"/>
               </a:rPr>
               <a:t>Chia sẻ có thời hạn</a:t>
             </a:r>
-            <a:endParaRPr lang="en-US" sz="1600" dirty="0"/>
+            <a:endParaRPr lang="vi-VN" sz="1600" dirty="0"/>
           </a:p>
         </p:txBody>
       </p:sp>
@@ -3715,17 +3715,17 @@
               <a:buNone/>
             </a:pPr>
             <a:r>
-              <a:rPr lang="en-US" sz="1300" dirty="0">
+              <a:rPr lang="vi-VN" sz="1300" dirty="0">
                 <a:solidFill>
                   <a:srgbClr val="4A5A50"/>
                 </a:solidFill>
-                <a:latin typeface="Be Vietnam Pro" pitchFamily="34" charset="0"/>
-                <a:ea typeface="Be Vietnam Pro" pitchFamily="34" charset="-122"/>
-                <a:cs typeface="Be Vietnam Pro" pitchFamily="34" charset="-120"/>
+                <a:latin typeface="Arial" pitchFamily="34" charset="0"/>
+                <a:ea typeface="Arial" pitchFamily="34" charset="-122"/>
+                <a:cs typeface="Arial" pitchFamily="34" charset="-120"/>
               </a:rPr>
               <a:t>Chia sẻ cho đồng nghiệp hoặc qua link công khai, tự hết hạn.</a:t>
             </a:r>
-            <a:endParaRPr lang="en-US" sz="1300" dirty="0"/>
+            <a:endParaRPr lang="vi-VN" sz="1300" dirty="0"/>
           </a:p>
         </p:txBody>
       </p:sp>
@@ -3759,17 +3759,17 @@
               <a:buNone/>
             </a:pPr>
             <a:r>
-              <a:rPr lang="en-US" sz="1200" dirty="0">
+              <a:rPr lang="vi-VN" sz="1200" dirty="0">
                 <a:solidFill>
                   <a:srgbClr val="6B7B70"/>
                 </a:solidFill>
-                <a:latin typeface="Be Vietnam Pro" pitchFamily="34" charset="0"/>
-                <a:ea typeface="Be Vietnam Pro" pitchFamily="34" charset="-122"/>
-                <a:cs typeface="Be Vietnam Pro" pitchFamily="34" charset="-120"/>
+                <a:latin typeface="Arial" pitchFamily="34" charset="0"/>
+                <a:ea typeface="Arial" pitchFamily="34" charset="-122"/>
+                <a:cs typeface="Arial" pitchFamily="34" charset="-120"/>
               </a:rPr>
               <a:t>FlyBot · 11</a:t>
             </a:r>
-            <a:endParaRPr lang="en-US" sz="1200" dirty="0"/>
+            <a:endParaRPr lang="vi-VN" sz="1200" dirty="0"/>
           </a:p>
         </p:txBody>
       </p:sp>
@@ -3835,17 +3835,17 @@
               <a:buNone/>
             </a:pPr>
             <a:r>
-              <a:rPr lang="en-US" sz="1200" b="1" spc="150" kern="0" dirty="0">
+              <a:rPr lang="vi-VN" sz="1200" b="1" spc="150" kern="0" dirty="0">
                 <a:solidFill>
                   <a:srgbClr val="F2C230"/>
                 </a:solidFill>
-                <a:latin typeface="Be Vietnam Pro" pitchFamily="34" charset="0"/>
-                <a:ea typeface="Be Vietnam Pro" pitchFamily="34" charset="-122"/>
-                <a:cs typeface="Be Vietnam Pro" pitchFamily="34" charset="-120"/>
+                <a:latin typeface="Arial" pitchFamily="34" charset="0"/>
+                <a:ea typeface="Arial" pitchFamily="34" charset="-122"/>
+                <a:cs typeface="Arial" pitchFamily="34" charset="-120"/>
               </a:rPr>
               <a:t>TRỢ LÝ AI</a:t>
             </a:r>
-            <a:endParaRPr lang="en-US" sz="1200" dirty="0"/>
+            <a:endParaRPr lang="vi-VN" sz="1200" dirty="0"/>
           </a:p>
         </p:txBody>
       </p:sp>
@@ -3881,17 +3881,17 @@
               <a:buNone/>
             </a:pPr>
             <a:r>
-              <a:rPr lang="en-US" sz="3200" b="1" i="0" dirty="0">
+              <a:rPr lang="vi-VN" sz="3200" b="1" i="0" dirty="0">
                 <a:solidFill>
                   <a:srgbClr val="F5F7F1"/>
                 </a:solidFill>
-                <a:latin typeface="Be Vietnam Pro" pitchFamily="34" charset="0"/>
-                <a:ea typeface="Be Vietnam Pro" pitchFamily="34" charset="-122"/>
-                <a:cs typeface="Be Vietnam Pro" pitchFamily="34" charset="-120"/>
+                <a:latin typeface="Arial" pitchFamily="34" charset="0"/>
+                <a:ea typeface="Arial" pitchFamily="34" charset="-122"/>
+                <a:cs typeface="Arial" pitchFamily="34" charset="-120"/>
               </a:rPr>
               <a:t>Hỏi bằng lời, trợ lý tự tra cứu và làm</a:t>
             </a:r>
-            <a:endParaRPr lang="en-US" sz="3200" dirty="0"/>
+            <a:endParaRPr lang="vi-VN" sz="3200" dirty="0"/>
           </a:p>
         </p:txBody>
       </p:sp>
@@ -3975,17 +3975,17 @@
               <a:buNone/>
             </a:pPr>
             <a:r>
-              <a:rPr lang="en-US" sz="1800" b="1" dirty="0">
+              <a:rPr lang="vi-VN" sz="1800" b="1" dirty="0">
                 <a:solidFill>
                   <a:srgbClr val="F5F7F1"/>
                 </a:solidFill>
-                <a:latin typeface="Be Vietnam Pro" pitchFamily="34" charset="0"/>
-                <a:ea typeface="Be Vietnam Pro" pitchFamily="34" charset="-122"/>
-                <a:cs typeface="Be Vietnam Pro" pitchFamily="34" charset="-120"/>
+                <a:latin typeface="Arial" pitchFamily="34" charset="0"/>
+                <a:ea typeface="Arial" pitchFamily="34" charset="-122"/>
+                <a:cs typeface="Arial" pitchFamily="34" charset="-120"/>
               </a:rPr>
               <a:t>Bạn hỏi</a:t>
             </a:r>
-            <a:endParaRPr lang="en-US" sz="1800" dirty="0"/>
+            <a:endParaRPr lang="vi-VN" sz="1800" dirty="0"/>
           </a:p>
         </p:txBody>
       </p:sp>
@@ -4019,17 +4019,17 @@
               <a:buNone/>
             </a:pPr>
             <a:r>
-              <a:rPr lang="en-US" sz="1300" dirty="0">
+              <a:rPr lang="vi-VN" sz="1300" dirty="0">
                 <a:solidFill>
                   <a:srgbClr val="BFD3C6"/>
                 </a:solidFill>
-                <a:latin typeface="Be Vietnam Pro" pitchFamily="34" charset="0"/>
-                <a:ea typeface="Be Vietnam Pro" pitchFamily="34" charset="-122"/>
-                <a:cs typeface="Be Vietnam Pro" pitchFamily="34" charset="-120"/>
+                <a:latin typeface="Arial" pitchFamily="34" charset="0"/>
+                <a:ea typeface="Arial" pitchFamily="34" charset="-122"/>
+                <a:cs typeface="Arial" pitchFamily="34" charset="-120"/>
               </a:rPr>
               <a:t>"Bẫy nào đang nặng nhất?"</a:t>
             </a:r>
-            <a:endParaRPr lang="en-US" sz="1300" dirty="0"/>
+            <a:endParaRPr lang="vi-VN" sz="1300" dirty="0"/>
           </a:p>
           <a:p>
             <a:pPr algn="l" indent="0" marL="0">
@@ -4039,17 +4039,17 @@
               <a:buNone/>
             </a:pPr>
             <a:r>
-              <a:rPr lang="en-US" sz="1300" dirty="0">
+              <a:rPr lang="vi-VN" sz="1300" dirty="0">
                 <a:solidFill>
                   <a:srgbClr val="BFD3C6"/>
                 </a:solidFill>
-                <a:latin typeface="Be Vietnam Pro" pitchFamily="34" charset="0"/>
-                <a:ea typeface="Be Vietnam Pro" pitchFamily="34" charset="-122"/>
-                <a:cs typeface="Be Vietnam Pro" pitchFamily="34" charset="-120"/>
+                <a:latin typeface="Arial" pitchFamily="34" charset="0"/>
+                <a:ea typeface="Arial" pitchFamily="34" charset="-122"/>
+                <a:cs typeface="Arial" pitchFamily="34" charset="-120"/>
               </a:rPr>
               <a:t>"Lần phun tuần trước có hiệu quả không?"</a:t>
             </a:r>
-            <a:endParaRPr lang="en-US" sz="1300" dirty="0"/>
+            <a:endParaRPr lang="vi-VN" sz="1300" dirty="0"/>
           </a:p>
           <a:p>
             <a:pPr algn="l" indent="0" marL="0">
@@ -4059,17 +4059,17 @@
               <a:buNone/>
             </a:pPr>
             <a:r>
-              <a:rPr lang="en-US" sz="1300" dirty="0">
+              <a:rPr lang="vi-VN" sz="1300" dirty="0">
                 <a:solidFill>
                   <a:srgbClr val="BFD3C6"/>
                 </a:solidFill>
-                <a:latin typeface="Be Vietnam Pro" pitchFamily="34" charset="0"/>
-                <a:ea typeface="Be Vietnam Pro" pitchFamily="34" charset="-122"/>
-                <a:cs typeface="Be Vietnam Pro" pitchFamily="34" charset="-120"/>
+                <a:latin typeface="Arial" pitchFamily="34" charset="0"/>
+                <a:ea typeface="Arial" pitchFamily="34" charset="-122"/>
+                <a:cs typeface="Arial" pitchFamily="34" charset="-120"/>
               </a:rPr>
               <a:t>"Tôi đã thay tấm keo bẫy A1."</a:t>
             </a:r>
-            <a:endParaRPr lang="en-US" sz="1300" dirty="0"/>
+            <a:endParaRPr lang="vi-VN" sz="1300" dirty="0"/>
           </a:p>
         </p:txBody>
       </p:sp>
@@ -4176,17 +4176,17 @@
               <a:buNone/>
             </a:pPr>
             <a:r>
-              <a:rPr lang="en-US" sz="1800" b="1" dirty="0">
+              <a:rPr lang="vi-VN" sz="1800" b="1" dirty="0">
                 <a:solidFill>
                   <a:srgbClr val="F5F7F1"/>
                 </a:solidFill>
-                <a:latin typeface="Be Vietnam Pro" pitchFamily="34" charset="0"/>
-                <a:ea typeface="Be Vietnam Pro" pitchFamily="34" charset="-122"/>
-                <a:cs typeface="Be Vietnam Pro" pitchFamily="34" charset="-120"/>
+                <a:latin typeface="Arial" pitchFamily="34" charset="0"/>
+                <a:ea typeface="Arial" pitchFamily="34" charset="-122"/>
+                <a:cs typeface="Arial" pitchFamily="34" charset="-120"/>
               </a:rPr>
               <a:t>Trợ lý tự chọn công cụ</a:t>
             </a:r>
-            <a:endParaRPr lang="en-US" sz="1800" dirty="0"/>
+            <a:endParaRPr lang="vi-VN" sz="1800" dirty="0"/>
           </a:p>
         </p:txBody>
       </p:sp>
@@ -4220,17 +4220,17 @@
               <a:buNone/>
             </a:pPr>
             <a:r>
-              <a:rPr lang="en-US" sz="1300" dirty="0">
+              <a:rPr lang="vi-VN" sz="1300" dirty="0">
                 <a:solidFill>
                   <a:srgbClr val="BFD3C6"/>
                 </a:solidFill>
-                <a:latin typeface="Be Vietnam Pro" pitchFamily="34" charset="0"/>
-                <a:ea typeface="Be Vietnam Pro" pitchFamily="34" charset="-122"/>
-                <a:cs typeface="Be Vietnam Pro" pitchFamily="34" charset="-120"/>
+                <a:latin typeface="Arial" pitchFamily="34" charset="0"/>
+                <a:ea typeface="Arial" pitchFamily="34" charset="-122"/>
+                <a:cs typeface="Arial" pitchFamily="34" charset="-120"/>
               </a:rPr>
               <a:t>Số liệu bẫy, so sánh tuần, cảnh báo, báo cáo, nhật ký vườn; nhìn trực tiếp một ảnh; chụp ảnh, gửi báo cáo.</a:t>
             </a:r>
-            <a:endParaRPr lang="en-US" sz="1300" dirty="0"/>
+            <a:endParaRPr lang="vi-VN" sz="1300" dirty="0"/>
           </a:p>
         </p:txBody>
       </p:sp>
@@ -4332,17 +4332,17 @@
               <a:buNone/>
             </a:pPr>
             <a:r>
-              <a:rPr lang="en-US" sz="1800" b="1" dirty="0">
+              <a:rPr lang="vi-VN" sz="1800" b="1" dirty="0">
                 <a:solidFill>
                   <a:srgbClr val="13261D"/>
                 </a:solidFill>
-                <a:latin typeface="Be Vietnam Pro" pitchFamily="34" charset="0"/>
-                <a:ea typeface="Be Vietnam Pro" pitchFamily="34" charset="-122"/>
-                <a:cs typeface="Be Vietnam Pro" pitchFamily="34" charset="-120"/>
+                <a:latin typeface="Arial" pitchFamily="34" charset="0"/>
+                <a:ea typeface="Arial" pitchFamily="34" charset="-122"/>
+                <a:cs typeface="Arial" pitchFamily="34" charset="-120"/>
               </a:rPr>
               <a:t>Trả lời và dẫn đường</a:t>
             </a:r>
-            <a:endParaRPr lang="en-US" sz="1800" dirty="0"/>
+            <a:endParaRPr lang="vi-VN" sz="1800" dirty="0"/>
           </a:p>
         </p:txBody>
       </p:sp>
@@ -4376,17 +4376,17 @@
               <a:buNone/>
             </a:pPr>
             <a:r>
-              <a:rPr lang="en-US" sz="1300" dirty="0">
+              <a:rPr lang="vi-VN" sz="1300" dirty="0">
                 <a:solidFill>
                   <a:srgbClr val="4A5A50"/>
                 </a:solidFill>
-                <a:latin typeface="Be Vietnam Pro" pitchFamily="34" charset="0"/>
-                <a:ea typeface="Be Vietnam Pro" pitchFamily="34" charset="-122"/>
-                <a:cs typeface="Be Vietnam Pro" pitchFamily="34" charset="-120"/>
+                <a:latin typeface="Arial" pitchFamily="34" charset="0"/>
+                <a:ea typeface="Arial" pitchFamily="34" charset="-122"/>
+                <a:cs typeface="Arial" pitchFamily="34" charset="-120"/>
               </a:rPr>
               <a:t>Trả lời hiện dần, kèm ảnh, biểu đồ; mở đúng màn hình. Thay đổi chỉ được ghi khi bạn bấm Xác nhận.</a:t>
             </a:r>
-            <a:endParaRPr lang="en-US" sz="1300" dirty="0"/>
+            <a:endParaRPr lang="vi-VN" sz="1300" dirty="0"/>
           </a:p>
         </p:txBody>
       </p:sp>
@@ -4420,17 +4420,17 @@
               <a:buNone/>
             </a:pPr>
             <a:r>
-              <a:rPr lang="en-US" sz="1300" dirty="0">
+              <a:rPr lang="vi-VN" sz="1300" dirty="0">
                 <a:solidFill>
                   <a:srgbClr val="BFD3C6"/>
                 </a:solidFill>
-                <a:latin typeface="Be Vietnam Pro" pitchFamily="34" charset="0"/>
-                <a:ea typeface="Be Vietnam Pro" pitchFamily="34" charset="-122"/>
-                <a:cs typeface="Be Vietnam Pro" pitchFamily="34" charset="-120"/>
+                <a:latin typeface="Arial" pitchFamily="34" charset="0"/>
+                <a:ea typeface="Arial" pitchFamily="34" charset="-122"/>
+                <a:cs typeface="Arial" pitchFamily="34" charset="-120"/>
               </a:rPr>
               <a:t>Trợ lý chỉ thấy camera bạn có quyền xem, và không thay đổi cài đặt hay tài khoản.</a:t>
             </a:r>
-            <a:endParaRPr lang="en-US" sz="1300" dirty="0"/>
+            <a:endParaRPr lang="vi-VN" sz="1300" dirty="0"/>
           </a:p>
         </p:txBody>
       </p:sp>
@@ -4464,24 +4464,24 @@
               <a:buNone/>
             </a:pPr>
             <a:r>
-              <a:rPr lang="en-US" sz="1200" dirty="0">
+              <a:rPr lang="vi-VN" sz="1200" dirty="0">
                 <a:solidFill>
                   <a:srgbClr val="8FA898"/>
                 </a:solidFill>
-                <a:latin typeface="Be Vietnam Pro" pitchFamily="34" charset="0"/>
-                <a:ea typeface="Be Vietnam Pro" pitchFamily="34" charset="-122"/>
-                <a:cs typeface="Be Vietnam Pro" pitchFamily="34" charset="-120"/>
+                <a:latin typeface="Arial" pitchFamily="34" charset="0"/>
+                <a:ea typeface="Arial" pitchFamily="34" charset="-122"/>
+                <a:cs typeface="Arial" pitchFamily="34" charset="-120"/>
               </a:rPr>
               <a:t>FlyBot · 12 · Hướng dẫn chi tiết: </a:t>
             </a:r>
             <a:r>
-              <a:rPr lang="en-US" sz="1200" u="sng" dirty="0">
+              <a:rPr lang="vi-VN" sz="1200" u="sng" dirty="0">
                 <a:solidFill>
                   <a:srgbClr val="8FA898"/>
                 </a:solidFill>
-                <a:latin typeface="Be Vietnam Pro" pitchFamily="34" charset="0"/>
-                <a:ea typeface="Be Vietnam Pro" pitchFamily="34" charset="-122"/>
-                <a:cs typeface="Be Vietnam Pro" pitchFamily="34" charset="-120"/>
+                <a:latin typeface="Arial" pitchFamily="34" charset="0"/>
+                <a:ea typeface="Arial" pitchFamily="34" charset="-122"/>
+                <a:cs typeface="Arial" pitchFamily="34" charset="-120"/>
                 <a:hlinkClick r:id="rId6" invalidUrl="" action="" tgtFrame="" tooltip="" history="1" highlightClick="0" endSnd="0">
                   <a:extLst>
                     <a:ext uri="{A12FA001-AC4F-418D-AE19-62706E023703}">
@@ -4492,7 +4492,7 @@
               </a:rPr>
               <a:t>ezviz.agrhub.com/manual</a:t>
             </a:r>
-            <a:endParaRPr lang="en-US" sz="1200" dirty="0"/>
+            <a:endParaRPr lang="vi-VN" sz="1200" dirty="0"/>
           </a:p>
         </p:txBody>
       </p:sp>
@@ -4558,17 +4558,17 @@
               <a:buNone/>
             </a:pPr>
             <a:r>
-              <a:rPr lang="en-US" sz="1200" b="1" spc="150" kern="0" dirty="0">
+              <a:rPr lang="vi-VN" sz="1200" b="1" spc="150" kern="0" dirty="0">
                 <a:solidFill>
                   <a:srgbClr val="1D7A50"/>
                 </a:solidFill>
-                <a:latin typeface="Be Vietnam Pro" pitchFamily="34" charset="0"/>
-                <a:ea typeface="Be Vietnam Pro" pitchFamily="34" charset="-122"/>
-                <a:cs typeface="Be Vietnam Pro" pitchFamily="34" charset="-120"/>
+                <a:latin typeface="Arial" pitchFamily="34" charset="0"/>
+                <a:ea typeface="Arial" pitchFamily="34" charset="-122"/>
+                <a:cs typeface="Arial" pitchFamily="34" charset="-120"/>
               </a:rPr>
               <a:t>TRỢ LÝ AI TRONG ỨNG DỤNG</a:t>
             </a:r>
-            <a:endParaRPr lang="en-US" sz="1200" dirty="0"/>
+            <a:endParaRPr lang="vi-VN" sz="1200" dirty="0"/>
           </a:p>
         </p:txBody>
       </p:sp>
@@ -4604,17 +4604,17 @@
               <a:buNone/>
             </a:pPr>
             <a:r>
-              <a:rPr lang="en-US" sz="3200" b="1" i="0" dirty="0">
+              <a:rPr lang="vi-VN" sz="3200" b="1" i="0" dirty="0">
                 <a:solidFill>
                   <a:srgbClr val="13261D"/>
                 </a:solidFill>
-                <a:latin typeface="Be Vietnam Pro" pitchFamily="34" charset="0"/>
-                <a:ea typeface="Be Vietnam Pro" pitchFamily="34" charset="-122"/>
-                <a:cs typeface="Be Vietnam Pro" pitchFamily="34" charset="-120"/>
+                <a:latin typeface="Arial" pitchFamily="34" charset="0"/>
+                <a:ea typeface="Arial" pitchFamily="34" charset="-122"/>
+                <a:cs typeface="Arial" pitchFamily="34" charset="-120"/>
               </a:rPr>
               <a:t>Trả lời bằng ảnh, biểu đồ và nút bấm</a:t>
             </a:r>
-            <a:endParaRPr lang="en-US" sz="3200" dirty="0"/>
+            <a:endParaRPr lang="vi-VN" sz="3200" dirty="0"/>
           </a:p>
         </p:txBody>
       </p:sp>
@@ -4648,17 +4648,17 @@
               <a:buNone/>
             </a:pPr>
             <a:r>
-              <a:rPr lang="en-US" sz="1200" b="1" dirty="0">
+              <a:rPr lang="vi-VN" sz="1200" b="1" dirty="0">
                 <a:solidFill>
                   <a:srgbClr val="13261D"/>
                 </a:solidFill>
-                <a:latin typeface="Be Vietnam Pro" pitchFamily="34" charset="0"/>
-                <a:ea typeface="Be Vietnam Pro" pitchFamily="34" charset="-122"/>
-                <a:cs typeface="Be Vietnam Pro" pitchFamily="34" charset="-120"/>
+                <a:latin typeface="Arial" pitchFamily="34" charset="0"/>
+                <a:ea typeface="Arial" pitchFamily="34" charset="-122"/>
+                <a:cs typeface="Arial" pitchFamily="34" charset="-120"/>
               </a:rPr>
               <a:t>Ảnh nhận dạng mới nhất</a:t>
             </a:r>
-            <a:endParaRPr lang="en-US" sz="1200" dirty="0"/>
+            <a:endParaRPr lang="vi-VN" sz="1200" dirty="0"/>
           </a:p>
         </p:txBody>
       </p:sp>
@@ -4771,17 +4771,17 @@
               <a:buNone/>
             </a:pPr>
             <a:r>
-              <a:rPr lang="en-US" sz="1200" b="1" dirty="0">
+              <a:rPr lang="vi-VN" sz="1200" b="1" dirty="0">
                 <a:solidFill>
                   <a:srgbClr val="13261D"/>
                 </a:solidFill>
-                <a:latin typeface="Be Vietnam Pro" pitchFamily="34" charset="0"/>
-                <a:ea typeface="Be Vietnam Pro" pitchFamily="34" charset="-122"/>
-                <a:cs typeface="Be Vietnam Pro" pitchFamily="34" charset="-120"/>
+                <a:latin typeface="Arial" pitchFamily="34" charset="0"/>
+                <a:ea typeface="Arial" pitchFamily="34" charset="-122"/>
+                <a:cs typeface="Arial" pitchFamily="34" charset="-120"/>
               </a:rPr>
               <a:t>Biểu đồ ngay trong chat</a:t>
             </a:r>
-            <a:endParaRPr lang="en-US" sz="1200" dirty="0"/>
+            <a:endParaRPr lang="vi-VN" sz="1200" dirty="0"/>
           </a:p>
         </p:txBody>
       </p:sp>
@@ -4894,17 +4894,17 @@
               <a:buNone/>
             </a:pPr>
             <a:r>
-              <a:rPr lang="en-US" sz="1200" b="1" dirty="0">
+              <a:rPr lang="vi-VN" sz="1200" b="1" dirty="0">
                 <a:solidFill>
                   <a:srgbClr val="13261D"/>
                 </a:solidFill>
-                <a:latin typeface="Be Vietnam Pro" pitchFamily="34" charset="0"/>
-                <a:ea typeface="Be Vietnam Pro" pitchFamily="34" charset="-122"/>
-                <a:cs typeface="Be Vietnam Pro" pitchFamily="34" charset="-120"/>
+                <a:latin typeface="Arial" pitchFamily="34" charset="0"/>
+                <a:ea typeface="Arial" pitchFamily="34" charset="-122"/>
+                <a:cs typeface="Arial" pitchFamily="34" charset="-120"/>
               </a:rPr>
               <a:t>Hỏi về một ảnh</a:t>
             </a:r>
-            <a:endParaRPr lang="en-US" sz="1200" dirty="0"/>
+            <a:endParaRPr lang="vi-VN" sz="1200" dirty="0"/>
           </a:p>
         </p:txBody>
       </p:sp>
@@ -5017,17 +5017,17 @@
               <a:buNone/>
             </a:pPr>
             <a:r>
-              <a:rPr lang="en-US" sz="1200" b="1" dirty="0">
+              <a:rPr lang="vi-VN" sz="1200" b="1" dirty="0">
                 <a:solidFill>
                   <a:srgbClr val="13261D"/>
                 </a:solidFill>
-                <a:latin typeface="Be Vietnam Pro" pitchFamily="34" charset="0"/>
-                <a:ea typeface="Be Vietnam Pro" pitchFamily="34" charset="-122"/>
-                <a:cs typeface="Be Vietnam Pro" pitchFamily="34" charset="-120"/>
+                <a:latin typeface="Arial" pitchFamily="34" charset="0"/>
+                <a:ea typeface="Arial" pitchFamily="34" charset="-122"/>
+                <a:cs typeface="Arial" pitchFamily="34" charset="-120"/>
               </a:rPr>
               <a:t>Ghi nhận khi bạn xác nhận</a:t>
             </a:r>
-            <a:endParaRPr lang="en-US" sz="1200" dirty="0"/>
+            <a:endParaRPr lang="vi-VN" sz="1200" dirty="0"/>
           </a:p>
         </p:txBody>
       </p:sp>
@@ -5140,24 +5140,24 @@
               <a:buNone/>
             </a:pPr>
             <a:r>
-              <a:rPr lang="en-US" sz="1200" dirty="0">
+              <a:rPr lang="vi-VN" sz="1200" dirty="0">
                 <a:solidFill>
                   <a:srgbClr val="6B7B70"/>
                 </a:solidFill>
-                <a:latin typeface="Be Vietnam Pro" pitchFamily="34" charset="0"/>
-                <a:ea typeface="Be Vietnam Pro" pitchFamily="34" charset="-122"/>
-                <a:cs typeface="Be Vietnam Pro" pitchFamily="34" charset="-120"/>
+                <a:latin typeface="Arial" pitchFamily="34" charset="0"/>
+                <a:ea typeface="Arial" pitchFamily="34" charset="-122"/>
+                <a:cs typeface="Arial" pitchFamily="34" charset="-120"/>
               </a:rPr>
               <a:t>FlyBot · 13 · Hướng dẫn chi tiết: </a:t>
             </a:r>
             <a:r>
-              <a:rPr lang="en-US" sz="1200" u="sng" dirty="0">
+              <a:rPr lang="vi-VN" sz="1200" u="sng" dirty="0">
                 <a:solidFill>
                   <a:srgbClr val="6B7B70"/>
                 </a:solidFill>
-                <a:latin typeface="Be Vietnam Pro" pitchFamily="34" charset="0"/>
-                <a:ea typeface="Be Vietnam Pro" pitchFamily="34" charset="-122"/>
-                <a:cs typeface="Be Vietnam Pro" pitchFamily="34" charset="-120"/>
+                <a:latin typeface="Arial" pitchFamily="34" charset="0"/>
+                <a:ea typeface="Arial" pitchFamily="34" charset="-122"/>
+                <a:cs typeface="Arial" pitchFamily="34" charset="-120"/>
                 <a:hlinkClick r:id="rId5" invalidUrl="" action="" tgtFrame="" tooltip="" history="1" highlightClick="0" endSnd="0">
                   <a:extLst>
                     <a:ext uri="{A12FA001-AC4F-418D-AE19-62706E023703}">
@@ -5168,7 +5168,7 @@
               </a:rPr>
               <a:t>ezviz.agrhub.com/manual</a:t>
             </a:r>
-            <a:endParaRPr lang="en-US" sz="1200" dirty="0"/>
+            <a:endParaRPr lang="vi-VN" sz="1200" dirty="0"/>
           </a:p>
         </p:txBody>
       </p:sp>
@@ -5234,17 +5234,17 @@
               <a:buNone/>
             </a:pPr>
             <a:r>
-              <a:rPr lang="en-US" sz="1196" b="1" spc="150" kern="0" dirty="0">
+              <a:rPr lang="vi-VN" sz="1196" b="1" spc="150" kern="0" dirty="0">
                 <a:solidFill>
                   <a:srgbClr val="1D7A50"/>
                 </a:solidFill>
-                <a:latin typeface="Be Vietnam Pro" pitchFamily="34" charset="0"/>
-                <a:ea typeface="Be Vietnam Pro" pitchFamily="34" charset="-122"/>
-                <a:cs typeface="Be Vietnam Pro" pitchFamily="34" charset="-120"/>
+                <a:latin typeface="Arial" pitchFamily="34" charset="0"/>
+                <a:ea typeface="Arial" pitchFamily="34" charset="-122"/>
+                <a:cs typeface="Arial" pitchFamily="34" charset="-120"/>
               </a:rPr>
               <a:t>VƯỜN, BẢN ĐỒ VÀ NHẬT KÝ</a:t>
             </a:r>
-            <a:endParaRPr lang="en-US" sz="1196" dirty="0"/>
+            <a:endParaRPr lang="vi-VN" sz="1196" dirty="0"/>
           </a:p>
         </p:txBody>
       </p:sp>
@@ -5280,17 +5280,17 @@
               <a:buNone/>
             </a:pPr>
             <a:r>
-              <a:rPr lang="en-US" sz="3190" b="1" i="0" dirty="0">
+              <a:rPr lang="vi-VN" sz="3190" b="1" i="0" dirty="0">
                 <a:solidFill>
                   <a:srgbClr val="13261D"/>
                 </a:solidFill>
-                <a:latin typeface="Be Vietnam Pro" pitchFamily="34" charset="0"/>
-                <a:ea typeface="Be Vietnam Pro" pitchFamily="34" charset="-122"/>
-                <a:cs typeface="Be Vietnam Pro" pitchFamily="34" charset="-120"/>
+                <a:latin typeface="Arial" pitchFamily="34" charset="0"/>
+                <a:ea typeface="Arial" pitchFamily="34" charset="-122"/>
+                <a:cs typeface="Arial" pitchFamily="34" charset="-120"/>
               </a:rPr>
               <a:t>Biết biện pháp nào thực sự hiệu quả</a:t>
             </a:r>
-            <a:endParaRPr lang="en-US" sz="3190" dirty="0"/>
+            <a:endParaRPr lang="vi-VN" sz="3190" dirty="0"/>
           </a:p>
         </p:txBody>
       </p:sp>
@@ -5403,17 +5403,17 @@
               <a:buNone/>
             </a:pPr>
             <a:r>
-              <a:rPr lang="en-US" sz="1600" b="1" dirty="0">
+              <a:rPr lang="vi-VN" sz="1600" b="1" dirty="0">
                 <a:solidFill>
                   <a:srgbClr val="13261D"/>
                 </a:solidFill>
-                <a:latin typeface="Be Vietnam Pro" pitchFamily="34" charset="0"/>
-                <a:ea typeface="Be Vietnam Pro" pitchFamily="34" charset="-122"/>
-                <a:cs typeface="Be Vietnam Pro" pitchFamily="34" charset="-120"/>
+                <a:latin typeface="Arial" pitchFamily="34" charset="0"/>
+                <a:ea typeface="Arial" pitchFamily="34" charset="-122"/>
+                <a:cs typeface="Arial" pitchFamily="34" charset="-120"/>
               </a:rPr>
               <a:t>Vườn, lô và bản đồ</a:t>
             </a:r>
-            <a:endParaRPr lang="en-US" sz="1600" dirty="0"/>
+            <a:endParaRPr lang="vi-VN" sz="1600" dirty="0"/>
           </a:p>
         </p:txBody>
       </p:sp>
@@ -5447,17 +5447,17 @@
               <a:buNone/>
             </a:pPr>
             <a:r>
-              <a:rPr lang="en-US" sz="1300" dirty="0">
+              <a:rPr lang="vi-VN" sz="1300" dirty="0">
                 <a:solidFill>
                   <a:srgbClr val="4A5A50"/>
                 </a:solidFill>
-                <a:latin typeface="Be Vietnam Pro" pitchFamily="34" charset="0"/>
-                <a:ea typeface="Be Vietnam Pro" pitchFamily="34" charset="-122"/>
-                <a:cs typeface="Be Vietnam Pro" pitchFamily="34" charset="-120"/>
+                <a:latin typeface="Arial" pitchFamily="34" charset="0"/>
+                <a:ea typeface="Arial" pitchFamily="34" charset="-122"/>
+                <a:cs typeface="Arial" pitchFamily="34" charset="-120"/>
               </a:rPr>
               <a:t>Bẫy gắn với lô; bản đồ nhiệt cho thấy chỗ nóng dịch hại.</a:t>
             </a:r>
-            <a:endParaRPr lang="en-US" sz="1300" dirty="0"/>
+            <a:endParaRPr lang="vi-VN" sz="1300" dirty="0"/>
           </a:p>
         </p:txBody>
       </p:sp>
@@ -5491,17 +5491,17 @@
               <a:buNone/>
             </a:pPr>
             <a:r>
-              <a:rPr lang="en-US" sz="1600" b="1" dirty="0">
+              <a:rPr lang="vi-VN" sz="1600" b="1" dirty="0">
                 <a:solidFill>
                   <a:srgbClr val="13261D"/>
                 </a:solidFill>
-                <a:latin typeface="Be Vietnam Pro" pitchFamily="34" charset="0"/>
-                <a:ea typeface="Be Vietnam Pro" pitchFamily="34" charset="-122"/>
-                <a:cs typeface="Be Vietnam Pro" pitchFamily="34" charset="-120"/>
+                <a:latin typeface="Arial" pitchFamily="34" charset="0"/>
+                <a:ea typeface="Arial" pitchFamily="34" charset="-122"/>
+                <a:cs typeface="Arial" pitchFamily="34" charset="-120"/>
               </a:rPr>
               <a:t>Nhật ký xử lý</a:t>
             </a:r>
-            <a:endParaRPr lang="en-US" sz="1600" dirty="0"/>
+            <a:endParaRPr lang="vi-VN" sz="1600" dirty="0"/>
           </a:p>
         </p:txBody>
       </p:sp>
@@ -5535,17 +5535,17 @@
               <a:buNone/>
             </a:pPr>
             <a:r>
-              <a:rPr lang="en-US" sz="1300" dirty="0">
+              <a:rPr lang="vi-VN" sz="1300" dirty="0">
                 <a:solidFill>
                   <a:srgbClr val="4A5A50"/>
                 </a:solidFill>
-                <a:latin typeface="Be Vietnam Pro" pitchFamily="34" charset="0"/>
-                <a:ea typeface="Be Vietnam Pro" pitchFamily="34" charset="-122"/>
-                <a:cs typeface="Be Vietnam Pro" pitchFamily="34" charset="-120"/>
+                <a:latin typeface="Arial" pitchFamily="34" charset="0"/>
+                <a:ea typeface="Arial" pitchFamily="34" charset="-122"/>
+                <a:cs typeface="Arial" pitchFamily="34" charset="-120"/>
               </a:rPr>
               <a:t>Mỗi lần phun hay đặt bả kèm hiệu quả đo được trên số ruồi.</a:t>
             </a:r>
-            <a:endParaRPr lang="en-US" sz="1300" dirty="0"/>
+            <a:endParaRPr lang="vi-VN" sz="1300" dirty="0"/>
           </a:p>
         </p:txBody>
       </p:sp>
@@ -5579,17 +5579,17 @@
               <a:buNone/>
             </a:pPr>
             <a:r>
-              <a:rPr lang="en-US" sz="1600" b="1" dirty="0">
+              <a:rPr lang="vi-VN" sz="1600" b="1" dirty="0">
                 <a:solidFill>
                   <a:srgbClr val="13261D"/>
                 </a:solidFill>
-                <a:latin typeface="Be Vietnam Pro" pitchFamily="34" charset="0"/>
-                <a:ea typeface="Be Vietnam Pro" pitchFamily="34" charset="-122"/>
-                <a:cs typeface="Be Vietnam Pro" pitchFamily="34" charset="-120"/>
+                <a:latin typeface="Arial" pitchFamily="34" charset="0"/>
+                <a:ea typeface="Arial" pitchFamily="34" charset="-122"/>
+                <a:cs typeface="Arial" pitchFamily="34" charset="-120"/>
               </a:rPr>
               <a:t>Sổ VietGAP</a:t>
             </a:r>
-            <a:endParaRPr lang="en-US" sz="1600" dirty="0"/>
+            <a:endParaRPr lang="vi-VN" sz="1600" dirty="0"/>
           </a:p>
         </p:txBody>
       </p:sp>
@@ -5623,17 +5623,17 @@
               <a:buNone/>
             </a:pPr>
             <a:r>
-              <a:rPr lang="en-US" sz="1300" dirty="0">
+              <a:rPr lang="vi-VN" sz="1300" dirty="0">
                 <a:solidFill>
                   <a:srgbClr val="4A5A50"/>
                 </a:solidFill>
-                <a:latin typeface="Be Vietnam Pro" pitchFamily="34" charset="0"/>
-                <a:ea typeface="Be Vietnam Pro" pitchFamily="34" charset="-122"/>
-                <a:cs typeface="Be Vietnam Pro" pitchFamily="34" charset="-120"/>
+                <a:latin typeface="Arial" pitchFamily="34" charset="0"/>
+                <a:ea typeface="Arial" pitchFamily="34" charset="-122"/>
+                <a:cs typeface="Arial" pitchFamily="34" charset="-120"/>
               </a:rPr>
               <a:t>Xuất sổ ghi chép sử dụng thuốc BVTV theo mẫu VietGAP.</a:t>
             </a:r>
-            <a:endParaRPr lang="en-US" sz="1300" dirty="0"/>
+            <a:endParaRPr lang="vi-VN" sz="1300" dirty="0"/>
           </a:p>
         </p:txBody>
       </p:sp>
@@ -5667,17 +5667,17 @@
               <a:buNone/>
             </a:pPr>
             <a:r>
-              <a:rPr lang="en-US" sz="1200" dirty="0">
+              <a:rPr lang="vi-VN" sz="1200" dirty="0">
                 <a:solidFill>
                   <a:srgbClr val="6B7B70"/>
                 </a:solidFill>
-                <a:latin typeface="Be Vietnam Pro" pitchFamily="34" charset="0"/>
-                <a:ea typeface="Be Vietnam Pro" pitchFamily="34" charset="-122"/>
-                <a:cs typeface="Be Vietnam Pro" pitchFamily="34" charset="-120"/>
+                <a:latin typeface="Arial" pitchFamily="34" charset="0"/>
+                <a:ea typeface="Arial" pitchFamily="34" charset="-122"/>
+                <a:cs typeface="Arial" pitchFamily="34" charset="-120"/>
               </a:rPr>
               <a:t>FlyBot · 14</a:t>
             </a:r>
-            <a:endParaRPr lang="en-US" sz="1200" dirty="0"/>
+            <a:endParaRPr lang="vi-VN" sz="1200" dirty="0"/>
           </a:p>
         </p:txBody>
       </p:sp>
@@ -5822,17 +5822,17 @@
               <a:buNone/>
             </a:pPr>
             <a:r>
-              <a:rPr lang="en-US" sz="1200" b="1" spc="150" kern="0" dirty="0">
+              <a:rPr lang="vi-VN" sz="1200" b="1" spc="150" kern="0" dirty="0">
                 <a:solidFill>
                   <a:srgbClr val="1D7A50"/>
                 </a:solidFill>
-                <a:latin typeface="Be Vietnam Pro" pitchFamily="34" charset="0"/>
-                <a:ea typeface="Be Vietnam Pro" pitchFamily="34" charset="-122"/>
-                <a:cs typeface="Be Vietnam Pro" pitchFamily="34" charset="-120"/>
+                <a:latin typeface="Arial" pitchFamily="34" charset="0"/>
+                <a:ea typeface="Arial" pitchFamily="34" charset="-122"/>
+                <a:cs typeface="Arial" pitchFamily="34" charset="-120"/>
               </a:rPr>
               <a:t>ĐIỆN THOẠI VÀ ĐỘI NHÓM</a:t>
             </a:r>
-            <a:endParaRPr lang="en-US" sz="1200" dirty="0"/>
+            <a:endParaRPr lang="vi-VN" sz="1200" dirty="0"/>
           </a:p>
         </p:txBody>
       </p:sp>
@@ -5868,17 +5868,17 @@
               <a:buNone/>
             </a:pPr>
             <a:r>
-              <a:rPr lang="en-US" sz="3200" b="1" i="0" dirty="0">
+              <a:rPr lang="vi-VN" sz="3200" b="1" i="0" dirty="0">
                 <a:solidFill>
                   <a:srgbClr val="13261D"/>
                 </a:solidFill>
-                <a:latin typeface="Be Vietnam Pro" pitchFamily="34" charset="0"/>
-                <a:ea typeface="Be Vietnam Pro" pitchFamily="34" charset="-122"/>
-                <a:cs typeface="Be Vietnam Pro" pitchFamily="34" charset="-120"/>
+                <a:latin typeface="Arial" pitchFamily="34" charset="0"/>
+                <a:ea typeface="Arial" pitchFamily="34" charset="-122"/>
+                <a:cs typeface="Arial" pitchFamily="34" charset="-120"/>
               </a:rPr>
               <a:t>Cả đội cùng theo dõi, mỗi người đúng quyền</a:t>
             </a:r>
-            <a:endParaRPr lang="en-US" sz="3200" dirty="0"/>
+            <a:endParaRPr lang="vi-VN" sz="3200" dirty="0"/>
           </a:p>
         </p:txBody>
       </p:sp>
@@ -5891,7 +5891,7 @@
         <p:spPr>
           <a:xfrm>
             <a:off x="3721100" y="3304480"/>
-            <a:ext cx="3943922" cy="279400"/>
+            <a:ext cx="3524250" cy="279400"/>
           </a:xfrm>
           <a:prstGeom prst="rect">
             <a:avLst/>
@@ -5912,17 +5912,17 @@
               <a:buNone/>
             </a:pPr>
             <a:r>
-              <a:rPr lang="en-US" sz="1600" b="1" dirty="0">
+              <a:rPr lang="vi-VN" sz="1600" b="1" dirty="0">
                 <a:solidFill>
                   <a:srgbClr val="13261D"/>
                 </a:solidFill>
-                <a:latin typeface="Be Vietnam Pro" pitchFamily="34" charset="0"/>
-                <a:ea typeface="Be Vietnam Pro" pitchFamily="34" charset="-122"/>
-                <a:cs typeface="Be Vietnam Pro" pitchFamily="34" charset="-120"/>
+                <a:latin typeface="Arial" pitchFamily="34" charset="0"/>
+                <a:ea typeface="Arial" pitchFamily="34" charset="-122"/>
+                <a:cs typeface="Arial" pitchFamily="34" charset="-120"/>
               </a:rPr>
               <a:t>Cài như ứng dụng</a:t>
             </a:r>
-            <a:endParaRPr lang="en-US" sz="1600" dirty="0"/>
+            <a:endParaRPr lang="vi-VN" sz="1600" dirty="0"/>
           </a:p>
         </p:txBody>
       </p:sp>
@@ -5935,7 +5935,7 @@
         <p:spPr>
           <a:xfrm>
             <a:off x="3721100" y="3609280"/>
-            <a:ext cx="3943922" cy="520700"/>
+            <a:ext cx="3524250" cy="520700"/>
           </a:xfrm>
           <a:prstGeom prst="rect">
             <a:avLst/>
@@ -5956,17 +5956,17 @@
               <a:buNone/>
             </a:pPr>
             <a:r>
-              <a:rPr lang="en-US" sz="1300" dirty="0">
+              <a:rPr lang="vi-VN" sz="1300" dirty="0">
                 <a:solidFill>
                   <a:srgbClr val="4A5A50"/>
                 </a:solidFill>
-                <a:latin typeface="Be Vietnam Pro" pitchFamily="34" charset="0"/>
-                <a:ea typeface="Be Vietnam Pro" pitchFamily="34" charset="-122"/>
-                <a:cs typeface="Be Vietnam Pro" pitchFamily="34" charset="-120"/>
+                <a:latin typeface="Arial" pitchFamily="34" charset="0"/>
+                <a:ea typeface="Arial" pitchFamily="34" charset="-122"/>
+                <a:cs typeface="Arial" pitchFamily="34" charset="-120"/>
               </a:rPr>
               <a:t>Dùng trên điện thoại, nhận thông báo đẩy, song ngữ Việt và Anh.</a:t>
             </a:r>
-            <a:endParaRPr lang="en-US" sz="1300" dirty="0"/>
+            <a:endParaRPr lang="vi-VN" sz="1300" dirty="0"/>
           </a:p>
         </p:txBody>
       </p:sp>
@@ -6000,17 +6000,17 @@
               <a:buNone/>
             </a:pPr>
             <a:r>
-              <a:rPr lang="en-US" sz="1600" b="1" dirty="0">
+              <a:rPr lang="vi-VN" sz="1600" b="1" dirty="0">
                 <a:solidFill>
                   <a:srgbClr val="13261D"/>
                 </a:solidFill>
-                <a:latin typeface="Be Vietnam Pro" pitchFamily="34" charset="0"/>
-                <a:ea typeface="Be Vietnam Pro" pitchFamily="34" charset="-122"/>
-                <a:cs typeface="Be Vietnam Pro" pitchFamily="34" charset="-120"/>
+                <a:latin typeface="Arial" pitchFamily="34" charset="0"/>
+                <a:ea typeface="Arial" pitchFamily="34" charset="-122"/>
+                <a:cs typeface="Arial" pitchFamily="34" charset="-120"/>
               </a:rPr>
               <a:t>Phân quyền</a:t>
             </a:r>
-            <a:endParaRPr lang="en-US" sz="1600" dirty="0"/>
+            <a:endParaRPr lang="vi-VN" sz="1600" dirty="0"/>
           </a:p>
         </p:txBody>
       </p:sp>
@@ -6044,17 +6044,17 @@
               <a:buNone/>
             </a:pPr>
             <a:r>
-              <a:rPr lang="en-US" sz="1300" dirty="0">
+              <a:rPr lang="vi-VN" sz="1300" dirty="0">
                 <a:solidFill>
                   <a:srgbClr val="4A5A50"/>
                 </a:solidFill>
-                <a:latin typeface="Be Vietnam Pro" pitchFamily="34" charset="0"/>
-                <a:ea typeface="Be Vietnam Pro" pitchFamily="34" charset="-122"/>
-                <a:cs typeface="Be Vietnam Pro" pitchFamily="34" charset="-120"/>
+                <a:latin typeface="Arial" pitchFamily="34" charset="0"/>
+                <a:ea typeface="Arial" pitchFamily="34" charset="-122"/>
+                <a:cs typeface="Arial" pitchFamily="34" charset="-120"/>
               </a:rPr>
               <a:t>Quản trị, quản lý, người xem; chia sẻ từng camera hoặc theo tổ chức.</a:t>
             </a:r>
-            <a:endParaRPr lang="en-US" sz="1300" dirty="0"/>
+            <a:endParaRPr lang="vi-VN" sz="1300" dirty="0"/>
           </a:p>
         </p:txBody>
       </p:sp>
@@ -6066,7 +6066,95 @@
         </p:nvSpPr>
         <p:spPr>
           <a:xfrm>
-            <a:off x="3721100" y="4104580"/>
+            <a:off x="3721100" y="4254500"/>
+            <a:ext cx="3524250" cy="279400"/>
+          </a:xfrm>
+          <a:prstGeom prst="rect">
+            <a:avLst/>
+          </a:prstGeom>
+          <a:noFill/>
+          <a:ln/>
+        </p:spPr>
+        <p:txBody>
+          <a:bodyPr wrap="square" lIns="0" tIns="0" rIns="0" bIns="0" rtlCol="0" anchor="t">
+            <a:normAutofit/>
+          </a:bodyPr>
+          <a:lstStyle/>
+          <a:p>
+            <a:pPr algn="l" indent="0" marL="0">
+              <a:lnSpc>
+                <a:spcPts val="2000"/>
+              </a:lnSpc>
+              <a:buNone/>
+            </a:pPr>
+            <a:r>
+              <a:rPr lang="vi-VN" sz="1600" b="1" dirty="0">
+                <a:solidFill>
+                  <a:srgbClr val="13261D"/>
+                </a:solidFill>
+                <a:latin typeface="Arial" pitchFamily="34" charset="0"/>
+                <a:ea typeface="Arial" pitchFamily="34" charset="-122"/>
+                <a:cs typeface="Arial" pitchFamily="34" charset="-120"/>
+              </a:rPr>
+              <a:t>Kết nối hệ thống khác</a:t>
+            </a:r>
+            <a:endParaRPr lang="vi-VN" sz="1600" dirty="0"/>
+          </a:p>
+        </p:txBody>
+      </p:sp>
+      <p:sp>
+        <p:nvSpPr>
+          <p:cNvPr id="12" name="Text 9"/>
+          <p:cNvSpPr/>
+          <p:nvPr/>
+        </p:nvSpPr>
+        <p:spPr>
+          <a:xfrm>
+            <a:off x="3721100" y="4559300"/>
+            <a:ext cx="3524250" cy="520700"/>
+          </a:xfrm>
+          <a:prstGeom prst="rect">
+            <a:avLst/>
+          </a:prstGeom>
+          <a:noFill/>
+          <a:ln/>
+        </p:spPr>
+        <p:txBody>
+          <a:bodyPr wrap="square" lIns="0" tIns="0" rIns="0" bIns="0" rtlCol="0" anchor="t">
+            <a:normAutofit/>
+          </a:bodyPr>
+          <a:lstStyle/>
+          <a:p>
+            <a:pPr algn="l" indent="0" marL="0">
+              <a:lnSpc>
+                <a:spcPts val="1950"/>
+              </a:lnSpc>
+              <a:buNone/>
+            </a:pPr>
+            <a:r>
+              <a:rPr lang="vi-VN" sz="1300" dirty="0">
+                <a:solidFill>
+                  <a:srgbClr val="4A5A50"/>
+                </a:solidFill>
+                <a:latin typeface="Arial" pitchFamily="34" charset="0"/>
+                <a:ea typeface="Arial" pitchFamily="34" charset="-122"/>
+                <a:cs typeface="Arial" pitchFamily="34" charset="-120"/>
+              </a:rPr>
+              <a:t>API key và webhook để đưa số liệu sang phần mềm của bạn.</a:t>
+            </a:r>
+            <a:endParaRPr lang="vi-VN" sz="1300" dirty="0"/>
+          </a:p>
+        </p:txBody>
+      </p:sp>
+      <p:sp>
+        <p:nvSpPr>
+          <p:cNvPr id="13" name="Text 10"/>
+          <p:cNvSpPr/>
+          <p:nvPr/>
+        </p:nvSpPr>
+        <p:spPr>
+          <a:xfrm>
+            <a:off x="7550150" y="4254500"/>
             <a:ext cx="3943922" cy="279400"/>
           </a:xfrm>
           <a:prstGeom prst="rect">
@@ -6088,29 +6176,29 @@
               <a:buNone/>
             </a:pPr>
             <a:r>
-              <a:rPr lang="en-US" sz="1600" b="1" dirty="0">
+              <a:rPr lang="vi-VN" sz="1600" b="1" dirty="0">
                 <a:solidFill>
                   <a:srgbClr val="13261D"/>
                 </a:solidFill>
-                <a:latin typeface="Be Vietnam Pro" pitchFamily="34" charset="0"/>
-                <a:ea typeface="Be Vietnam Pro" pitchFamily="34" charset="-122"/>
-                <a:cs typeface="Be Vietnam Pro" pitchFamily="34" charset="-120"/>
-              </a:rPr>
-              <a:t>Kết nối hệ thống khác</a:t>
-            </a:r>
-            <a:endParaRPr lang="en-US" sz="1600" dirty="0"/>
-          </a:p>
-        </p:txBody>
-      </p:sp>
-      <p:sp>
-        <p:nvSpPr>
-          <p:cNvPr id="12" name="Text 9"/>
-          <p:cNvSpPr/>
-          <p:nvPr/>
-        </p:nvSpPr>
-        <p:spPr>
-          <a:xfrm>
-            <a:off x="3721100" y="4409380"/>
+                <a:latin typeface="Arial" pitchFamily="34" charset="0"/>
+                <a:ea typeface="Arial" pitchFamily="34" charset="-122"/>
+                <a:cs typeface="Arial" pitchFamily="34" charset="-120"/>
+              </a:rPr>
+              <a:t>Theo dõi vận hành</a:t>
+            </a:r>
+            <a:endParaRPr lang="vi-VN" sz="1600" dirty="0"/>
+          </a:p>
+        </p:txBody>
+      </p:sp>
+      <p:sp>
+        <p:nvSpPr>
+          <p:cNvPr id="14" name="Text 11"/>
+          <p:cNvSpPr/>
+          <p:nvPr/>
+        </p:nvSpPr>
+        <p:spPr>
+          <a:xfrm>
+            <a:off x="7550150" y="4559300"/>
             <a:ext cx="3943922" cy="520700"/>
           </a:xfrm>
           <a:prstGeom prst="rect">
@@ -6132,105 +6220,17 @@
               <a:buNone/>
             </a:pPr>
             <a:r>
-              <a:rPr lang="en-US" sz="1300" dirty="0">
+              <a:rPr lang="vi-VN" sz="1300" dirty="0">
                 <a:solidFill>
                   <a:srgbClr val="4A5A50"/>
                 </a:solidFill>
-                <a:latin typeface="Be Vietnam Pro" pitchFamily="34" charset="0"/>
-                <a:ea typeface="Be Vietnam Pro" pitchFamily="34" charset="-122"/>
-                <a:cs typeface="Be Vietnam Pro" pitchFamily="34" charset="-120"/>
-              </a:rPr>
-              <a:t>API key và webhook để đưa số liệu sang phần mềm của bạn.</a:t>
-            </a:r>
-            <a:endParaRPr lang="en-US" sz="1300" dirty="0"/>
-          </a:p>
-        </p:txBody>
-      </p:sp>
-      <p:sp>
-        <p:nvSpPr>
-          <p:cNvPr id="13" name="Text 10"/>
-          <p:cNvSpPr/>
-          <p:nvPr/>
-        </p:nvSpPr>
-        <p:spPr>
-          <a:xfrm>
-            <a:off x="7550150" y="4104580"/>
-            <a:ext cx="3943922" cy="279400"/>
-          </a:xfrm>
-          <a:prstGeom prst="rect">
-            <a:avLst/>
-          </a:prstGeom>
-          <a:noFill/>
-          <a:ln/>
-        </p:spPr>
-        <p:txBody>
-          <a:bodyPr wrap="square" lIns="0" tIns="0" rIns="0" bIns="0" rtlCol="0" anchor="t">
-            <a:normAutofit/>
-          </a:bodyPr>
-          <a:lstStyle/>
-          <a:p>
-            <a:pPr algn="l" indent="0" marL="0">
-              <a:lnSpc>
-                <a:spcPts val="2000"/>
-              </a:lnSpc>
-              <a:buNone/>
-            </a:pPr>
-            <a:r>
-              <a:rPr lang="en-US" sz="1600" b="1" dirty="0">
-                <a:solidFill>
-                  <a:srgbClr val="13261D"/>
-                </a:solidFill>
-                <a:latin typeface="Be Vietnam Pro" pitchFamily="34" charset="0"/>
-                <a:ea typeface="Be Vietnam Pro" pitchFamily="34" charset="-122"/>
-                <a:cs typeface="Be Vietnam Pro" pitchFamily="34" charset="-120"/>
-              </a:rPr>
-              <a:t>Theo dõi vận hành</a:t>
-            </a:r>
-            <a:endParaRPr lang="en-US" sz="1600" dirty="0"/>
-          </a:p>
-        </p:txBody>
-      </p:sp>
-      <p:sp>
-        <p:nvSpPr>
-          <p:cNvPr id="14" name="Text 11"/>
-          <p:cNvSpPr/>
-          <p:nvPr/>
-        </p:nvSpPr>
-        <p:spPr>
-          <a:xfrm>
-            <a:off x="7550150" y="4409380"/>
-            <a:ext cx="3943922" cy="520700"/>
-          </a:xfrm>
-          <a:prstGeom prst="rect">
-            <a:avLst/>
-          </a:prstGeom>
-          <a:noFill/>
-          <a:ln/>
-        </p:spPr>
-        <p:txBody>
-          <a:bodyPr wrap="square" lIns="0" tIns="0" rIns="0" bIns="0" rtlCol="0" anchor="t">
-            <a:normAutofit/>
-          </a:bodyPr>
-          <a:lstStyle/>
-          <a:p>
-            <a:pPr algn="l" indent="0" marL="0">
-              <a:lnSpc>
-                <a:spcPts val="1950"/>
-              </a:lnSpc>
-              <a:buNone/>
-            </a:pPr>
-            <a:r>
-              <a:rPr lang="en-US" sz="1300" dirty="0">
-                <a:solidFill>
-                  <a:srgbClr val="4A5A50"/>
-                </a:solidFill>
-                <a:latin typeface="Be Vietnam Pro" pitchFamily="34" charset="0"/>
-                <a:ea typeface="Be Vietnam Pro" pitchFamily="34" charset="-122"/>
-                <a:cs typeface="Be Vietnam Pro" pitchFamily="34" charset="-120"/>
+                <a:latin typeface="Arial" pitchFamily="34" charset="0"/>
+                <a:ea typeface="Arial" pitchFamily="34" charset="-122"/>
+                <a:cs typeface="Arial" pitchFamily="34" charset="-120"/>
               </a:rPr>
               <a:t>Nhật ký hoạt động và màn hình theo dõi luồng chụp ảnh.</a:t>
             </a:r>
-            <a:endParaRPr lang="en-US" sz="1300" dirty="0"/>
+            <a:endParaRPr lang="vi-VN" sz="1300" dirty="0"/>
           </a:p>
         </p:txBody>
       </p:sp>
@@ -6264,17 +6264,17 @@
               <a:buNone/>
             </a:pPr>
             <a:r>
-              <a:rPr lang="en-US" sz="1200" dirty="0">
+              <a:rPr lang="vi-VN" sz="1200" dirty="0">
                 <a:solidFill>
                   <a:srgbClr val="6B7B70"/>
                 </a:solidFill>
-                <a:latin typeface="Be Vietnam Pro" pitchFamily="34" charset="0"/>
-                <a:ea typeface="Be Vietnam Pro" pitchFamily="34" charset="-122"/>
-                <a:cs typeface="Be Vietnam Pro" pitchFamily="34" charset="-120"/>
+                <a:latin typeface="Arial" pitchFamily="34" charset="0"/>
+                <a:ea typeface="Arial" pitchFamily="34" charset="-122"/>
+                <a:cs typeface="Arial" pitchFamily="34" charset="-120"/>
               </a:rPr>
               <a:t>FlyBot · 15</a:t>
             </a:r>
-            <a:endParaRPr lang="en-US" sz="1200" dirty="0"/>
+            <a:endParaRPr lang="vi-VN" sz="1200" dirty="0"/>
           </a:p>
         </p:txBody>
       </p:sp>
@@ -6318,7 +6318,7 @@
         </p:nvSpPr>
         <p:spPr>
           <a:xfrm>
-            <a:off x="812800" y="812800"/>
+            <a:off x="812800" y="711200"/>
             <a:ext cx="10883392" cy="238720"/>
           </a:xfrm>
           <a:prstGeom prst="rect">
@@ -6340,17 +6340,17 @@
               <a:buNone/>
             </a:pPr>
             <a:r>
-              <a:rPr lang="en-US" sz="1200" b="1" spc="150" kern="0" dirty="0">
+              <a:rPr lang="vi-VN" sz="1200" b="1" spc="150" kern="0" dirty="0">
                 <a:solidFill>
                   <a:srgbClr val="F2C230"/>
                 </a:solidFill>
-                <a:latin typeface="Be Vietnam Pro" pitchFamily="34" charset="0"/>
-                <a:ea typeface="Be Vietnam Pro" pitchFamily="34" charset="-122"/>
-                <a:cs typeface="Be Vietnam Pro" pitchFamily="34" charset="-120"/>
+                <a:latin typeface="Arial" pitchFamily="34" charset="0"/>
+                <a:ea typeface="Arial" pitchFamily="34" charset="-122"/>
+                <a:cs typeface="Arial" pitchFamily="34" charset="-120"/>
               </a:rPr>
               <a:t>BẮT ĐẦU</a:t>
             </a:r>
-            <a:endParaRPr lang="en-US" sz="1200" dirty="0"/>
+            <a:endParaRPr lang="vi-VN" sz="1200" dirty="0"/>
           </a:p>
         </p:txBody>
       </p:sp>
@@ -6364,7 +6364,7 @@
         </p:nvSpPr>
         <p:spPr>
           <a:xfrm>
-            <a:off x="812800" y="1127720"/>
+            <a:off x="812800" y="1026120"/>
             <a:ext cx="10883392" cy="537369"/>
           </a:xfrm>
           <a:prstGeom prst="rect">
@@ -6386,17 +6386,17 @@
               <a:buNone/>
             </a:pPr>
             <a:r>
-              <a:rPr lang="en-US" sz="3600" b="1" i="0" dirty="0">
+              <a:rPr lang="vi-VN" sz="3600" b="1" i="0" dirty="0">
                 <a:solidFill>
                   <a:srgbClr val="F5F7F1"/>
                 </a:solidFill>
-                <a:latin typeface="Be Vietnam Pro" pitchFamily="34" charset="0"/>
-                <a:ea typeface="Be Vietnam Pro" pitchFamily="34" charset="-122"/>
-                <a:cs typeface="Be Vietnam Pro" pitchFamily="34" charset="-120"/>
+                <a:latin typeface="Arial" pitchFamily="34" charset="0"/>
+                <a:ea typeface="Arial" pitchFamily="34" charset="-122"/>
+                <a:cs typeface="Arial" pitchFamily="34" charset="-120"/>
               </a:rPr>
               <a:t>Ba bước để bẫy đầu tiên tự báo số</a:t>
             </a:r>
-            <a:endParaRPr lang="en-US" sz="3600" dirty="0"/>
+            <a:endParaRPr lang="vi-VN" sz="3600" dirty="0"/>
           </a:p>
         </p:txBody>
       </p:sp>
@@ -6408,7 +6408,7 @@
         </p:nvSpPr>
         <p:spPr>
           <a:xfrm>
-            <a:off x="812800" y="2058789"/>
+            <a:off x="812800" y="1906389"/>
             <a:ext cx="3386634" cy="0"/>
           </a:xfrm>
           <a:prstGeom prst="line">
@@ -6431,7 +6431,7 @@
         </p:nvSpPr>
         <p:spPr>
           <a:xfrm>
-            <a:off x="812800" y="2274689"/>
+            <a:off x="812800" y="2122289"/>
             <a:ext cx="3488233" cy="416520"/>
           </a:xfrm>
           <a:prstGeom prst="rect">
@@ -6453,17 +6453,17 @@
               <a:buNone/>
             </a:pPr>
             <a:r>
-              <a:rPr lang="en-US" sz="2200" b="1" dirty="0">
+              <a:rPr lang="vi-VN" sz="2200" b="1" dirty="0">
                 <a:solidFill>
                   <a:srgbClr val="F2C230"/>
                 </a:solidFill>
-                <a:latin typeface="Be Vietnam Pro" pitchFamily="34" charset="0"/>
-                <a:ea typeface="Be Vietnam Pro" pitchFamily="34" charset="-122"/>
-                <a:cs typeface="Be Vietnam Pro" pitchFamily="34" charset="-120"/>
+                <a:latin typeface="Arial" pitchFamily="34" charset="0"/>
+                <a:ea typeface="Arial" pitchFamily="34" charset="-122"/>
+                <a:cs typeface="Arial" pitchFamily="34" charset="-120"/>
               </a:rPr>
               <a:t>01</a:t>
             </a:r>
-            <a:endParaRPr lang="en-US" sz="2200" dirty="0"/>
+            <a:endParaRPr lang="vi-VN" sz="2200" dirty="0"/>
           </a:p>
         </p:txBody>
       </p:sp>
@@ -6475,7 +6475,7 @@
         </p:nvSpPr>
         <p:spPr>
           <a:xfrm>
-            <a:off x="812800" y="2792809"/>
+            <a:off x="812800" y="2640409"/>
             <a:ext cx="3488233" cy="311150"/>
           </a:xfrm>
           <a:prstGeom prst="rect">
@@ -6497,17 +6497,17 @@
               <a:buNone/>
             </a:pPr>
             <a:r>
-              <a:rPr lang="en-US" sz="1800" b="1" dirty="0">
+              <a:rPr lang="vi-VN" sz="1800" b="1" dirty="0">
                 <a:solidFill>
                   <a:srgbClr val="F5F7F1"/>
                 </a:solidFill>
-                <a:latin typeface="Be Vietnam Pro" pitchFamily="34" charset="0"/>
-                <a:ea typeface="Be Vietnam Pro" pitchFamily="34" charset="-122"/>
-                <a:cs typeface="Be Vietnam Pro" pitchFamily="34" charset="-120"/>
+                <a:latin typeface="Arial" pitchFamily="34" charset="0"/>
+                <a:ea typeface="Arial" pitchFamily="34" charset="-122"/>
+                <a:cs typeface="Arial" pitchFamily="34" charset="-120"/>
               </a:rPr>
               <a:t>Lắp camera trước tấm bẫy</a:t>
             </a:r>
-            <a:endParaRPr lang="en-US" sz="1800" dirty="0"/>
+            <a:endParaRPr lang="vi-VN" sz="1800" dirty="0"/>
           </a:p>
         </p:txBody>
       </p:sp>
@@ -6519,7 +6519,7 @@
         </p:nvSpPr>
         <p:spPr>
           <a:xfrm>
-            <a:off x="812800" y="3205559"/>
+            <a:off x="812800" y="3053159"/>
             <a:ext cx="3488233" cy="520700"/>
           </a:xfrm>
           <a:prstGeom prst="rect">
@@ -6541,17 +6541,17 @@
               <a:buNone/>
             </a:pPr>
             <a:r>
-              <a:rPr lang="en-US" sz="1300" dirty="0">
+              <a:rPr lang="vi-VN" sz="1300" dirty="0">
                 <a:solidFill>
                   <a:srgbClr val="BFD3C6"/>
                 </a:solidFill>
-                <a:latin typeface="Be Vietnam Pro" pitchFamily="34" charset="0"/>
-                <a:ea typeface="Be Vietnam Pro" pitchFamily="34" charset="-122"/>
-                <a:cs typeface="Be Vietnam Pro" pitchFamily="34" charset="-120"/>
+                <a:latin typeface="Arial" pitchFamily="34" charset="0"/>
+                <a:ea typeface="Arial" pitchFamily="34" charset="-122"/>
+                <a:cs typeface="Arial" pitchFamily="34" charset="-120"/>
               </a:rPr>
               <a:t>Camera EZVIZ hướng vào tấm bẫy dính hoặc bẫy dẫn dụ.</a:t>
             </a:r>
-            <a:endParaRPr lang="en-US" sz="1300" dirty="0"/>
+            <a:endParaRPr lang="vi-VN" sz="1300" dirty="0"/>
           </a:p>
         </p:txBody>
       </p:sp>
@@ -6563,7 +6563,7 @@
         </p:nvSpPr>
         <p:spPr>
           <a:xfrm>
-            <a:off x="4402634" y="2058789"/>
+            <a:off x="4402634" y="1906389"/>
             <a:ext cx="3386733" cy="0"/>
           </a:xfrm>
           <a:prstGeom prst="line">
@@ -6586,7 +6586,7 @@
         </p:nvSpPr>
         <p:spPr>
           <a:xfrm>
-            <a:off x="4402634" y="2274689"/>
+            <a:off x="4402634" y="2122289"/>
             <a:ext cx="3488335" cy="416520"/>
           </a:xfrm>
           <a:prstGeom prst="rect">
@@ -6608,17 +6608,17 @@
               <a:buNone/>
             </a:pPr>
             <a:r>
-              <a:rPr lang="en-US" sz="2200" b="1" dirty="0">
+              <a:rPr lang="vi-VN" sz="2200" b="1" dirty="0">
                 <a:solidFill>
                   <a:srgbClr val="F2C230"/>
                 </a:solidFill>
-                <a:latin typeface="Be Vietnam Pro" pitchFamily="34" charset="0"/>
-                <a:ea typeface="Be Vietnam Pro" pitchFamily="34" charset="-122"/>
-                <a:cs typeface="Be Vietnam Pro" pitchFamily="34" charset="-120"/>
+                <a:latin typeface="Arial" pitchFamily="34" charset="0"/>
+                <a:ea typeface="Arial" pitchFamily="34" charset="-122"/>
+                <a:cs typeface="Arial" pitchFamily="34" charset="-120"/>
               </a:rPr>
               <a:t>02</a:t>
             </a:r>
-            <a:endParaRPr lang="en-US" sz="2200" dirty="0"/>
+            <a:endParaRPr lang="vi-VN" sz="2200" dirty="0"/>
           </a:p>
         </p:txBody>
       </p:sp>
@@ -6630,7 +6630,7 @@
         </p:nvSpPr>
         <p:spPr>
           <a:xfrm>
-            <a:off x="4402634" y="2792809"/>
+            <a:off x="4402634" y="2640409"/>
             <a:ext cx="3488335" cy="311150"/>
           </a:xfrm>
           <a:prstGeom prst="rect">
@@ -6652,17 +6652,17 @@
               <a:buNone/>
             </a:pPr>
             <a:r>
-              <a:rPr lang="en-US" sz="1800" b="1" dirty="0">
+              <a:rPr lang="vi-VN" sz="1800" b="1" dirty="0">
                 <a:solidFill>
                   <a:srgbClr val="F5F7F1"/>
                 </a:solidFill>
-                <a:latin typeface="Be Vietnam Pro" pitchFamily="34" charset="0"/>
-                <a:ea typeface="Be Vietnam Pro" pitchFamily="34" charset="-122"/>
-                <a:cs typeface="Be Vietnam Pro" pitchFamily="34" charset="-120"/>
+                <a:latin typeface="Arial" pitchFamily="34" charset="0"/>
+                <a:ea typeface="Arial" pitchFamily="34" charset="-122"/>
+                <a:cs typeface="Arial" pitchFamily="34" charset="-120"/>
               </a:rPr>
               <a:t>Thêm camera vào FlyBot</a:t>
             </a:r>
-            <a:endParaRPr lang="en-US" sz="1800" dirty="0"/>
+            <a:endParaRPr lang="vi-VN" sz="1800" dirty="0"/>
           </a:p>
         </p:txBody>
       </p:sp>
@@ -6674,7 +6674,7 @@
         </p:nvSpPr>
         <p:spPr>
           <a:xfrm>
-            <a:off x="4402634" y="3205559"/>
+            <a:off x="4402634" y="3053159"/>
             <a:ext cx="3488335" cy="520700"/>
           </a:xfrm>
           <a:prstGeom prst="rect">
@@ -6696,17 +6696,17 @@
               <a:buNone/>
             </a:pPr>
             <a:r>
-              <a:rPr lang="en-US" sz="1300" dirty="0">
+              <a:rPr lang="vi-VN" sz="1300" dirty="0">
                 <a:solidFill>
                   <a:srgbClr val="BFD3C6"/>
                 </a:solidFill>
-                <a:latin typeface="Be Vietnam Pro" pitchFamily="34" charset="0"/>
-                <a:ea typeface="Be Vietnam Pro" pitchFamily="34" charset="-122"/>
-                <a:cs typeface="Be Vietnam Pro" pitchFamily="34" charset="-120"/>
-              </a:rPr>
-              <a:t>Nhập số serial và mã xác minh, chọn loại bẫy và lịch chụp.</a:t>
-            </a:r>
-            <a:endParaRPr lang="en-US" sz="1300" dirty="0"/>
+                <a:latin typeface="Arial" pitchFamily="34" charset="0"/>
+                <a:ea typeface="Arial" pitchFamily="34" charset="-122"/>
+                <a:cs typeface="Arial" pitchFamily="34" charset="-120"/>
+              </a:rPr>
+              <a:t>Nhập số serial và mã xác thực, chọn loại bẫy và lịch chụp.</a:t>
+            </a:r>
+            <a:endParaRPr lang="vi-VN" sz="1300" dirty="0"/>
           </a:p>
         </p:txBody>
       </p:sp>
@@ -6718,7 +6718,7 @@
         </p:nvSpPr>
         <p:spPr>
           <a:xfrm>
-            <a:off x="7992566" y="2058789"/>
+            <a:off x="7992566" y="1906389"/>
             <a:ext cx="3386634" cy="0"/>
           </a:xfrm>
           <a:prstGeom prst="line">
@@ -6741,7 +6741,7 @@
         </p:nvSpPr>
         <p:spPr>
           <a:xfrm>
-            <a:off x="7992566" y="2274689"/>
+            <a:off x="7992566" y="2122289"/>
             <a:ext cx="3488233" cy="416520"/>
           </a:xfrm>
           <a:prstGeom prst="rect">
@@ -6763,17 +6763,17 @@
               <a:buNone/>
             </a:pPr>
             <a:r>
-              <a:rPr lang="en-US" sz="2200" b="1" dirty="0">
+              <a:rPr lang="vi-VN" sz="2200" b="1" dirty="0">
                 <a:solidFill>
                   <a:srgbClr val="F2C230"/>
                 </a:solidFill>
-                <a:latin typeface="Be Vietnam Pro" pitchFamily="34" charset="0"/>
-                <a:ea typeface="Be Vietnam Pro" pitchFamily="34" charset="-122"/>
-                <a:cs typeface="Be Vietnam Pro" pitchFamily="34" charset="-120"/>
+                <a:latin typeface="Arial" pitchFamily="34" charset="0"/>
+                <a:ea typeface="Arial" pitchFamily="34" charset="-122"/>
+                <a:cs typeface="Arial" pitchFamily="34" charset="-120"/>
               </a:rPr>
               <a:t>03</a:t>
             </a:r>
-            <a:endParaRPr lang="en-US" sz="2200" dirty="0"/>
+            <a:endParaRPr lang="vi-VN" sz="2200" dirty="0"/>
           </a:p>
         </p:txBody>
       </p:sp>
@@ -6785,7 +6785,7 @@
         </p:nvSpPr>
         <p:spPr>
           <a:xfrm>
-            <a:off x="7992566" y="2792809"/>
+            <a:off x="7992566" y="2640409"/>
             <a:ext cx="3488233" cy="311150"/>
           </a:xfrm>
           <a:prstGeom prst="rect">
@@ -6807,17 +6807,17 @@
               <a:buNone/>
             </a:pPr>
             <a:r>
-              <a:rPr lang="en-US" sz="1800" b="1" dirty="0">
+              <a:rPr lang="vi-VN" sz="1800" b="1" dirty="0">
                 <a:solidFill>
                   <a:srgbClr val="F5F7F1"/>
                 </a:solidFill>
-                <a:latin typeface="Be Vietnam Pro" pitchFamily="34" charset="0"/>
-                <a:ea typeface="Be Vietnam Pro" pitchFamily="34" charset="-122"/>
-                <a:cs typeface="Be Vietnam Pro" pitchFamily="34" charset="-120"/>
+                <a:latin typeface="Arial" pitchFamily="34" charset="0"/>
+                <a:ea typeface="Arial" pitchFamily="34" charset="-122"/>
+                <a:cs typeface="Arial" pitchFamily="34" charset="-120"/>
               </a:rPr>
               <a:t>Đặt ngưỡng và kênh nhận</a:t>
             </a:r>
-            <a:endParaRPr lang="en-US" sz="1800" dirty="0"/>
+            <a:endParaRPr lang="vi-VN" sz="1800" dirty="0"/>
           </a:p>
         </p:txBody>
       </p:sp>
@@ -6829,7 +6829,7 @@
         </p:nvSpPr>
         <p:spPr>
           <a:xfrm>
-            <a:off x="7992566" y="3205559"/>
+            <a:off x="7992566" y="3053159"/>
             <a:ext cx="3488233" cy="520700"/>
           </a:xfrm>
           <a:prstGeom prst="rect">
@@ -6851,30 +6851,99 @@
               <a:buNone/>
             </a:pPr>
             <a:r>
-              <a:rPr lang="en-US" sz="1300" dirty="0">
+              <a:rPr lang="vi-VN" sz="1300" dirty="0">
                 <a:solidFill>
                   <a:srgbClr val="BFD3C6"/>
                 </a:solidFill>
-                <a:latin typeface="Be Vietnam Pro" pitchFamily="34" charset="0"/>
-                <a:ea typeface="Be Vietnam Pro" pitchFamily="34" charset="-122"/>
-                <a:cs typeface="Be Vietnam Pro" pitchFamily="34" charset="-120"/>
+                <a:latin typeface="Arial" pitchFamily="34" charset="0"/>
+                <a:ea typeface="Arial" pitchFamily="34" charset="-122"/>
+                <a:cs typeface="Arial" pitchFamily="34" charset="-120"/>
               </a:rPr>
               <a:t>Ngưỡng cho từng bẫy; nhận cảnh báo qua điện thoại, email, Telegram.</a:t>
             </a:r>
-            <a:endParaRPr lang="en-US" sz="1300" dirty="0"/>
-          </a:p>
-        </p:txBody>
-      </p:sp>
-      <p:sp>
-        <p:nvSpPr>
-          <p:cNvPr id="16" name="Text 14"/>
-          <p:cNvSpPr/>
-          <p:nvPr/>
-        </p:nvSpPr>
-        <p:spPr>
-          <a:xfrm>
-            <a:off x="812800" y="6238280"/>
-            <a:ext cx="10883392" cy="238720"/>
+            <a:endParaRPr lang="vi-VN" sz="1300" dirty="0"/>
+          </a:p>
+        </p:txBody>
+      </p:sp>
+      <p:pic>
+        <p:nvPicPr>
+          <p:cNvPr id="16" name="Image 0" descr="Mã QR mở ezviz.agrhub.com">    </p:cNvPr>
+          <p:cNvPicPr>
+            <a:picLocks noChangeAspect="1"/>
+          </p:cNvPicPr>
+          <p:nvPr/>
+        </p:nvPicPr>
+        <p:blipFill>
+          <a:blip r:embed="rId1"/>
+          <a:srcRect l="0" r="0" t="0" b="0"/>
+          <a:stretch/>
+        </p:blipFill>
+        <p:spPr>
+          <a:xfrm>
+            <a:off x="812800" y="3904059"/>
+            <a:ext cx="1143000" cy="1143000"/>
+          </a:xfrm>
+          <a:prstGeom prst="roundRect">
+            <a:avLst>
+              <a:gd name="adj" fmla="val 6667"/>
+            </a:avLst>
+          </a:prstGeom>
+        </p:spPr>
+      </p:pic>
+      <p:sp>
+        <p:nvSpPr>
+          <p:cNvPr id="17" name="Text 14"/>
+          <p:cNvSpPr/>
+          <p:nvPr/>
+        </p:nvSpPr>
+        <p:spPr>
+          <a:xfrm>
+            <a:off x="2108200" y="4210149"/>
+            <a:ext cx="1372295" cy="292100"/>
+          </a:xfrm>
+          <a:prstGeom prst="rect">
+            <a:avLst/>
+          </a:prstGeom>
+          <a:noFill/>
+          <a:ln/>
+        </p:spPr>
+        <p:txBody>
+          <a:bodyPr wrap="square" lIns="0" tIns="0" rIns="0" bIns="0" rtlCol="0" anchor="t">
+            <a:normAutofit/>
+          </a:bodyPr>
+          <a:lstStyle/>
+          <a:p>
+            <a:pPr algn="l" indent="0" marL="0">
+              <a:lnSpc>
+                <a:spcPts val="2100"/>
+              </a:lnSpc>
+              <a:buNone/>
+            </a:pPr>
+            <a:r>
+              <a:rPr lang="vi-VN" sz="1500" b="1" dirty="0">
+                <a:solidFill>
+                  <a:srgbClr val="F5F7F1"/>
+                </a:solidFill>
+                <a:latin typeface="Arial" pitchFamily="34" charset="0"/>
+                <a:ea typeface="Arial" pitchFamily="34" charset="-122"/>
+                <a:cs typeface="Arial" pitchFamily="34" charset="-120"/>
+              </a:rPr>
+              <a:t>Mở ứng dụng</a:t>
+            </a:r>
+            <a:endParaRPr lang="vi-VN" sz="1500" dirty="0"/>
+          </a:p>
+        </p:txBody>
+      </p:sp>
+      <p:sp>
+        <p:nvSpPr>
+          <p:cNvPr id="18" name="Text 15"/>
+          <p:cNvSpPr/>
+          <p:nvPr/>
+        </p:nvSpPr>
+        <p:spPr>
+          <a:xfrm>
+            <a:off x="2108200" y="4527649"/>
+            <a:ext cx="1585793" cy="238720"/>
           </a:xfrm>
           <a:prstGeom prst="rect">
             <a:avLst/>
@@ -6895,75 +6964,13 @@
               <a:buNone/>
             </a:pPr>
             <a:r>
-              <a:rPr lang="en-US" sz="1200" dirty="0">
-                <a:solidFill>
-                  <a:srgbClr val="8FA898"/>
-                </a:solidFill>
-                <a:latin typeface="Be Vietnam Pro" pitchFamily="34" charset="0"/>
-                <a:ea typeface="Be Vietnam Pro" pitchFamily="34" charset="-122"/>
-                <a:cs typeface="Be Vietnam Pro" pitchFamily="34" charset="-120"/>
-              </a:rPr>
-              <a:t>Liên hệ: </a:t>
-            </a:r>
-            <a:r>
-              <a:rPr lang="en-US" sz="1200" dirty="0">
-                <a:solidFill>
-                  <a:srgbClr val="8FA898"/>
-                </a:solidFill>
-                <a:latin typeface="Be Vietnam Pro" pitchFamily="34" charset="0"/>
-                <a:ea typeface="Be Vietnam Pro" pitchFamily="34" charset="-122"/>
-                <a:cs typeface="Be Vietnam Pro" pitchFamily="34" charset="-120"/>
-              </a:rPr>
-              <a:t>contact@agrhub.com</a:t>
-            </a:r>
-            <a:r>
-              <a:rPr lang="en-US" sz="1200" dirty="0">
-                <a:solidFill>
-                  <a:srgbClr val="8FA898"/>
-                </a:solidFill>
-                <a:latin typeface="Be Vietnam Pro" pitchFamily="34" charset="0"/>
-                <a:ea typeface="Be Vietnam Pro" pitchFamily="34" charset="-122"/>
-                <a:cs typeface="Be Vietnam Pro" pitchFamily="34" charset="-120"/>
-              </a:rPr>
-              <a:t> · </a:t>
-            </a:r>
-            <a:r>
-              <a:rPr lang="en-US" sz="1200" u="sng" dirty="0">
-                <a:solidFill>
-                  <a:srgbClr val="8FA898"/>
-                </a:solidFill>
-                <a:latin typeface="Be Vietnam Pro" pitchFamily="34" charset="0"/>
-                <a:ea typeface="Be Vietnam Pro" pitchFamily="34" charset="-122"/>
-                <a:cs typeface="Be Vietnam Pro" pitchFamily="34" charset="-120"/>
-                <a:hlinkClick r:id="rId1" invalidUrl="" action="" tgtFrame="" tooltip="" history="1" highlightClick="0" endSnd="0">
-                  <a:extLst>
-                    <a:ext uri="{A12FA001-AC4F-418D-AE19-62706E023703}">
-                      <ahyp:hlinkClr xmlns:ahyp="http://schemas.microsoft.com/office/drawing/2018/hyperlinkcolor" val="tx"/>
-                    </a:ext>
-                  </a:extLst>
-                </a:hlinkClick>
-              </a:rPr>
-              <a:t>ezviz.agrhub.com</a:t>
-            </a:r>
-            <a:r>
-              <a:rPr lang="en-US" sz="1200" dirty="0">
-                <a:solidFill>
-                  <a:srgbClr val="8FA898"/>
-                </a:solidFill>
-                <a:latin typeface="Be Vietnam Pro" pitchFamily="34" charset="0"/>
-                <a:ea typeface="Be Vietnam Pro" pitchFamily="34" charset="-122"/>
-                <a:cs typeface="Be Vietnam Pro" pitchFamily="34" charset="-120"/>
-              </a:rPr>
-              <a:t> · </a:t>
-            </a:r>
-            <a:r>
-              <a:rPr lang="en-US" sz="1200" u="sng" dirty="0">
-                <a:solidFill>
-                  <a:srgbClr val="8FA898"/>
-                </a:solidFill>
-                <a:latin typeface="Be Vietnam Pro" pitchFamily="34" charset="0"/>
-                <a:ea typeface="Be Vietnam Pro" pitchFamily="34" charset="-122"/>
-                <a:cs typeface="Be Vietnam Pro" pitchFamily="34" charset="-120"/>
+              <a:rPr lang="vi-VN" sz="1200" u="sng" dirty="0">
+                <a:solidFill>
+                  <a:srgbClr val="BFD3C6"/>
+                </a:solidFill>
+                <a:latin typeface="Arial" pitchFamily="34" charset="0"/>
+                <a:ea typeface="Arial" pitchFamily="34" charset="-122"/>
+                <a:cs typeface="Arial" pitchFamily="34" charset="-120"/>
                 <a:hlinkClick r:id="rId2" invalidUrl="" action="" tgtFrame="" tooltip="" history="1" highlightClick="0" endSnd="0">
                   <a:extLst>
                     <a:ext uri="{A12FA001-AC4F-418D-AE19-62706E023703}">
@@ -6972,28 +6979,119 @@
                   </a:extLst>
                 </a:hlinkClick>
               </a:rPr>
-              <a:t>Hướng dẫn</a:t>
-            </a:r>
-            <a:r>
-              <a:rPr lang="en-US" sz="1200" dirty="0">
-                <a:solidFill>
-                  <a:srgbClr val="8FA898"/>
-                </a:solidFill>
-                <a:latin typeface="Be Vietnam Pro" pitchFamily="34" charset="0"/>
-                <a:ea typeface="Be Vietnam Pro" pitchFamily="34" charset="-122"/>
-                <a:cs typeface="Be Vietnam Pro" pitchFamily="34" charset="-120"/>
-              </a:rPr>
-              <a:t> · </a:t>
-            </a:r>
-            <a:r>
-              <a:rPr lang="en-US" sz="1200" u="sng" dirty="0">
-                <a:solidFill>
-                  <a:srgbClr val="8FA898"/>
-                </a:solidFill>
-                <a:latin typeface="Be Vietnam Pro" pitchFamily="34" charset="0"/>
-                <a:ea typeface="Be Vietnam Pro" pitchFamily="34" charset="-122"/>
-                <a:cs typeface="Be Vietnam Pro" pitchFamily="34" charset="-120"/>
-                <a:hlinkClick r:id="rId3" invalidUrl="" action="" tgtFrame="" tooltip="" history="1" highlightClick="0" endSnd="0">
+              <a:t>ezviz.agrhub.com</a:t>
+            </a:r>
+            <a:endParaRPr lang="vi-VN" sz="1200" dirty="0"/>
+          </a:p>
+        </p:txBody>
+      </p:sp>
+      <p:pic>
+        <p:nvPicPr>
+          <p:cNvPr id="19" name="Image 1" descr="Mã QR mở video giới thiệu FlyBot">    </p:cNvPr>
+          <p:cNvPicPr>
+            <a:picLocks noChangeAspect="1"/>
+          </p:cNvPicPr>
+          <p:nvPr/>
+        </p:nvPicPr>
+        <p:blipFill>
+          <a:blip r:embed="rId3"/>
+          <a:srcRect l="0" r="0" t="0" b="0"/>
+          <a:stretch/>
+        </p:blipFill>
+        <p:spPr>
+          <a:xfrm>
+            <a:off x="3886895" y="3904059"/>
+            <a:ext cx="1143000" cy="1143000"/>
+          </a:xfrm>
+          <a:prstGeom prst="roundRect">
+            <a:avLst>
+              <a:gd name="adj" fmla="val 6667"/>
+            </a:avLst>
+          </a:prstGeom>
+        </p:spPr>
+      </p:pic>
+      <p:sp>
+        <p:nvSpPr>
+          <p:cNvPr id="20" name="Text 16"/>
+          <p:cNvSpPr/>
+          <p:nvPr/>
+        </p:nvSpPr>
+        <p:spPr>
+          <a:xfrm>
+            <a:off x="5182295" y="4210149"/>
+            <a:ext cx="2240837" cy="292100"/>
+          </a:xfrm>
+          <a:prstGeom prst="rect">
+            <a:avLst/>
+          </a:prstGeom>
+          <a:noFill/>
+          <a:ln/>
+        </p:spPr>
+        <p:txBody>
+          <a:bodyPr wrap="square" lIns="0" tIns="0" rIns="0" bIns="0" rtlCol="0" anchor="t">
+            <a:normAutofit/>
+          </a:bodyPr>
+          <a:lstStyle/>
+          <a:p>
+            <a:pPr algn="l" indent="0" marL="0">
+              <a:lnSpc>
+                <a:spcPts val="2100"/>
+              </a:lnSpc>
+              <a:buNone/>
+            </a:pPr>
+            <a:r>
+              <a:rPr lang="vi-VN" sz="1500" b="1" dirty="0">
+                <a:solidFill>
+                  <a:srgbClr val="F5F7F1"/>
+                </a:solidFill>
+                <a:latin typeface="Arial" pitchFamily="34" charset="0"/>
+                <a:ea typeface="Arial" pitchFamily="34" charset="-122"/>
+                <a:cs typeface="Arial" pitchFamily="34" charset="-120"/>
+              </a:rPr>
+              <a:t>Xem video 82 giây</a:t>
+            </a:r>
+            <a:endParaRPr lang="vi-VN" sz="1500" dirty="0"/>
+          </a:p>
+        </p:txBody>
+      </p:sp>
+      <p:sp>
+        <p:nvSpPr>
+          <p:cNvPr id="21" name="Text 17"/>
+          <p:cNvSpPr/>
+          <p:nvPr/>
+        </p:nvSpPr>
+        <p:spPr>
+          <a:xfrm>
+            <a:off x="5182295" y="4527649"/>
+            <a:ext cx="2610683" cy="238720"/>
+          </a:xfrm>
+          <a:prstGeom prst="rect">
+            <a:avLst/>
+          </a:prstGeom>
+          <a:noFill/>
+          <a:ln/>
+        </p:spPr>
+        <p:txBody>
+          <a:bodyPr wrap="square" lIns="0" tIns="0" rIns="0" bIns="0" rtlCol="0" anchor="t">
+            <a:normAutofit/>
+          </a:bodyPr>
+          <a:lstStyle/>
+          <a:p>
+            <a:pPr algn="l" indent="0" marL="0">
+              <a:lnSpc>
+                <a:spcPts val="1680"/>
+              </a:lnSpc>
+              <a:buNone/>
+            </a:pPr>
+            <a:r>
+              <a:rPr lang="vi-VN" sz="1200" u="sng" dirty="0">
+                <a:solidFill>
+                  <a:srgbClr val="BFD3C6"/>
+                </a:solidFill>
+                <a:latin typeface="Arial" pitchFamily="34" charset="0"/>
+                <a:ea typeface="Arial" pitchFamily="34" charset="-122"/>
+                <a:cs typeface="Arial" pitchFamily="34" charset="-120"/>
+                <a:hlinkClick r:id="rId4" invalidUrl="" action="" tgtFrame="" tooltip="" history="1" highlightClick="0" endSnd="0">
                   <a:extLst>
                     <a:ext uri="{A12FA001-AC4F-418D-AE19-62706E023703}">
                       <ahyp:hlinkClr xmlns:ahyp="http://schemas.microsoft.com/office/drawing/2018/hyperlinkcolor" val="tx"/>
@@ -7001,9 +7099,151 @@
                   </a:extLst>
                 </a:hlinkClick>
               </a:rPr>
+              <a:t>Quét bằng camera điện thoại</a:t>
+            </a:r>
+            <a:endParaRPr lang="vi-VN" sz="1200" dirty="0"/>
+          </a:p>
+        </p:txBody>
+      </p:sp>
+      <p:sp>
+        <p:nvSpPr>
+          <p:cNvPr id="22" name="Text 18"/>
+          <p:cNvSpPr/>
+          <p:nvPr/>
+        </p:nvSpPr>
+        <p:spPr>
+          <a:xfrm>
+            <a:off x="812800" y="6238280"/>
+            <a:ext cx="10883392" cy="238720"/>
+          </a:xfrm>
+          <a:prstGeom prst="rect">
+            <a:avLst/>
+          </a:prstGeom>
+          <a:noFill/>
+          <a:ln/>
+        </p:spPr>
+        <p:txBody>
+          <a:bodyPr wrap="square" lIns="0" tIns="0" rIns="0" bIns="0" rtlCol="0" anchor="t">
+            <a:normAutofit/>
+          </a:bodyPr>
+          <a:lstStyle/>
+          <a:p>
+            <a:pPr algn="l" indent="0" marL="0">
+              <a:lnSpc>
+                <a:spcPts val="1680"/>
+              </a:lnSpc>
+              <a:buNone/>
+            </a:pPr>
+            <a:r>
+              <a:rPr lang="vi-VN" sz="1200" dirty="0">
+                <a:solidFill>
+                  <a:srgbClr val="8FA898"/>
+                </a:solidFill>
+                <a:latin typeface="Arial" pitchFamily="34" charset="0"/>
+                <a:ea typeface="Arial" pitchFamily="34" charset="-122"/>
+                <a:cs typeface="Arial" pitchFamily="34" charset="-120"/>
+              </a:rPr>
+              <a:t>Liên hệ: </a:t>
+            </a:r>
+            <a:r>
+              <a:rPr lang="vi-VN" sz="1200" dirty="0">
+                <a:solidFill>
+                  <a:srgbClr val="8FA898"/>
+                </a:solidFill>
+                <a:latin typeface="Arial" pitchFamily="34" charset="0"/>
+                <a:ea typeface="Arial" pitchFamily="34" charset="-122"/>
+                <a:cs typeface="Arial" pitchFamily="34" charset="-120"/>
+              </a:rPr>
+              <a:t>contact@agrhub.com</a:t>
+            </a:r>
+            <a:r>
+              <a:rPr lang="vi-VN" sz="1200" dirty="0">
+                <a:solidFill>
+                  <a:srgbClr val="8FA898"/>
+                </a:solidFill>
+                <a:latin typeface="Arial" pitchFamily="34" charset="0"/>
+                <a:ea typeface="Arial" pitchFamily="34" charset="-122"/>
+                <a:cs typeface="Arial" pitchFamily="34" charset="-120"/>
+              </a:rPr>
+              <a:t> · </a:t>
+            </a:r>
+            <a:r>
+              <a:rPr lang="vi-VN" sz="1200" u="sng" dirty="0">
+                <a:solidFill>
+                  <a:srgbClr val="8FA898"/>
+                </a:solidFill>
+                <a:latin typeface="Arial" pitchFamily="34" charset="0"/>
+                <a:ea typeface="Arial" pitchFamily="34" charset="-122"/>
+                <a:cs typeface="Arial" pitchFamily="34" charset="-120"/>
+                <a:hlinkClick r:id="rId5" invalidUrl="" action="" tgtFrame="" tooltip="" history="1" highlightClick="0" endSnd="0">
+                  <a:extLst>
+                    <a:ext uri="{A12FA001-AC4F-418D-AE19-62706E023703}">
+                      <ahyp:hlinkClr xmlns:ahyp="http://schemas.microsoft.com/office/drawing/2018/hyperlinkcolor" val="tx"/>
+                    </a:ext>
+                  </a:extLst>
+                </a:hlinkClick>
+              </a:rPr>
+              <a:t>ezviz.agrhub.com</a:t>
+            </a:r>
+            <a:r>
+              <a:rPr lang="vi-VN" sz="1200" dirty="0">
+                <a:solidFill>
+                  <a:srgbClr val="8FA898"/>
+                </a:solidFill>
+                <a:latin typeface="Arial" pitchFamily="34" charset="0"/>
+                <a:ea typeface="Arial" pitchFamily="34" charset="-122"/>
+                <a:cs typeface="Arial" pitchFamily="34" charset="-120"/>
+              </a:rPr>
+              <a:t> · </a:t>
+            </a:r>
+            <a:r>
+              <a:rPr lang="vi-VN" sz="1200" u="sng" dirty="0">
+                <a:solidFill>
+                  <a:srgbClr val="8FA898"/>
+                </a:solidFill>
+                <a:latin typeface="Arial" pitchFamily="34" charset="0"/>
+                <a:ea typeface="Arial" pitchFamily="34" charset="-122"/>
+                <a:cs typeface="Arial" pitchFamily="34" charset="-120"/>
+                <a:hlinkClick r:id="rId6" invalidUrl="" action="" tgtFrame="" tooltip="" history="1" highlightClick="0" endSnd="0">
+                  <a:extLst>
+                    <a:ext uri="{A12FA001-AC4F-418D-AE19-62706E023703}">
+                      <ahyp:hlinkClr xmlns:ahyp="http://schemas.microsoft.com/office/drawing/2018/hyperlinkcolor" val="tx"/>
+                    </a:ext>
+                  </a:extLst>
+                </a:hlinkClick>
+              </a:rPr>
+              <a:t>Hướng dẫn</a:t>
+            </a:r>
+            <a:r>
+              <a:rPr lang="vi-VN" sz="1200" dirty="0">
+                <a:solidFill>
+                  <a:srgbClr val="8FA898"/>
+                </a:solidFill>
+                <a:latin typeface="Arial" pitchFamily="34" charset="0"/>
+                <a:ea typeface="Arial" pitchFamily="34" charset="-122"/>
+                <a:cs typeface="Arial" pitchFamily="34" charset="-120"/>
+              </a:rPr>
+              <a:t> · </a:t>
+            </a:r>
+            <a:r>
+              <a:rPr lang="vi-VN" sz="1200" u="sng" dirty="0">
+                <a:solidFill>
+                  <a:srgbClr val="8FA898"/>
+                </a:solidFill>
+                <a:latin typeface="Arial" pitchFamily="34" charset="0"/>
+                <a:ea typeface="Arial" pitchFamily="34" charset="-122"/>
+                <a:cs typeface="Arial" pitchFamily="34" charset="-120"/>
+                <a:hlinkClick r:id="rId7" invalidUrl="" action="" tgtFrame="" tooltip="" history="1" highlightClick="0" endSnd="0">
+                  <a:extLst>
+                    <a:ext uri="{A12FA001-AC4F-418D-AE19-62706E023703}">
+                      <ahyp:hlinkClr xmlns:ahyp="http://schemas.microsoft.com/office/drawing/2018/hyperlinkcolor" val="tx"/>
+                    </a:ext>
+                  </a:extLst>
+                </a:hlinkClick>
+              </a:rPr>
               <a:t>Video giới thiệu</a:t>
             </a:r>
-            <a:endParaRPr lang="en-US" sz="1200" dirty="0"/>
+            <a:endParaRPr lang="vi-VN" sz="1200" dirty="0"/>
           </a:p>
         </p:txBody>
       </p:sp>
@@ -7069,17 +7309,17 @@
               <a:buNone/>
             </a:pPr>
             <a:r>
-              <a:rPr lang="en-US" sz="1200" b="1" spc="150" kern="0" dirty="0">
+              <a:rPr lang="vi-VN" sz="1200" b="1" spc="150" kern="0" dirty="0">
                 <a:solidFill>
                   <a:srgbClr val="1D7A50"/>
                 </a:solidFill>
-                <a:latin typeface="Be Vietnam Pro" pitchFamily="34" charset="0"/>
-                <a:ea typeface="Be Vietnam Pro" pitchFamily="34" charset="-122"/>
-                <a:cs typeface="Be Vietnam Pro" pitchFamily="34" charset="-120"/>
+                <a:latin typeface="Arial" pitchFamily="34" charset="0"/>
+                <a:ea typeface="Arial" pitchFamily="34" charset="-122"/>
+                <a:cs typeface="Arial" pitchFamily="34" charset="-120"/>
               </a:rPr>
               <a:t>VẤN ĐỀ</a:t>
             </a:r>
-            <a:endParaRPr lang="en-US" sz="1200" dirty="0"/>
+            <a:endParaRPr lang="vi-VN" sz="1200" dirty="0"/>
           </a:p>
         </p:txBody>
       </p:sp>
@@ -7115,17 +7355,17 @@
               <a:buNone/>
             </a:pPr>
             <a:r>
-              <a:rPr lang="en-US" sz="3200" b="1" i="0" dirty="0">
+              <a:rPr lang="vi-VN" sz="3200" b="1" i="0" dirty="0">
                 <a:solidFill>
                   <a:srgbClr val="13261D"/>
                 </a:solidFill>
-                <a:latin typeface="Be Vietnam Pro" pitchFamily="34" charset="0"/>
-                <a:ea typeface="Be Vietnam Pro" pitchFamily="34" charset="-122"/>
-                <a:cs typeface="Be Vietnam Pro" pitchFamily="34" charset="-120"/>
+                <a:latin typeface="Arial" pitchFamily="34" charset="0"/>
+                <a:ea typeface="Arial" pitchFamily="34" charset="-122"/>
+                <a:cs typeface="Arial" pitchFamily="34" charset="-120"/>
               </a:rPr>
               <a:t>Kiểm bẫy thủ công tốn công và luôn đi sau dịch hại</a:t>
             </a:r>
-            <a:endParaRPr lang="en-US" sz="3200" dirty="0"/>
+            <a:endParaRPr lang="vi-VN" sz="3200" dirty="0"/>
           </a:p>
         </p:txBody>
       </p:sp>
@@ -7209,17 +7449,17 @@
               <a:buNone/>
             </a:pPr>
             <a:r>
-              <a:rPr lang="en-US" sz="2000" b="1" dirty="0">
+              <a:rPr lang="vi-VN" sz="2000" b="1" dirty="0">
                 <a:solidFill>
                   <a:srgbClr val="13261D"/>
                 </a:solidFill>
-                <a:latin typeface="Be Vietnam Pro" pitchFamily="34" charset="0"/>
-                <a:ea typeface="Be Vietnam Pro" pitchFamily="34" charset="-122"/>
-                <a:cs typeface="Be Vietnam Pro" pitchFamily="34" charset="-120"/>
+                <a:latin typeface="Arial" pitchFamily="34" charset="0"/>
+                <a:ea typeface="Arial" pitchFamily="34" charset="-122"/>
+                <a:cs typeface="Arial" pitchFamily="34" charset="-120"/>
               </a:rPr>
               <a:t>Đi từng bẫy, đếm bằng tay</a:t>
             </a:r>
-            <a:endParaRPr lang="en-US" sz="2000" dirty="0"/>
+            <a:endParaRPr lang="vi-VN" sz="2000" dirty="0"/>
           </a:p>
         </p:txBody>
       </p:sp>
@@ -7253,17 +7493,17 @@
               <a:buNone/>
             </a:pPr>
             <a:r>
-              <a:rPr lang="en-US" sz="1400" dirty="0">
+              <a:rPr lang="vi-VN" sz="1400" dirty="0">
                 <a:solidFill>
                   <a:srgbClr val="4A5A50"/>
                 </a:solidFill>
-                <a:latin typeface="Be Vietnam Pro" pitchFamily="34" charset="0"/>
-                <a:ea typeface="Be Vietnam Pro" pitchFamily="34" charset="-122"/>
-                <a:cs typeface="Be Vietnam Pro" pitchFamily="34" charset="-120"/>
+                <a:latin typeface="Arial" pitchFamily="34" charset="0"/>
+                <a:ea typeface="Arial" pitchFamily="34" charset="-122"/>
+                <a:cs typeface="Arial" pitchFamily="34" charset="-120"/>
               </a:rPr>
               <a:t>Mỗi lần kiểm tra mất nhiều giờ công, và số đếm phụ thuộc vào người đếm.</a:t>
             </a:r>
-            <a:endParaRPr lang="en-US" sz="1400" dirty="0"/>
+            <a:endParaRPr lang="vi-VN" sz="1400" dirty="0"/>
           </a:p>
         </p:txBody>
       </p:sp>
@@ -7347,17 +7587,17 @@
               <a:buNone/>
             </a:pPr>
             <a:r>
-              <a:rPr lang="en-US" sz="2000" b="1" dirty="0">
+              <a:rPr lang="vi-VN" sz="2000" b="1" dirty="0">
                 <a:solidFill>
                   <a:srgbClr val="13261D"/>
                 </a:solidFill>
-                <a:latin typeface="Be Vietnam Pro" pitchFamily="34" charset="0"/>
-                <a:ea typeface="Be Vietnam Pro" pitchFamily="34" charset="-122"/>
-                <a:cs typeface="Be Vietnam Pro" pitchFamily="34" charset="-120"/>
+                <a:latin typeface="Arial" pitchFamily="34" charset="0"/>
+                <a:ea typeface="Arial" pitchFamily="34" charset="-122"/>
+                <a:cs typeface="Arial" pitchFamily="34" charset="-120"/>
               </a:rPr>
               <a:t>Số liệu rời rạc</a:t>
             </a:r>
-            <a:endParaRPr lang="en-US" sz="2000" dirty="0"/>
+            <a:endParaRPr lang="vi-VN" sz="2000" dirty="0"/>
           </a:p>
         </p:txBody>
       </p:sp>
@@ -7391,17 +7631,17 @@
               <a:buNone/>
             </a:pPr>
             <a:r>
-              <a:rPr lang="en-US" sz="1400" dirty="0">
+              <a:rPr lang="vi-VN" sz="1400" dirty="0">
                 <a:solidFill>
                   <a:srgbClr val="4A5A50"/>
                 </a:solidFill>
-                <a:latin typeface="Be Vietnam Pro" pitchFamily="34" charset="0"/>
-                <a:ea typeface="Be Vietnam Pro" pitchFamily="34" charset="-122"/>
-                <a:cs typeface="Be Vietnam Pro" pitchFamily="34" charset="-120"/>
+                <a:latin typeface="Arial" pitchFamily="34" charset="0"/>
+                <a:ea typeface="Arial" pitchFamily="34" charset="-122"/>
+                <a:cs typeface="Arial" pitchFamily="34" charset="-120"/>
               </a:rPr>
               <a:t>Ghi chép trên giấy khó so sánh giữa các bẫy, các lô và các tuần.</a:t>
             </a:r>
-            <a:endParaRPr lang="en-US" sz="1400" dirty="0"/>
+            <a:endParaRPr lang="vi-VN" sz="1400" dirty="0"/>
           </a:p>
         </p:txBody>
       </p:sp>
@@ -7485,17 +7725,17 @@
               <a:buNone/>
             </a:pPr>
             <a:r>
-              <a:rPr lang="en-US" sz="2000" b="1" dirty="0">
+              <a:rPr lang="vi-VN" sz="2000" b="1" dirty="0">
                 <a:solidFill>
                   <a:srgbClr val="13261D"/>
                 </a:solidFill>
-                <a:latin typeface="Be Vietnam Pro" pitchFamily="34" charset="0"/>
-                <a:ea typeface="Be Vietnam Pro" pitchFamily="34" charset="-122"/>
-                <a:cs typeface="Be Vietnam Pro" pitchFamily="34" charset="-120"/>
+                <a:latin typeface="Arial" pitchFamily="34" charset="0"/>
+                <a:ea typeface="Arial" pitchFamily="34" charset="-122"/>
+                <a:cs typeface="Arial" pitchFamily="34" charset="-120"/>
               </a:rPr>
               <a:t>Phát hiện muộn</a:t>
             </a:r>
-            <a:endParaRPr lang="en-US" sz="2000" dirty="0"/>
+            <a:endParaRPr lang="vi-VN" sz="2000" dirty="0"/>
           </a:p>
         </p:txBody>
       </p:sp>
@@ -7529,17 +7769,17 @@
               <a:buNone/>
             </a:pPr>
             <a:r>
-              <a:rPr lang="en-US" sz="1400" dirty="0">
+              <a:rPr lang="vi-VN" sz="1400" dirty="0">
                 <a:solidFill>
                   <a:srgbClr val="4A5A50"/>
                 </a:solidFill>
-                <a:latin typeface="Be Vietnam Pro" pitchFamily="34" charset="0"/>
-                <a:ea typeface="Be Vietnam Pro" pitchFamily="34" charset="-122"/>
-                <a:cs typeface="Be Vietnam Pro" pitchFamily="34" charset="-120"/>
+                <a:latin typeface="Arial" pitchFamily="34" charset="0"/>
+                <a:ea typeface="Arial" pitchFamily="34" charset="-122"/>
+                <a:cs typeface="Arial" pitchFamily="34" charset="-120"/>
               </a:rPr>
               <a:t>Khi thấy mật độ tăng thì đợt bùng phát đã bắt đầu, xử lý tốn kém hơn.</a:t>
             </a:r>
-            <a:endParaRPr lang="en-US" sz="1400" dirty="0"/>
+            <a:endParaRPr lang="vi-VN" sz="1400" dirty="0"/>
           </a:p>
         </p:txBody>
       </p:sp>
@@ -7573,17 +7813,17 @@
               <a:buNone/>
             </a:pPr>
             <a:r>
-              <a:rPr lang="en-US" sz="1200" dirty="0">
+              <a:rPr lang="vi-VN" sz="1200" dirty="0">
                 <a:solidFill>
                   <a:srgbClr val="6B7B70"/>
                 </a:solidFill>
-                <a:latin typeface="Be Vietnam Pro" pitchFamily="34" charset="0"/>
-                <a:ea typeface="Be Vietnam Pro" pitchFamily="34" charset="-122"/>
-                <a:cs typeface="Be Vietnam Pro" pitchFamily="34" charset="-120"/>
+                <a:latin typeface="Arial" pitchFamily="34" charset="0"/>
+                <a:ea typeface="Arial" pitchFamily="34" charset="-122"/>
+                <a:cs typeface="Arial" pitchFamily="34" charset="-120"/>
               </a:rPr>
               <a:t>FlyBot · 2</a:t>
             </a:r>
-            <a:endParaRPr lang="en-US" sz="1200" dirty="0"/>
+            <a:endParaRPr lang="vi-VN" sz="1200" dirty="0"/>
           </a:p>
         </p:txBody>
       </p:sp>
@@ -7649,17 +7889,17 @@
               <a:buNone/>
             </a:pPr>
             <a:r>
-              <a:rPr lang="en-US" sz="1200" b="1" spc="150" kern="0" dirty="0">
+              <a:rPr lang="vi-VN" sz="1200" b="1" spc="150" kern="0" dirty="0">
                 <a:solidFill>
                   <a:srgbClr val="1D7A50"/>
                 </a:solidFill>
-                <a:latin typeface="Be Vietnam Pro" pitchFamily="34" charset="0"/>
-                <a:ea typeface="Be Vietnam Pro" pitchFamily="34" charset="-122"/>
-                <a:cs typeface="Be Vietnam Pro" pitchFamily="34" charset="-120"/>
+                <a:latin typeface="Arial" pitchFamily="34" charset="0"/>
+                <a:ea typeface="Arial" pitchFamily="34" charset="-122"/>
+                <a:cs typeface="Arial" pitchFamily="34" charset="-120"/>
               </a:rPr>
               <a:t>CÁCH HOẠT ĐỘNG</a:t>
             </a:r>
-            <a:endParaRPr lang="en-US" sz="1200" dirty="0"/>
+            <a:endParaRPr lang="vi-VN" sz="1200" dirty="0"/>
           </a:p>
         </p:txBody>
       </p:sp>
@@ -7695,17 +7935,17 @@
               <a:buNone/>
             </a:pPr>
             <a:r>
-              <a:rPr lang="en-US" sz="3200" b="1" i="0" dirty="0">
+              <a:rPr lang="vi-VN" sz="3200" b="1" i="0" dirty="0">
                 <a:solidFill>
                   <a:srgbClr val="13261D"/>
                 </a:solidFill>
-                <a:latin typeface="Be Vietnam Pro" pitchFamily="34" charset="0"/>
-                <a:ea typeface="Be Vietnam Pro" pitchFamily="34" charset="-122"/>
-                <a:cs typeface="Be Vietnam Pro" pitchFamily="34" charset="-120"/>
+                <a:latin typeface="Arial" pitchFamily="34" charset="0"/>
+                <a:ea typeface="Arial" pitchFamily="34" charset="-122"/>
+                <a:cs typeface="Arial" pitchFamily="34" charset="-120"/>
               </a:rPr>
               <a:t>Từ tấm bẫy đến quyết định, không cần đếm tay</a:t>
             </a:r>
-            <a:endParaRPr lang="en-US" sz="3200" dirty="0"/>
+            <a:endParaRPr lang="vi-VN" sz="3200" dirty="0"/>
           </a:p>
         </p:txBody>
       </p:sp>
@@ -7796,17 +8036,17 @@
               <a:buNone/>
             </a:pPr>
             <a:r>
-              <a:rPr lang="en-US" sz="1200" b="1" dirty="0">
+              <a:rPr lang="vi-VN" sz="1200" b="1" dirty="0">
                 <a:solidFill>
                   <a:srgbClr val="13261D"/>
                 </a:solidFill>
-                <a:latin typeface="Be Vietnam Pro" pitchFamily="34" charset="0"/>
-                <a:ea typeface="Be Vietnam Pro" pitchFamily="34" charset="-122"/>
-                <a:cs typeface="Be Vietnam Pro" pitchFamily="34" charset="-120"/>
+                <a:latin typeface="Arial" pitchFamily="34" charset="0"/>
+                <a:ea typeface="Arial" pitchFamily="34" charset="-122"/>
+                <a:cs typeface="Arial" pitchFamily="34" charset="-120"/>
               </a:rPr>
               <a:t>1</a:t>
             </a:r>
-            <a:endParaRPr lang="en-US" sz="1200" dirty="0"/>
+            <a:endParaRPr lang="vi-VN" sz="1200" dirty="0"/>
           </a:p>
         </p:txBody>
       </p:sp>
@@ -7840,17 +8080,17 @@
               <a:buNone/>
             </a:pPr>
             <a:r>
-              <a:rPr lang="en-US" sz="1800" b="1" dirty="0">
+              <a:rPr lang="vi-VN" sz="1800" b="1" dirty="0">
                 <a:solidFill>
                   <a:srgbClr val="13261D"/>
                 </a:solidFill>
-                <a:latin typeface="Be Vietnam Pro" pitchFamily="34" charset="0"/>
-                <a:ea typeface="Be Vietnam Pro" pitchFamily="34" charset="-122"/>
-                <a:cs typeface="Be Vietnam Pro" pitchFamily="34" charset="-120"/>
+                <a:latin typeface="Arial" pitchFamily="34" charset="0"/>
+                <a:ea typeface="Arial" pitchFamily="34" charset="-122"/>
+                <a:cs typeface="Arial" pitchFamily="34" charset="-120"/>
               </a:rPr>
               <a:t>Camera chụp tấm bẫy</a:t>
             </a:r>
-            <a:endParaRPr lang="en-US" sz="1800" dirty="0"/>
+            <a:endParaRPr lang="vi-VN" sz="1800" dirty="0"/>
           </a:p>
         </p:txBody>
       </p:sp>
@@ -7884,17 +8124,17 @@
               <a:buNone/>
             </a:pPr>
             <a:r>
-              <a:rPr lang="en-US" sz="1300" dirty="0">
+              <a:rPr lang="vi-VN" sz="1300" dirty="0">
                 <a:solidFill>
                   <a:srgbClr val="4A5A50"/>
                 </a:solidFill>
-                <a:latin typeface="Be Vietnam Pro" pitchFamily="34" charset="0"/>
-                <a:ea typeface="Be Vietnam Pro" pitchFamily="34" charset="-122"/>
-                <a:cs typeface="Be Vietnam Pro" pitchFamily="34" charset="-120"/>
+                <a:latin typeface="Arial" pitchFamily="34" charset="0"/>
+                <a:ea typeface="Arial" pitchFamily="34" charset="-122"/>
+                <a:cs typeface="Arial" pitchFamily="34" charset="-120"/>
               </a:rPr>
               <a:t>Camera EZVIZ chụp theo lịch riêng của từng bẫy, có thể chỉ chụp ban ngày.</a:t>
             </a:r>
-            <a:endParaRPr lang="en-US" sz="1300" dirty="0"/>
+            <a:endParaRPr lang="vi-VN" sz="1300" dirty="0"/>
           </a:p>
         </p:txBody>
       </p:sp>
@@ -8008,17 +8248,17 @@
               <a:buNone/>
             </a:pPr>
             <a:r>
-              <a:rPr lang="en-US" sz="1200" b="1" dirty="0">
+              <a:rPr lang="vi-VN" sz="1200" b="1" dirty="0">
                 <a:solidFill>
                   <a:srgbClr val="13261D"/>
                 </a:solidFill>
-                <a:latin typeface="Be Vietnam Pro" pitchFamily="34" charset="0"/>
-                <a:ea typeface="Be Vietnam Pro" pitchFamily="34" charset="-122"/>
-                <a:cs typeface="Be Vietnam Pro" pitchFamily="34" charset="-120"/>
+                <a:latin typeface="Arial" pitchFamily="34" charset="0"/>
+                <a:ea typeface="Arial" pitchFamily="34" charset="-122"/>
+                <a:cs typeface="Arial" pitchFamily="34" charset="-120"/>
               </a:rPr>
               <a:t>2</a:t>
             </a:r>
-            <a:endParaRPr lang="en-US" sz="1200" dirty="0"/>
+            <a:endParaRPr lang="vi-VN" sz="1200" dirty="0"/>
           </a:p>
         </p:txBody>
       </p:sp>
@@ -8052,17 +8292,17 @@
               <a:buNone/>
             </a:pPr>
             <a:r>
-              <a:rPr lang="en-US" sz="1800" b="1" dirty="0">
+              <a:rPr lang="vi-VN" sz="1800" b="1" dirty="0">
                 <a:solidFill>
                   <a:srgbClr val="13261D"/>
                 </a:solidFill>
-                <a:latin typeface="Be Vietnam Pro" pitchFamily="34" charset="0"/>
-                <a:ea typeface="Be Vietnam Pro" pitchFamily="34" charset="-122"/>
-                <a:cs typeface="Be Vietnam Pro" pitchFamily="34" charset="-120"/>
+                <a:latin typeface="Arial" pitchFamily="34" charset="0"/>
+                <a:ea typeface="Arial" pitchFamily="34" charset="-122"/>
+                <a:cs typeface="Arial" pitchFamily="34" charset="-120"/>
               </a:rPr>
               <a:t>AI nhận dạng và đếm</a:t>
             </a:r>
-            <a:endParaRPr lang="en-US" sz="1800" dirty="0"/>
+            <a:endParaRPr lang="vi-VN" sz="1800" dirty="0"/>
           </a:p>
         </p:txBody>
       </p:sp>
@@ -8096,17 +8336,17 @@
               <a:buNone/>
             </a:pPr>
             <a:r>
-              <a:rPr lang="en-US" sz="1300" dirty="0">
+              <a:rPr lang="vi-VN" sz="1300" dirty="0">
                 <a:solidFill>
                   <a:srgbClr val="4A5A50"/>
                 </a:solidFill>
-                <a:latin typeface="Be Vietnam Pro" pitchFamily="34" charset="0"/>
-                <a:ea typeface="Be Vietnam Pro" pitchFamily="34" charset="-122"/>
-                <a:cs typeface="Be Vietnam Pro" pitchFamily="34" charset="-120"/>
+                <a:latin typeface="Arial" pitchFamily="34" charset="0"/>
+                <a:ea typeface="Arial" pitchFamily="34" charset="-122"/>
+                <a:cs typeface="Arial" pitchFamily="34" charset="-120"/>
               </a:rPr>
               <a:t>Khoanh từng con trên ảnh, ghi tên loài và độ tin cậy.</a:t>
             </a:r>
-            <a:endParaRPr lang="en-US" sz="1300" dirty="0"/>
+            <a:endParaRPr lang="vi-VN" sz="1300" dirty="0"/>
           </a:p>
         </p:txBody>
       </p:sp>
@@ -8220,17 +8460,17 @@
               <a:buNone/>
             </a:pPr>
             <a:r>
-              <a:rPr lang="en-US" sz="1200" b="1" dirty="0">
+              <a:rPr lang="vi-VN" sz="1200" b="1" dirty="0">
                 <a:solidFill>
                   <a:srgbClr val="13261D"/>
                 </a:solidFill>
-                <a:latin typeface="Be Vietnam Pro" pitchFamily="34" charset="0"/>
-                <a:ea typeface="Be Vietnam Pro" pitchFamily="34" charset="-122"/>
-                <a:cs typeface="Be Vietnam Pro" pitchFamily="34" charset="-120"/>
+                <a:latin typeface="Arial" pitchFamily="34" charset="0"/>
+                <a:ea typeface="Arial" pitchFamily="34" charset="-122"/>
+                <a:cs typeface="Arial" pitchFamily="34" charset="-120"/>
               </a:rPr>
               <a:t>3</a:t>
             </a:r>
-            <a:endParaRPr lang="en-US" sz="1200" dirty="0"/>
+            <a:endParaRPr lang="vi-VN" sz="1200" dirty="0"/>
           </a:p>
         </p:txBody>
       </p:sp>
@@ -8264,17 +8504,17 @@
               <a:buNone/>
             </a:pPr>
             <a:r>
-              <a:rPr lang="en-US" sz="1800" b="1" dirty="0">
+              <a:rPr lang="vi-VN" sz="1800" b="1" dirty="0">
                 <a:solidFill>
                   <a:srgbClr val="13261D"/>
                 </a:solidFill>
-                <a:latin typeface="Be Vietnam Pro" pitchFamily="34" charset="0"/>
-                <a:ea typeface="Be Vietnam Pro" pitchFamily="34" charset="-122"/>
-                <a:cs typeface="Be Vietnam Pro" pitchFamily="34" charset="-120"/>
+                <a:latin typeface="Arial" pitchFamily="34" charset="0"/>
+                <a:ea typeface="Arial" pitchFamily="34" charset="-122"/>
+                <a:cs typeface="Arial" pitchFamily="34" charset="-120"/>
               </a:rPr>
               <a:t>Tính ruồi vào bẫy mỗi ngày</a:t>
             </a:r>
-            <a:endParaRPr lang="en-US" sz="1800" dirty="0"/>
+            <a:endParaRPr lang="vi-VN" sz="1800" dirty="0"/>
           </a:p>
         </p:txBody>
       </p:sp>
@@ -8308,17 +8548,17 @@
               <a:buNone/>
             </a:pPr>
             <a:r>
-              <a:rPr lang="en-US" sz="1300" dirty="0">
+              <a:rPr lang="vi-VN" sz="1300" dirty="0">
                 <a:solidFill>
                   <a:srgbClr val="4A5A50"/>
                 </a:solidFill>
-                <a:latin typeface="Be Vietnam Pro" pitchFamily="34" charset="0"/>
-                <a:ea typeface="Be Vietnam Pro" pitchFamily="34" charset="-122"/>
-                <a:cs typeface="Be Vietnam Pro" pitchFamily="34" charset="-120"/>
+                <a:latin typeface="Arial" pitchFamily="34" charset="0"/>
+                <a:ea typeface="Arial" pitchFamily="34" charset="-122"/>
+                <a:cs typeface="Arial" pitchFamily="34" charset="-120"/>
               </a:rPr>
               <a:t>Số con mới mỗi ngày và chỉ số ruồi/bẫy/ngày để so sánh.</a:t>
             </a:r>
-            <a:endParaRPr lang="en-US" sz="1300" dirty="0"/>
+            <a:endParaRPr lang="vi-VN" sz="1300" dirty="0"/>
           </a:p>
         </p:txBody>
       </p:sp>
@@ -8427,17 +8667,17 @@
               <a:buNone/>
             </a:pPr>
             <a:r>
-              <a:rPr lang="en-US" sz="1200" b="1" dirty="0">
+              <a:rPr lang="vi-VN" sz="1200" b="1" dirty="0">
                 <a:solidFill>
                   <a:srgbClr val="13261D"/>
                 </a:solidFill>
-                <a:latin typeface="Be Vietnam Pro" pitchFamily="34" charset="0"/>
-                <a:ea typeface="Be Vietnam Pro" pitchFamily="34" charset="-122"/>
-                <a:cs typeface="Be Vietnam Pro" pitchFamily="34" charset="-120"/>
+                <a:latin typeface="Arial" pitchFamily="34" charset="0"/>
+                <a:ea typeface="Arial" pitchFamily="34" charset="-122"/>
+                <a:cs typeface="Arial" pitchFamily="34" charset="-120"/>
               </a:rPr>
               <a:t>4</a:t>
             </a:r>
-            <a:endParaRPr lang="en-US" sz="1200" dirty="0"/>
+            <a:endParaRPr lang="vi-VN" sz="1200" dirty="0"/>
           </a:p>
         </p:txBody>
       </p:sp>
@@ -8471,17 +8711,17 @@
               <a:buNone/>
             </a:pPr>
             <a:r>
-              <a:rPr lang="en-US" sz="1800" b="1" dirty="0">
+              <a:rPr lang="vi-VN" sz="1800" b="1" dirty="0">
                 <a:solidFill>
                   <a:srgbClr val="F5F7F1"/>
                 </a:solidFill>
-                <a:latin typeface="Be Vietnam Pro" pitchFamily="34" charset="0"/>
-                <a:ea typeface="Be Vietnam Pro" pitchFamily="34" charset="-122"/>
-                <a:cs typeface="Be Vietnam Pro" pitchFamily="34" charset="-120"/>
+                <a:latin typeface="Arial" pitchFamily="34" charset="0"/>
+                <a:ea typeface="Arial" pitchFamily="34" charset="-122"/>
+                <a:cs typeface="Arial" pitchFamily="34" charset="-120"/>
               </a:rPr>
               <a:t>Cảnh báo và báo cáo</a:t>
             </a:r>
-            <a:endParaRPr lang="en-US" sz="1800" dirty="0"/>
+            <a:endParaRPr lang="vi-VN" sz="1800" dirty="0"/>
           </a:p>
         </p:txBody>
       </p:sp>
@@ -8515,17 +8755,17 @@
               <a:buNone/>
             </a:pPr>
             <a:r>
-              <a:rPr lang="en-US" sz="1300" dirty="0">
+              <a:rPr lang="vi-VN" sz="1300" dirty="0">
                 <a:solidFill>
                   <a:srgbClr val="BFD3C6"/>
                 </a:solidFill>
-                <a:latin typeface="Be Vietnam Pro" pitchFamily="34" charset="0"/>
-                <a:ea typeface="Be Vietnam Pro" pitchFamily="34" charset="-122"/>
-                <a:cs typeface="Be Vietnam Pro" pitchFamily="34" charset="-120"/>
+                <a:latin typeface="Arial" pitchFamily="34" charset="0"/>
+                <a:ea typeface="Arial" pitchFamily="34" charset="-122"/>
+                <a:cs typeface="Arial" pitchFamily="34" charset="-120"/>
               </a:rPr>
               <a:t>Báo ngay khi vượt ngưỡng; báo cáo gửi định kỳ.</a:t>
             </a:r>
-            <a:endParaRPr lang="en-US" sz="1300" dirty="0"/>
+            <a:endParaRPr lang="vi-VN" sz="1300" dirty="0"/>
           </a:p>
         </p:txBody>
       </p:sp>
@@ -8559,17 +8799,17 @@
               <a:buNone/>
             </a:pPr>
             <a:r>
-              <a:rPr lang="en-US" sz="1200" dirty="0">
+              <a:rPr lang="vi-VN" sz="1200" dirty="0">
                 <a:solidFill>
                   <a:srgbClr val="6B7B70"/>
                 </a:solidFill>
-                <a:latin typeface="Be Vietnam Pro" pitchFamily="34" charset="0"/>
-                <a:ea typeface="Be Vietnam Pro" pitchFamily="34" charset="-122"/>
-                <a:cs typeface="Be Vietnam Pro" pitchFamily="34" charset="-120"/>
+                <a:latin typeface="Arial" pitchFamily="34" charset="0"/>
+                <a:ea typeface="Arial" pitchFamily="34" charset="-122"/>
+                <a:cs typeface="Arial" pitchFamily="34" charset="-120"/>
               </a:rPr>
               <a:t>FlyBot · 3</a:t>
             </a:r>
-            <a:endParaRPr lang="en-US" sz="1200" dirty="0"/>
+            <a:endParaRPr lang="vi-VN" sz="1200" dirty="0"/>
           </a:p>
         </p:txBody>
       </p:sp>
@@ -8635,17 +8875,17 @@
               <a:buNone/>
             </a:pPr>
             <a:r>
-              <a:rPr lang="en-US" sz="1200" b="1" spc="150" kern="0" dirty="0">
+              <a:rPr lang="vi-VN" sz="1200" b="1" spc="150" kern="0" dirty="0">
                 <a:solidFill>
                   <a:srgbClr val="F2C230"/>
                 </a:solidFill>
-                <a:latin typeface="Be Vietnam Pro" pitchFamily="34" charset="0"/>
-                <a:ea typeface="Be Vietnam Pro" pitchFamily="34" charset="-122"/>
-                <a:cs typeface="Be Vietnam Pro" pitchFamily="34" charset="-120"/>
+                <a:latin typeface="Arial" pitchFamily="34" charset="0"/>
+                <a:ea typeface="Arial" pitchFamily="34" charset="-122"/>
+                <a:cs typeface="Arial" pitchFamily="34" charset="-120"/>
               </a:rPr>
               <a:t>VIDEO GIỚI THIỆU</a:t>
             </a:r>
-            <a:endParaRPr lang="en-US" sz="1200" dirty="0"/>
+            <a:endParaRPr lang="vi-VN" sz="1200" dirty="0"/>
           </a:p>
         </p:txBody>
       </p:sp>
@@ -8681,17 +8921,17 @@
               <a:buNone/>
             </a:pPr>
             <a:r>
-              <a:rPr lang="en-US" sz="3200" b="1" i="0" dirty="0">
+              <a:rPr lang="vi-VN" sz="3200" b="1" i="0" dirty="0">
                 <a:solidFill>
                   <a:srgbClr val="F5F7F1"/>
                 </a:solidFill>
-                <a:latin typeface="Be Vietnam Pro" pitchFamily="34" charset="0"/>
-                <a:ea typeface="Be Vietnam Pro" pitchFamily="34" charset="-122"/>
-                <a:cs typeface="Be Vietnam Pro" pitchFamily="34" charset="-120"/>
+                <a:latin typeface="Arial" pitchFamily="34" charset="0"/>
+                <a:ea typeface="Arial" pitchFamily="34" charset="-122"/>
+                <a:cs typeface="Arial" pitchFamily="34" charset="-120"/>
               </a:rPr>
               <a:t>FlyBot trong 82 giây</a:t>
             </a:r>
-            <a:endParaRPr lang="en-US" sz="3200" dirty="0"/>
+            <a:endParaRPr lang="vi-VN" sz="3200" dirty="0"/>
           </a:p>
         </p:txBody>
       </p:sp>
@@ -8725,17 +8965,17 @@
               <a:buNone/>
             </a:pPr>
             <a:r>
-              <a:rPr lang="en-US" sz="1400" dirty="0">
+              <a:rPr lang="vi-VN" sz="1400" dirty="0">
                 <a:solidFill>
                   <a:srgbClr val="BFD3C6"/>
                 </a:solidFill>
-                <a:latin typeface="Be Vietnam Pro" pitchFamily="34" charset="0"/>
-                <a:ea typeface="Be Vietnam Pro" pitchFamily="34" charset="-122"/>
-                <a:cs typeface="Be Vietnam Pro" pitchFamily="34" charset="-120"/>
+                <a:latin typeface="Arial" pitchFamily="34" charset="0"/>
+                <a:ea typeface="Arial" pitchFamily="34" charset="-122"/>
+                <a:cs typeface="Arial" pitchFamily="34" charset="-120"/>
               </a:rPr>
               <a:t>Một vòng qua ứng dụng: tổng quan, nhận dạng AI, camera, phân tích, báo cáo, trợ lý FlyBot và hướng dẫn nhanh.</a:t>
             </a:r>
-            <a:endParaRPr lang="en-US" sz="1400" dirty="0"/>
+            <a:endParaRPr lang="vi-VN" sz="1400" dirty="0"/>
           </a:p>
         </p:txBody>
       </p:sp>
@@ -8769,24 +9009,24 @@
               <a:buNone/>
             </a:pPr>
             <a:r>
-              <a:rPr lang="en-US" sz="1400" b="1" dirty="0">
+              <a:rPr lang="vi-VN" sz="1400" b="1" dirty="0">
                 <a:solidFill>
                   <a:srgbClr val="F2C230"/>
                 </a:solidFill>
-                <a:latin typeface="Be Vietnam Pro" pitchFamily="34" charset="0"/>
-                <a:ea typeface="Be Vietnam Pro" pitchFamily="34" charset="-122"/>
-                <a:cs typeface="Be Vietnam Pro" pitchFamily="34" charset="-120"/>
+                <a:latin typeface="Arial" pitchFamily="34" charset="0"/>
+                <a:ea typeface="Arial" pitchFamily="34" charset="-122"/>
+                <a:cs typeface="Arial" pitchFamily="34" charset="-120"/>
               </a:rPr>
               <a:t>▶ </a:t>
             </a:r>
             <a:r>
-              <a:rPr lang="en-US" sz="1400" b="1" u="sng" dirty="0">
+              <a:rPr lang="vi-VN" sz="1400" b="1" u="sng" dirty="0">
                 <a:solidFill>
                   <a:srgbClr val="F2C230"/>
                 </a:solidFill>
-                <a:latin typeface="Be Vietnam Pro" pitchFamily="34" charset="0"/>
-                <a:ea typeface="Be Vietnam Pro" pitchFamily="34" charset="-122"/>
-                <a:cs typeface="Be Vietnam Pro" pitchFamily="34" charset="-120"/>
+                <a:latin typeface="Arial" pitchFamily="34" charset="0"/>
+                <a:ea typeface="Arial" pitchFamily="34" charset="-122"/>
+                <a:cs typeface="Arial" pitchFamily="34" charset="-120"/>
                 <a:hlinkClick r:id="rId1" invalidUrl="" action="" tgtFrame="" tooltip="" history="1" highlightClick="0" endSnd="0">
                   <a:extLst>
                     <a:ext uri="{A12FA001-AC4F-418D-AE19-62706E023703}">
@@ -8797,7 +9037,7 @@
               </a:rPr>
               <a:t>Xem video trên website</a:t>
             </a:r>
-            <a:endParaRPr lang="en-US" sz="1400" dirty="0"/>
+            <a:endParaRPr lang="vi-VN" sz="1400" dirty="0"/>
           </a:p>
         </p:txBody>
       </p:sp>
@@ -8831,17 +9071,17 @@
               <a:buNone/>
             </a:pPr>
             <a:r>
-              <a:rPr lang="en-US" sz="1200" dirty="0">
+              <a:rPr lang="vi-VN" sz="1200" dirty="0">
                 <a:solidFill>
                   <a:srgbClr val="8FA898"/>
                 </a:solidFill>
-                <a:latin typeface="Be Vietnam Pro" pitchFamily="34" charset="0"/>
-                <a:ea typeface="Be Vietnam Pro" pitchFamily="34" charset="-122"/>
-                <a:cs typeface="Be Vietnam Pro" pitchFamily="34" charset="-120"/>
+                <a:latin typeface="Arial" pitchFamily="34" charset="0"/>
+                <a:ea typeface="Arial" pitchFamily="34" charset="-122"/>
+                <a:cs typeface="Arial" pitchFamily="34" charset="-120"/>
               </a:rPr>
               <a:t>Video tự chạy khi trình chiếu. Trong file PDF hoặc PowerPoint, bấm vào video hoặc link trên để xem bản mới nhất trên website.</a:t>
             </a:r>
-            <a:endParaRPr lang="en-US" sz="1200" dirty="0"/>
+            <a:endParaRPr lang="vi-VN" sz="1200" dirty="0"/>
           </a:p>
         </p:txBody>
       </p:sp>
@@ -9008,17 +9248,17 @@
               <a:buNone/>
             </a:pPr>
             <a:r>
-              <a:rPr lang="en-US" sz="1200" dirty="0">
+              <a:rPr lang="vi-VN" sz="1200" dirty="0">
                 <a:solidFill>
                   <a:srgbClr val="8FA898"/>
                 </a:solidFill>
-                <a:latin typeface="Be Vietnam Pro" pitchFamily="34" charset="0"/>
-                <a:ea typeface="Be Vietnam Pro" pitchFamily="34" charset="-122"/>
-                <a:cs typeface="Be Vietnam Pro" pitchFamily="34" charset="-120"/>
+                <a:latin typeface="Arial" pitchFamily="34" charset="0"/>
+                <a:ea typeface="Arial" pitchFamily="34" charset="-122"/>
+                <a:cs typeface="Arial" pitchFamily="34" charset="-120"/>
               </a:rPr>
               <a:t>FlyBot · 4</a:t>
             </a:r>
-            <a:endParaRPr lang="en-US" sz="1200" dirty="0"/>
+            <a:endParaRPr lang="vi-VN" sz="1200" dirty="0"/>
           </a:p>
         </p:txBody>
       </p:sp>
@@ -9084,17 +9324,17 @@
               <a:buNone/>
             </a:pPr>
             <a:r>
-              <a:rPr lang="en-US" sz="1196" b="1" spc="150" kern="0" dirty="0">
+              <a:rPr lang="vi-VN" sz="1196" b="1" spc="150" kern="0" dirty="0">
                 <a:solidFill>
                   <a:srgbClr val="1D7A50"/>
                 </a:solidFill>
-                <a:latin typeface="Be Vietnam Pro" pitchFamily="34" charset="0"/>
-                <a:ea typeface="Be Vietnam Pro" pitchFamily="34" charset="-122"/>
-                <a:cs typeface="Be Vietnam Pro" pitchFamily="34" charset="-120"/>
+                <a:latin typeface="Arial" pitchFamily="34" charset="0"/>
+                <a:ea typeface="Arial" pitchFamily="34" charset="-122"/>
+                <a:cs typeface="Arial" pitchFamily="34" charset="-120"/>
               </a:rPr>
               <a:t>TỔNG QUAN</a:t>
             </a:r>
-            <a:endParaRPr lang="en-US" sz="1196" dirty="0"/>
+            <a:endParaRPr lang="vi-VN" sz="1196" dirty="0"/>
           </a:p>
         </p:txBody>
       </p:sp>
@@ -9130,17 +9370,17 @@
               <a:buNone/>
             </a:pPr>
             <a:r>
-              <a:rPr lang="en-US" sz="3190" b="1" i="0" dirty="0">
+              <a:rPr lang="vi-VN" sz="3190" b="1" i="0" dirty="0">
                 <a:solidFill>
                   <a:srgbClr val="13261D"/>
                 </a:solidFill>
-                <a:latin typeface="Be Vietnam Pro" pitchFamily="34" charset="0"/>
-                <a:ea typeface="Be Vietnam Pro" pitchFamily="34" charset="-122"/>
-                <a:cs typeface="Be Vietnam Pro" pitchFamily="34" charset="-120"/>
+                <a:latin typeface="Arial" pitchFamily="34" charset="0"/>
+                <a:ea typeface="Arial" pitchFamily="34" charset="-122"/>
+                <a:cs typeface="Arial" pitchFamily="34" charset="-120"/>
               </a:rPr>
               <a:t>Cả vườn trong một màn hình</a:t>
             </a:r>
-            <a:endParaRPr lang="en-US" sz="3190" dirty="0"/>
+            <a:endParaRPr lang="vi-VN" sz="3190" dirty="0"/>
           </a:p>
         </p:txBody>
       </p:sp>
@@ -9253,17 +9493,17 @@
               <a:buNone/>
             </a:pPr>
             <a:r>
-              <a:rPr lang="en-US" sz="1600" b="1" dirty="0">
+              <a:rPr lang="vi-VN" sz="1600" b="1" dirty="0">
                 <a:solidFill>
                   <a:srgbClr val="13261D"/>
                 </a:solidFill>
-                <a:latin typeface="Be Vietnam Pro" pitchFamily="34" charset="0"/>
-                <a:ea typeface="Be Vietnam Pro" pitchFamily="34" charset="-122"/>
-                <a:cs typeface="Be Vietnam Pro" pitchFamily="34" charset="-120"/>
+                <a:latin typeface="Arial" pitchFamily="34" charset="0"/>
+                <a:ea typeface="Arial" pitchFamily="34" charset="-122"/>
+                <a:cs typeface="Arial" pitchFamily="34" charset="-120"/>
               </a:rPr>
               <a:t>Ruồi vào bẫy hôm nay</a:t>
             </a:r>
-            <a:endParaRPr lang="en-US" sz="1600" dirty="0"/>
+            <a:endParaRPr lang="vi-VN" sz="1600" dirty="0"/>
           </a:p>
         </p:txBody>
       </p:sp>
@@ -9297,17 +9537,17 @@
               <a:buNone/>
             </a:pPr>
             <a:r>
-              <a:rPr lang="en-US" sz="1300" dirty="0">
+              <a:rPr lang="vi-VN" sz="1300" dirty="0">
                 <a:solidFill>
                   <a:srgbClr val="4A5A50"/>
                 </a:solidFill>
-                <a:latin typeface="Be Vietnam Pro" pitchFamily="34" charset="0"/>
-                <a:ea typeface="Be Vietnam Pro" pitchFamily="34" charset="-122"/>
-                <a:cs typeface="Be Vietnam Pro" pitchFamily="34" charset="-120"/>
+                <a:latin typeface="Arial" pitchFamily="34" charset="0"/>
+                <a:ea typeface="Arial" pitchFamily="34" charset="-122"/>
+                <a:cs typeface="Arial" pitchFamily="34" charset="-120"/>
               </a:rPr>
               <a:t>Số con mới, không phải tổng dồn trên tấm keo.</a:t>
             </a:r>
-            <a:endParaRPr lang="en-US" sz="1300" dirty="0"/>
+            <a:endParaRPr lang="vi-VN" sz="1300" dirty="0"/>
           </a:p>
         </p:txBody>
       </p:sp>
@@ -9341,17 +9581,17 @@
               <a:buNone/>
             </a:pPr>
             <a:r>
-              <a:rPr lang="en-US" sz="1600" b="1" dirty="0">
+              <a:rPr lang="vi-VN" sz="1600" b="1" dirty="0">
                 <a:solidFill>
                   <a:srgbClr val="13261D"/>
                 </a:solidFill>
-                <a:latin typeface="Be Vietnam Pro" pitchFamily="34" charset="0"/>
-                <a:ea typeface="Be Vietnam Pro" pitchFamily="34" charset="-122"/>
-                <a:cs typeface="Be Vietnam Pro" pitchFamily="34" charset="-120"/>
+                <a:latin typeface="Arial" pitchFamily="34" charset="0"/>
+                <a:ea typeface="Arial" pitchFamily="34" charset="-122"/>
+                <a:cs typeface="Arial" pitchFamily="34" charset="-120"/>
               </a:rPr>
               <a:t>Ruồi/bẫy/ngày</a:t>
             </a:r>
-            <a:endParaRPr lang="en-US" sz="1600" dirty="0"/>
+            <a:endParaRPr lang="vi-VN" sz="1600" dirty="0"/>
           </a:p>
         </p:txBody>
       </p:sp>
@@ -9385,17 +9625,17 @@
               <a:buNone/>
             </a:pPr>
             <a:r>
-              <a:rPr lang="en-US" sz="1300" dirty="0">
+              <a:rPr lang="vi-VN" sz="1300" dirty="0">
                 <a:solidFill>
                   <a:srgbClr val="4A5A50"/>
                 </a:solidFill>
-                <a:latin typeface="Be Vietnam Pro" pitchFamily="34" charset="0"/>
-                <a:ea typeface="Be Vietnam Pro" pitchFamily="34" charset="-122"/>
-                <a:cs typeface="Be Vietnam Pro" pitchFamily="34" charset="-120"/>
+                <a:latin typeface="Arial" pitchFamily="34" charset="0"/>
+                <a:ea typeface="Arial" pitchFamily="34" charset="-122"/>
+                <a:cs typeface="Arial" pitchFamily="34" charset="-120"/>
               </a:rPr>
               <a:t>Chỉ số chuẩn để so sánh giữa các bẫy và với tuần trước.</a:t>
             </a:r>
-            <a:endParaRPr lang="en-US" sz="1300" dirty="0"/>
+            <a:endParaRPr lang="vi-VN" sz="1300" dirty="0"/>
           </a:p>
         </p:txBody>
       </p:sp>
@@ -9429,17 +9669,17 @@
               <a:buNone/>
             </a:pPr>
             <a:r>
-              <a:rPr lang="en-US" sz="1600" b="1" dirty="0">
+              <a:rPr lang="vi-VN" sz="1600" b="1" dirty="0">
                 <a:solidFill>
                   <a:srgbClr val="13261D"/>
                 </a:solidFill>
-                <a:latin typeface="Be Vietnam Pro" pitchFamily="34" charset="0"/>
-                <a:ea typeface="Be Vietnam Pro" pitchFamily="34" charset="-122"/>
-                <a:cs typeface="Be Vietnam Pro" pitchFamily="34" charset="-120"/>
+                <a:latin typeface="Arial" pitchFamily="34" charset="0"/>
+                <a:ea typeface="Arial" pitchFamily="34" charset="-122"/>
+                <a:cs typeface="Arial" pitchFamily="34" charset="-120"/>
               </a:rPr>
               <a:t>Nguy cơ theo từng bẫy</a:t>
             </a:r>
-            <a:endParaRPr lang="en-US" sz="1600" dirty="0"/>
+            <a:endParaRPr lang="vi-VN" sz="1600" dirty="0"/>
           </a:p>
         </p:txBody>
       </p:sp>
@@ -9473,17 +9713,17 @@
               <a:buNone/>
             </a:pPr>
             <a:r>
-              <a:rPr lang="en-US" sz="1300" dirty="0">
+              <a:rPr lang="vi-VN" sz="1300" dirty="0">
                 <a:solidFill>
                   <a:srgbClr val="4A5A50"/>
                 </a:solidFill>
-                <a:latin typeface="Be Vietnam Pro" pitchFamily="34" charset="0"/>
-                <a:ea typeface="Be Vietnam Pro" pitchFamily="34" charset="-122"/>
-                <a:cs typeface="Be Vietnam Pro" pitchFamily="34" charset="-120"/>
+                <a:latin typeface="Arial" pitchFamily="34" charset="0"/>
+                <a:ea typeface="Arial" pitchFamily="34" charset="-122"/>
+                <a:cs typeface="Arial" pitchFamily="34" charset="-120"/>
               </a:rPr>
               <a:t>So với ngưỡng riêng của mỗi bẫy, kèm ảnh nhận dạng mới nhất.</a:t>
             </a:r>
-            <a:endParaRPr lang="en-US" sz="1300" dirty="0"/>
+            <a:endParaRPr lang="vi-VN" sz="1300" dirty="0"/>
           </a:p>
         </p:txBody>
       </p:sp>
@@ -9517,17 +9757,17 @@
               <a:buNone/>
             </a:pPr>
             <a:r>
-              <a:rPr lang="en-US" sz="1200" dirty="0">
+              <a:rPr lang="vi-VN" sz="1200" dirty="0">
                 <a:solidFill>
                   <a:srgbClr val="6B7B70"/>
                 </a:solidFill>
-                <a:latin typeface="Be Vietnam Pro" pitchFamily="34" charset="0"/>
-                <a:ea typeface="Be Vietnam Pro" pitchFamily="34" charset="-122"/>
-                <a:cs typeface="Be Vietnam Pro" pitchFamily="34" charset="-120"/>
+                <a:latin typeface="Arial" pitchFamily="34" charset="0"/>
+                <a:ea typeface="Arial" pitchFamily="34" charset="-122"/>
+                <a:cs typeface="Arial" pitchFamily="34" charset="-120"/>
               </a:rPr>
               <a:t>FlyBot · 5</a:t>
             </a:r>
-            <a:endParaRPr lang="en-US" sz="1200" dirty="0"/>
+            <a:endParaRPr lang="vi-VN" sz="1200" dirty="0"/>
           </a:p>
         </p:txBody>
       </p:sp>
@@ -9593,17 +9833,17 @@
               <a:buNone/>
             </a:pPr>
             <a:r>
-              <a:rPr lang="en-US" sz="1196" b="1" spc="150" kern="0" dirty="0">
+              <a:rPr lang="vi-VN" sz="1196" b="1" spc="150" kern="0" dirty="0">
                 <a:solidFill>
                   <a:srgbClr val="1D7A50"/>
                 </a:solidFill>
-                <a:latin typeface="Be Vietnam Pro" pitchFamily="34" charset="0"/>
-                <a:ea typeface="Be Vietnam Pro" pitchFamily="34" charset="-122"/>
-                <a:cs typeface="Be Vietnam Pro" pitchFamily="34" charset="-120"/>
+                <a:latin typeface="Arial" pitchFamily="34" charset="0"/>
+                <a:ea typeface="Arial" pitchFamily="34" charset="-122"/>
+                <a:cs typeface="Arial" pitchFamily="34" charset="-120"/>
               </a:rPr>
               <a:t>NHẬN DẠNG AI</a:t>
             </a:r>
-            <a:endParaRPr lang="en-US" sz="1196" dirty="0"/>
+            <a:endParaRPr lang="vi-VN" sz="1196" dirty="0"/>
           </a:p>
         </p:txBody>
       </p:sp>
@@ -9639,17 +9879,17 @@
               <a:buNone/>
             </a:pPr>
             <a:r>
-              <a:rPr lang="en-US" sz="3190" b="1" i="0" dirty="0">
+              <a:rPr lang="vi-VN" sz="3190" b="1" i="0" dirty="0">
                 <a:solidFill>
                   <a:srgbClr val="13261D"/>
                 </a:solidFill>
-                <a:latin typeface="Be Vietnam Pro" pitchFamily="34" charset="0"/>
-                <a:ea typeface="Be Vietnam Pro" pitchFamily="34" charset="-122"/>
-                <a:cs typeface="Be Vietnam Pro" pitchFamily="34" charset="-120"/>
+                <a:latin typeface="Arial" pitchFamily="34" charset="0"/>
+                <a:ea typeface="Arial" pitchFamily="34" charset="-122"/>
+                <a:cs typeface="Arial" pitchFamily="34" charset="-120"/>
               </a:rPr>
               <a:t>Từng con được khoanh và gọi đúng tên</a:t>
             </a:r>
-            <a:endParaRPr lang="en-US" sz="3190" dirty="0"/>
+            <a:endParaRPr lang="vi-VN" sz="3190" dirty="0"/>
           </a:p>
         </p:txBody>
       </p:sp>
@@ -9762,17 +10002,17 @@
               <a:buNone/>
             </a:pPr>
             <a:r>
-              <a:rPr lang="en-US" sz="1600" b="1" dirty="0">
+              <a:rPr lang="vi-VN" sz="1600" b="1" dirty="0">
                 <a:solidFill>
                   <a:srgbClr val="13261D"/>
                 </a:solidFill>
-                <a:latin typeface="Be Vietnam Pro" pitchFamily="34" charset="0"/>
-                <a:ea typeface="Be Vietnam Pro" pitchFamily="34" charset="-122"/>
-                <a:cs typeface="Be Vietnam Pro" pitchFamily="34" charset="-120"/>
+                <a:latin typeface="Arial" pitchFamily="34" charset="0"/>
+                <a:ea typeface="Arial" pitchFamily="34" charset="-122"/>
+                <a:cs typeface="Arial" pitchFamily="34" charset="-120"/>
               </a:rPr>
               <a:t>Khung và tên loài</a:t>
             </a:r>
-            <a:endParaRPr lang="en-US" sz="1600" dirty="0"/>
+            <a:endParaRPr lang="vi-VN" sz="1600" dirty="0"/>
           </a:p>
         </p:txBody>
       </p:sp>
@@ -9806,17 +10046,17 @@
               <a:buNone/>
             </a:pPr>
             <a:r>
-              <a:rPr lang="en-US" sz="1300" dirty="0">
+              <a:rPr lang="vi-VN" sz="1300" dirty="0">
                 <a:solidFill>
                   <a:srgbClr val="4A5A50"/>
                 </a:solidFill>
-                <a:latin typeface="Be Vietnam Pro" pitchFamily="34" charset="0"/>
-                <a:ea typeface="Be Vietnam Pro" pitchFamily="34" charset="-122"/>
-                <a:cs typeface="Be Vietnam Pro" pitchFamily="34" charset="-120"/>
+                <a:latin typeface="Arial" pitchFamily="34" charset="0"/>
+                <a:ea typeface="Arial" pitchFamily="34" charset="-122"/>
+                <a:cs typeface="Arial" pitchFamily="34" charset="-120"/>
               </a:rPr>
               <a:t>Mỗi con có khung, tên loài và độ tin cậy; thống kê theo loài.</a:t>
             </a:r>
-            <a:endParaRPr lang="en-US" sz="1300" dirty="0"/>
+            <a:endParaRPr lang="vi-VN" sz="1300" dirty="0"/>
           </a:p>
         </p:txBody>
       </p:sp>
@@ -9828,7 +10068,7 @@
         </p:nvSpPr>
         <p:spPr>
           <a:xfrm>
-            <a:off x="7569200" y="2949575"/>
+            <a:off x="7569200" y="2898775"/>
             <a:ext cx="3924300" cy="279400"/>
           </a:xfrm>
           <a:prstGeom prst="rect">
@@ -9850,29 +10090,117 @@
               <a:buNone/>
             </a:pPr>
             <a:r>
-              <a:rPr lang="en-US" sz="1600" b="1" dirty="0">
+              <a:rPr lang="vi-VN" sz="1600" b="1" dirty="0">
                 <a:solidFill>
                   <a:srgbClr val="13261D"/>
                 </a:solidFill>
-                <a:latin typeface="Be Vietnam Pro" pitchFamily="34" charset="0"/>
-                <a:ea typeface="Be Vietnam Pro" pitchFamily="34" charset="-122"/>
-                <a:cs typeface="Be Vietnam Pro" pitchFamily="34" charset="-120"/>
+                <a:latin typeface="Arial" pitchFamily="34" charset="0"/>
+                <a:ea typeface="Arial" pitchFamily="34" charset="-122"/>
+                <a:cs typeface="Arial" pitchFamily="34" charset="-120"/>
+              </a:rPr>
+              <a:t>Độ chính xác đã kiểm chứng</a:t>
+            </a:r>
+            <a:endParaRPr lang="vi-VN" sz="1600" dirty="0"/>
+          </a:p>
+        </p:txBody>
+      </p:sp>
+      <p:sp>
+        <p:nvSpPr>
+          <p:cNvPr id="10" name="Text 7"/>
+          <p:cNvSpPr/>
+          <p:nvPr/>
+        </p:nvSpPr>
+        <p:spPr>
+          <a:xfrm>
+            <a:off x="7569200" y="3203575"/>
+            <a:ext cx="3924300" cy="520700"/>
+          </a:xfrm>
+          <a:prstGeom prst="rect">
+            <a:avLst/>
+          </a:prstGeom>
+          <a:noFill/>
+          <a:ln/>
+        </p:spPr>
+        <p:txBody>
+          <a:bodyPr wrap="square" lIns="0" tIns="0" rIns="0" bIns="0" rtlCol="0" anchor="t">
+            <a:normAutofit/>
+          </a:bodyPr>
+          <a:lstStyle/>
+          <a:p>
+            <a:pPr algn="l" indent="0" marL="0">
+              <a:lnSpc>
+                <a:spcPts val="1950"/>
+              </a:lnSpc>
+              <a:buNone/>
+            </a:pPr>
+            <a:r>
+              <a:rPr lang="vi-VN" sz="1300" dirty="0">
+                <a:solidFill>
+                  <a:srgbClr val="4A5A50"/>
+                </a:solidFill>
+                <a:latin typeface="Arial" pitchFamily="34" charset="0"/>
+                <a:ea typeface="Arial" pitchFamily="34" charset="-122"/>
+                <a:cs typeface="Arial" pitchFamily="34" charset="-120"/>
+              </a:rPr>
+              <a:t>Trên ảnh kiểm thử: tìm thấy 92% số ruồi, 93% khung đúng là ruồi vàng.</a:t>
+            </a:r>
+            <a:endParaRPr lang="vi-VN" sz="1300" dirty="0"/>
+          </a:p>
+        </p:txBody>
+      </p:sp>
+      <p:sp>
+        <p:nvSpPr>
+          <p:cNvPr id="11" name="Text 8"/>
+          <p:cNvSpPr/>
+          <p:nvPr/>
+        </p:nvSpPr>
+        <p:spPr>
+          <a:xfrm>
+            <a:off x="7569200" y="3902075"/>
+            <a:ext cx="3924300" cy="279400"/>
+          </a:xfrm>
+          <a:prstGeom prst="rect">
+            <a:avLst/>
+          </a:prstGeom>
+          <a:noFill/>
+          <a:ln/>
+        </p:spPr>
+        <p:txBody>
+          <a:bodyPr wrap="square" lIns="0" tIns="0" rIns="0" bIns="0" rtlCol="0" anchor="t">
+            <a:normAutofit/>
+          </a:bodyPr>
+          <a:lstStyle/>
+          <a:p>
+            <a:pPr algn="l" indent="0" marL="0">
+              <a:lnSpc>
+                <a:spcPts val="2000"/>
+              </a:lnSpc>
+              <a:buNone/>
+            </a:pPr>
+            <a:r>
+              <a:rPr lang="vi-VN" sz="1600" b="1" dirty="0">
+                <a:solidFill>
+                  <a:srgbClr val="13261D"/>
+                </a:solidFill>
+                <a:latin typeface="Arial" pitchFamily="34" charset="0"/>
+                <a:ea typeface="Arial" pitchFamily="34" charset="-122"/>
+                <a:cs typeface="Arial" pitchFamily="34" charset="-120"/>
               </a:rPr>
               <a:t>Người kiểm tra lại</a:t>
             </a:r>
-            <a:endParaRPr lang="en-US" sz="1600" dirty="0"/>
-          </a:p>
-        </p:txBody>
-      </p:sp>
-      <p:sp>
-        <p:nvSpPr>
-          <p:cNvPr id="10" name="Text 7"/>
-          <p:cNvSpPr/>
-          <p:nvPr/>
-        </p:nvSpPr>
-        <p:spPr>
-          <a:xfrm>
-            <a:off x="7569200" y="3254375"/>
+            <a:endParaRPr lang="vi-VN" sz="1600" dirty="0"/>
+          </a:p>
+        </p:txBody>
+      </p:sp>
+      <p:sp>
+        <p:nvSpPr>
+          <p:cNvPr id="12" name="Text 9"/>
+          <p:cNvSpPr/>
+          <p:nvPr/>
+        </p:nvSpPr>
+        <p:spPr>
+          <a:xfrm>
+            <a:off x="7569200" y="4206875"/>
             <a:ext cx="4572000" cy="273050"/>
           </a:xfrm>
           <a:prstGeom prst="rect">
@@ -9894,29 +10222,29 @@
               <a:buNone/>
             </a:pPr>
             <a:r>
-              <a:rPr lang="en-US" sz="1300" dirty="0">
+              <a:rPr lang="vi-VN" sz="1300" dirty="0">
                 <a:solidFill>
                   <a:srgbClr val="4A5A50"/>
                 </a:solidFill>
-                <a:latin typeface="Be Vietnam Pro" pitchFamily="34" charset="0"/>
-                <a:ea typeface="Be Vietnam Pro" pitchFamily="34" charset="-122"/>
-                <a:cs typeface="Be Vietnam Pro" pitchFamily="34" charset="-120"/>
+                <a:latin typeface="Arial" pitchFamily="34" charset="0"/>
+                <a:ea typeface="Arial" pitchFamily="34" charset="-122"/>
+                <a:cs typeface="Arial" pitchFamily="34" charset="-120"/>
               </a:rPr>
               <a:t>Xác nhận đúng hoặc sửa số đếm ngay trên ảnh.</a:t>
             </a:r>
-            <a:endParaRPr lang="en-US" sz="1300" dirty="0"/>
-          </a:p>
-        </p:txBody>
-      </p:sp>
-      <p:sp>
-        <p:nvSpPr>
-          <p:cNvPr id="11" name="Text 8"/>
-          <p:cNvSpPr/>
-          <p:nvPr/>
-        </p:nvSpPr>
-        <p:spPr>
-          <a:xfrm>
-            <a:off x="7569200" y="3756025"/>
+            <a:endParaRPr lang="vi-VN" sz="1300" dirty="0"/>
+          </a:p>
+        </p:txBody>
+      </p:sp>
+      <p:sp>
+        <p:nvSpPr>
+          <p:cNvPr id="13" name="Text 10"/>
+          <p:cNvSpPr/>
+          <p:nvPr/>
+        </p:nvSpPr>
+        <p:spPr>
+          <a:xfrm>
+            <a:off x="7569200" y="4657725"/>
             <a:ext cx="3924300" cy="279400"/>
           </a:xfrm>
           <a:prstGeom prst="rect">
@@ -9938,29 +10266,29 @@
               <a:buNone/>
             </a:pPr>
             <a:r>
-              <a:rPr lang="en-US" sz="1600" b="1" dirty="0">
+              <a:rPr lang="vi-VN" sz="1600" b="1" dirty="0">
                 <a:solidFill>
                   <a:srgbClr val="13261D"/>
                 </a:solidFill>
-                <a:latin typeface="Be Vietnam Pro" pitchFamily="34" charset="0"/>
-                <a:ea typeface="Be Vietnam Pro" pitchFamily="34" charset="-122"/>
-                <a:cs typeface="Be Vietnam Pro" pitchFamily="34" charset="-120"/>
+                <a:latin typeface="Arial" pitchFamily="34" charset="0"/>
+                <a:ea typeface="Arial" pitchFamily="34" charset="-122"/>
+                <a:cs typeface="Arial" pitchFamily="34" charset="-120"/>
               </a:rPr>
               <a:t>AI ngày càng chính xác</a:t>
             </a:r>
-            <a:endParaRPr lang="en-US" sz="1600" dirty="0"/>
-          </a:p>
-        </p:txBody>
-      </p:sp>
-      <p:sp>
-        <p:nvSpPr>
-          <p:cNvPr id="12" name="Text 9"/>
-          <p:cNvSpPr/>
-          <p:nvPr/>
-        </p:nvSpPr>
-        <p:spPr>
-          <a:xfrm>
-            <a:off x="7569200" y="4060825"/>
+            <a:endParaRPr lang="vi-VN" sz="1600" dirty="0"/>
+          </a:p>
+        </p:txBody>
+      </p:sp>
+      <p:sp>
+        <p:nvSpPr>
+          <p:cNvPr id="14" name="Text 11"/>
+          <p:cNvSpPr/>
+          <p:nvPr/>
+        </p:nvSpPr>
+        <p:spPr>
+          <a:xfrm>
+            <a:off x="7569200" y="4962525"/>
             <a:ext cx="3924300" cy="520700"/>
           </a:xfrm>
           <a:prstGeom prst="rect">
@@ -9982,23 +10310,23 @@
               <a:buNone/>
             </a:pPr>
             <a:r>
-              <a:rPr lang="en-US" sz="1300" dirty="0">
+              <a:rPr lang="vi-VN" sz="1300" dirty="0">
                 <a:solidFill>
                   <a:srgbClr val="4A5A50"/>
                 </a:solidFill>
-                <a:latin typeface="Be Vietnam Pro" pitchFamily="34" charset="0"/>
-                <a:ea typeface="Be Vietnam Pro" pitchFamily="34" charset="-122"/>
-                <a:cs typeface="Be Vietnam Pro" pitchFamily="34" charset="-120"/>
+                <a:latin typeface="Arial" pitchFamily="34" charset="0"/>
+                <a:ea typeface="Arial" pitchFamily="34" charset="-122"/>
+                <a:cs typeface="Arial" pitchFamily="34" charset="-120"/>
               </a:rPr>
               <a:t>Ảnh đã duyệt được gửi đi để huấn luyện lại mô hình.</a:t>
             </a:r>
-            <a:endParaRPr lang="en-US" sz="1300" dirty="0"/>
-          </a:p>
-        </p:txBody>
-      </p:sp>
-      <p:sp>
-        <p:nvSpPr>
-          <p:cNvPr id="13" name="Text 10"/>
+            <a:endParaRPr lang="vi-VN" sz="1300" dirty="0"/>
+          </a:p>
+        </p:txBody>
+      </p:sp>
+      <p:sp>
+        <p:nvSpPr>
+          <p:cNvPr id="15" name="Text 12"/>
           <p:cNvSpPr/>
           <p:nvPr/>
         </p:nvSpPr>
@@ -10026,17 +10354,17 @@
               <a:buNone/>
             </a:pPr>
             <a:r>
-              <a:rPr lang="en-US" sz="1200" dirty="0">
+              <a:rPr lang="vi-VN" sz="1200" dirty="0">
                 <a:solidFill>
                   <a:srgbClr val="6B7B70"/>
                 </a:solidFill>
-                <a:latin typeface="Be Vietnam Pro" pitchFamily="34" charset="0"/>
-                <a:ea typeface="Be Vietnam Pro" pitchFamily="34" charset="-122"/>
-                <a:cs typeface="Be Vietnam Pro" pitchFamily="34" charset="-120"/>
+                <a:latin typeface="Arial" pitchFamily="34" charset="0"/>
+                <a:ea typeface="Arial" pitchFamily="34" charset="-122"/>
+                <a:cs typeface="Arial" pitchFamily="34" charset="-120"/>
               </a:rPr>
               <a:t>FlyBot · 6</a:t>
             </a:r>
-            <a:endParaRPr lang="en-US" sz="1200" dirty="0"/>
+            <a:endParaRPr lang="vi-VN" sz="1200" dirty="0"/>
           </a:p>
         </p:txBody>
       </p:sp>
@@ -10102,17 +10430,17 @@
               <a:buNone/>
             </a:pPr>
             <a:r>
-              <a:rPr lang="en-US" sz="1200" b="1" spc="150" kern="0" dirty="0">
+              <a:rPr lang="vi-VN" sz="1200" b="1" spc="150" kern="0" dirty="0">
                 <a:solidFill>
                   <a:srgbClr val="F2C230"/>
                 </a:solidFill>
-                <a:latin typeface="Be Vietnam Pro" pitchFamily="34" charset="0"/>
-                <a:ea typeface="Be Vietnam Pro" pitchFamily="34" charset="-122"/>
-                <a:cs typeface="Be Vietnam Pro" pitchFamily="34" charset="-120"/>
+                <a:latin typeface="Arial" pitchFamily="34" charset="0"/>
+                <a:ea typeface="Arial" pitchFamily="34" charset="-122"/>
+                <a:cs typeface="Arial" pitchFamily="34" charset="-120"/>
               </a:rPr>
               <a:t>HAI LOẠI BẪY</a:t>
             </a:r>
-            <a:endParaRPr lang="en-US" sz="1200" dirty="0"/>
+            <a:endParaRPr lang="vi-VN" sz="1200" dirty="0"/>
           </a:p>
         </p:txBody>
       </p:sp>
@@ -10148,17 +10476,17 @@
               <a:buNone/>
             </a:pPr>
             <a:r>
-              <a:rPr lang="en-US" sz="3200" b="1" i="0" dirty="0">
+              <a:rPr lang="vi-VN" sz="3200" b="1" i="0" dirty="0">
                 <a:solidFill>
                   <a:srgbClr val="F5F7F1"/>
                 </a:solidFill>
-                <a:latin typeface="Be Vietnam Pro" pitchFamily="34" charset="0"/>
-                <a:ea typeface="Be Vietnam Pro" pitchFamily="34" charset="-122"/>
-                <a:cs typeface="Be Vietnam Pro" pitchFamily="34" charset="-120"/>
+                <a:latin typeface="Arial" pitchFamily="34" charset="0"/>
+                <a:ea typeface="Arial" pitchFamily="34" charset="-122"/>
+                <a:cs typeface="Arial" pitchFamily="34" charset="-120"/>
               </a:rPr>
               <a:t>Mỗi loại bẫy được đọc số theo cách riêng</a:t>
             </a:r>
-            <a:endParaRPr lang="en-US" sz="3200" dirty="0"/>
+            <a:endParaRPr lang="vi-VN" sz="3200" dirty="0"/>
           </a:p>
         </p:txBody>
       </p:sp>
@@ -10223,17 +10551,17 @@
               <a:buNone/>
             </a:pPr>
             <a:r>
-              <a:rPr lang="en-US" sz="1200" b="1" dirty="0">
+              <a:rPr lang="vi-VN" sz="1200" b="1" dirty="0">
                 <a:solidFill>
                   <a:srgbClr val="13261D"/>
                 </a:solidFill>
-                <a:latin typeface="Be Vietnam Pro" pitchFamily="34" charset="0"/>
-                <a:ea typeface="Be Vietnam Pro" pitchFamily="34" charset="-122"/>
-                <a:cs typeface="Be Vietnam Pro" pitchFamily="34" charset="-120"/>
+                <a:latin typeface="Arial" pitchFamily="34" charset="0"/>
+                <a:ea typeface="Arial" pitchFamily="34" charset="-122"/>
+                <a:cs typeface="Arial" pitchFamily="34" charset="-120"/>
               </a:rPr>
               <a:t>Bẫy dính</a:t>
             </a:r>
-            <a:endParaRPr lang="en-US" sz="1200" dirty="0"/>
+            <a:endParaRPr lang="vi-VN" sz="1200" dirty="0"/>
           </a:p>
         </p:txBody>
       </p:sp>
@@ -10267,17 +10595,17 @@
               <a:buNone/>
             </a:pPr>
             <a:r>
-              <a:rPr lang="en-US" sz="2000" b="1" dirty="0">
+              <a:rPr lang="vi-VN" sz="2000" b="1" dirty="0">
                 <a:solidFill>
                   <a:srgbClr val="F5F7F1"/>
                 </a:solidFill>
-                <a:latin typeface="Be Vietnam Pro" pitchFamily="34" charset="0"/>
-                <a:ea typeface="Be Vietnam Pro" pitchFamily="34" charset="-122"/>
-                <a:cs typeface="Be Vietnam Pro" pitchFamily="34" charset="-120"/>
+                <a:latin typeface="Arial" pitchFamily="34" charset="0"/>
+                <a:ea typeface="Arial" pitchFamily="34" charset="-122"/>
+                <a:cs typeface="Arial" pitchFamily="34" charset="-120"/>
               </a:rPr>
               <a:t>Ruồi vào bẫy = phần tăng thêm mỗi ngày</a:t>
             </a:r>
-            <a:endParaRPr lang="en-US" sz="2000" dirty="0"/>
+            <a:endParaRPr lang="vi-VN" sz="2000" dirty="0"/>
           </a:p>
         </p:txBody>
       </p:sp>
@@ -10311,17 +10639,17 @@
               <a:buNone/>
             </a:pPr>
             <a:r>
-              <a:rPr lang="en-US" sz="1400" dirty="0">
+              <a:rPr lang="vi-VN" sz="1400" dirty="0">
                 <a:solidFill>
                   <a:srgbClr val="BFD3C6"/>
                 </a:solidFill>
-                <a:latin typeface="Be Vietnam Pro" pitchFamily="34" charset="0"/>
-                <a:ea typeface="Be Vietnam Pro" pitchFamily="34" charset="-122"/>
-                <a:cs typeface="Be Vietnam Pro" pitchFamily="34" charset="-120"/>
+                <a:latin typeface="Arial" pitchFamily="34" charset="0"/>
+                <a:ea typeface="Arial" pitchFamily="34" charset="-122"/>
+                <a:cs typeface="Arial" pitchFamily="34" charset="-120"/>
               </a:rPr>
               <a:t>Tấm keo giữ lại mọi con đã dính. FlyBot tính số con mới so với hôm trước, bỏ qua ngày thay tấm, và nhắc thay tấm theo tuổi tấm.</a:t>
             </a:r>
-            <a:endParaRPr lang="en-US" sz="1400" dirty="0"/>
+            <a:endParaRPr lang="vi-VN" sz="1400" dirty="0"/>
           </a:p>
         </p:txBody>
       </p:sp>
@@ -10386,17 +10714,17 @@
               <a:buNone/>
             </a:pPr>
             <a:r>
-              <a:rPr lang="en-US" sz="1200" b="1" dirty="0">
+              <a:rPr lang="vi-VN" sz="1200" b="1" dirty="0">
                 <a:solidFill>
                   <a:srgbClr val="13261D"/>
                 </a:solidFill>
-                <a:latin typeface="Be Vietnam Pro" pitchFamily="34" charset="0"/>
-                <a:ea typeface="Be Vietnam Pro" pitchFamily="34" charset="-122"/>
-                <a:cs typeface="Be Vietnam Pro" pitchFamily="34" charset="-120"/>
+                <a:latin typeface="Arial" pitchFamily="34" charset="0"/>
+                <a:ea typeface="Arial" pitchFamily="34" charset="-122"/>
+                <a:cs typeface="Arial" pitchFamily="34" charset="-120"/>
               </a:rPr>
               <a:t>Bẫy dẫn dụ</a:t>
             </a:r>
-            <a:endParaRPr lang="en-US" sz="1200" dirty="0"/>
+            <a:endParaRPr lang="vi-VN" sz="1200" dirty="0"/>
           </a:p>
         </p:txBody>
       </p:sp>
@@ -10430,17 +10758,17 @@
               <a:buNone/>
             </a:pPr>
             <a:r>
-              <a:rPr lang="en-US" sz="2000" b="1" dirty="0">
+              <a:rPr lang="vi-VN" sz="2000" b="1" dirty="0">
                 <a:solidFill>
                   <a:srgbClr val="F5F7F1"/>
                 </a:solidFill>
-                <a:latin typeface="Be Vietnam Pro" pitchFamily="34" charset="0"/>
-                <a:ea typeface="Be Vietnam Pro" pitchFamily="34" charset="-122"/>
-                <a:cs typeface="Be Vietnam Pro" pitchFamily="34" charset="-120"/>
+                <a:latin typeface="Arial" pitchFamily="34" charset="0"/>
+                <a:ea typeface="Arial" pitchFamily="34" charset="-122"/>
+                <a:cs typeface="Arial" pitchFamily="34" charset="-120"/>
               </a:rPr>
               <a:t>Đánh giá theo trung bình trong ngày</a:t>
             </a:r>
-            <a:endParaRPr lang="en-US" sz="2000" dirty="0"/>
+            <a:endParaRPr lang="vi-VN" sz="2000" dirty="0"/>
           </a:p>
         </p:txBody>
       </p:sp>
@@ -10474,17 +10802,17 @@
               <a:buNone/>
             </a:pPr>
             <a:r>
-              <a:rPr lang="en-US" sz="1400" dirty="0">
+              <a:rPr lang="vi-VN" sz="1400" dirty="0">
                 <a:solidFill>
                   <a:srgbClr val="BFD3C6"/>
                 </a:solidFill>
-                <a:latin typeface="Be Vietnam Pro" pitchFamily="34" charset="0"/>
-                <a:ea typeface="Be Vietnam Pro" pitchFamily="34" charset="-122"/>
-                <a:cs typeface="Be Vietnam Pro" pitchFamily="34" charset="-120"/>
+                <a:latin typeface="Arial" pitchFamily="34" charset="0"/>
+                <a:ea typeface="Arial" pitchFamily="34" charset="-122"/>
+                <a:cs typeface="Arial" pitchFamily="34" charset="-120"/>
               </a:rPr>
               <a:t>Ruồi vào rồi có thể bay đi, nên FlyBot dùng số con trung bình mỗi ảnh trong ngày. Một ảnh đông ruồi không còn gây báo động sai.</a:t>
             </a:r>
-            <a:endParaRPr lang="en-US" sz="1400" dirty="0"/>
+            <a:endParaRPr lang="vi-VN" sz="1400" dirty="0"/>
           </a:p>
         </p:txBody>
       </p:sp>
@@ -10518,17 +10846,17 @@
               <a:buNone/>
             </a:pPr>
             <a:r>
-              <a:rPr lang="en-US" sz="1200" dirty="0">
+              <a:rPr lang="vi-VN" sz="1200" dirty="0">
                 <a:solidFill>
                   <a:srgbClr val="8FA898"/>
                 </a:solidFill>
-                <a:latin typeface="Be Vietnam Pro" pitchFamily="34" charset="0"/>
-                <a:ea typeface="Be Vietnam Pro" pitchFamily="34" charset="-122"/>
-                <a:cs typeface="Be Vietnam Pro" pitchFamily="34" charset="-120"/>
+                <a:latin typeface="Arial" pitchFamily="34" charset="0"/>
+                <a:ea typeface="Arial" pitchFamily="34" charset="-122"/>
+                <a:cs typeface="Arial" pitchFamily="34" charset="-120"/>
               </a:rPr>
               <a:t>FlyBot · 7</a:t>
             </a:r>
-            <a:endParaRPr lang="en-US" sz="1200" dirty="0"/>
+            <a:endParaRPr lang="vi-VN" sz="1200" dirty="0"/>
           </a:p>
         </p:txBody>
       </p:sp>
@@ -10594,17 +10922,17 @@
               <a:buNone/>
             </a:pPr>
             <a:r>
-              <a:rPr lang="en-US" sz="1196" b="1" spc="150" kern="0" dirty="0">
+              <a:rPr lang="vi-VN" sz="1196" b="1" spc="150" kern="0" dirty="0">
                 <a:solidFill>
                   <a:srgbClr val="1D7A50"/>
                 </a:solidFill>
-                <a:latin typeface="Be Vietnam Pro" pitchFamily="34" charset="0"/>
-                <a:ea typeface="Be Vietnam Pro" pitchFamily="34" charset="-122"/>
-                <a:cs typeface="Be Vietnam Pro" pitchFamily="34" charset="-120"/>
+                <a:latin typeface="Arial" pitchFamily="34" charset="0"/>
+                <a:ea typeface="Arial" pitchFamily="34" charset="-122"/>
+                <a:cs typeface="Arial" pitchFamily="34" charset="-120"/>
               </a:rPr>
               <a:t>CAMERA</a:t>
             </a:r>
-            <a:endParaRPr lang="en-US" sz="1196" dirty="0"/>
+            <a:endParaRPr lang="vi-VN" sz="1196" dirty="0"/>
           </a:p>
         </p:txBody>
       </p:sp>
@@ -10640,17 +10968,17 @@
               <a:buNone/>
             </a:pPr>
             <a:r>
-              <a:rPr lang="en-US" sz="3190" b="1" i="0" dirty="0">
+              <a:rPr lang="vi-VN" sz="3190" b="1" i="0" dirty="0">
                 <a:solidFill>
                   <a:srgbClr val="13261D"/>
                 </a:solidFill>
-                <a:latin typeface="Be Vietnam Pro" pitchFamily="34" charset="0"/>
-                <a:ea typeface="Be Vietnam Pro" pitchFamily="34" charset="-122"/>
-                <a:cs typeface="Be Vietnam Pro" pitchFamily="34" charset="-120"/>
+                <a:latin typeface="Arial" pitchFamily="34" charset="0"/>
+                <a:ea typeface="Arial" pitchFamily="34" charset="-122"/>
+                <a:cs typeface="Arial" pitchFamily="34" charset="-120"/>
               </a:rPr>
               <a:t>Xem trực tiếp, xem lại và bảo trì bẫy</a:t>
             </a:r>
-            <a:endParaRPr lang="en-US" sz="3190" dirty="0"/>
+            <a:endParaRPr lang="vi-VN" sz="3190" dirty="0"/>
           </a:p>
         </p:txBody>
       </p:sp>
@@ -10763,17 +11091,17 @@
               <a:buNone/>
             </a:pPr>
             <a:r>
-              <a:rPr lang="en-US" sz="1600" b="1" dirty="0">
+              <a:rPr lang="vi-VN" sz="1600" b="1" dirty="0">
                 <a:solidFill>
                   <a:srgbClr val="13261D"/>
                 </a:solidFill>
-                <a:latin typeface="Be Vietnam Pro" pitchFamily="34" charset="0"/>
-                <a:ea typeface="Be Vietnam Pro" pitchFamily="34" charset="-122"/>
-                <a:cs typeface="Be Vietnam Pro" pitchFamily="34" charset="-120"/>
+                <a:latin typeface="Arial" pitchFamily="34" charset="0"/>
+                <a:ea typeface="Arial" pitchFamily="34" charset="-122"/>
+                <a:cs typeface="Arial" pitchFamily="34" charset="-120"/>
               </a:rPr>
               <a:t>Trực tiếp và chụp ngay</a:t>
             </a:r>
-            <a:endParaRPr lang="en-US" sz="1600" dirty="0"/>
+            <a:endParaRPr lang="vi-VN" sz="1600" dirty="0"/>
           </a:p>
         </p:txBody>
       </p:sp>
@@ -10807,17 +11135,17 @@
               <a:buNone/>
             </a:pPr>
             <a:r>
-              <a:rPr lang="en-US" sz="1300" dirty="0">
+              <a:rPr lang="vi-VN" sz="1300" dirty="0">
                 <a:solidFill>
                   <a:srgbClr val="4A5A50"/>
                 </a:solidFill>
-                <a:latin typeface="Be Vietnam Pro" pitchFamily="34" charset="0"/>
-                <a:ea typeface="Be Vietnam Pro" pitchFamily="34" charset="-122"/>
-                <a:cs typeface="Be Vietnam Pro" pitchFamily="34" charset="-120"/>
+                <a:latin typeface="Arial" pitchFamily="34" charset="0"/>
+                <a:ea typeface="Arial" pitchFamily="34" charset="-122"/>
+                <a:cs typeface="Arial" pitchFamily="34" charset="-120"/>
               </a:rPr>
               <a:t>Hình trực tiếp từ camera, chụp và phân tích ngay khi cần.</a:t>
             </a:r>
-            <a:endParaRPr lang="en-US" sz="1300" dirty="0"/>
+            <a:endParaRPr lang="vi-VN" sz="1300" dirty="0"/>
           </a:p>
         </p:txBody>
       </p:sp>
@@ -10851,17 +11179,17 @@
               <a:buNone/>
             </a:pPr>
             <a:r>
-              <a:rPr lang="en-US" sz="1600" b="1" dirty="0">
+              <a:rPr lang="vi-VN" sz="1600" b="1" dirty="0">
                 <a:solidFill>
                   <a:srgbClr val="13261D"/>
                 </a:solidFill>
-                <a:latin typeface="Be Vietnam Pro" pitchFamily="34" charset="0"/>
-                <a:ea typeface="Be Vietnam Pro" pitchFamily="34" charset="-122"/>
-                <a:cs typeface="Be Vietnam Pro" pitchFamily="34" charset="-120"/>
+                <a:latin typeface="Arial" pitchFamily="34" charset="0"/>
+                <a:ea typeface="Arial" pitchFamily="34" charset="-122"/>
+                <a:cs typeface="Arial" pitchFamily="34" charset="-120"/>
               </a:rPr>
               <a:t>Xem lại theo dòng thời gian</a:t>
             </a:r>
-            <a:endParaRPr lang="en-US" sz="1600" dirty="0"/>
+            <a:endParaRPr lang="vi-VN" sz="1600" dirty="0"/>
           </a:p>
         </p:txBody>
       </p:sp>
@@ -10895,17 +11223,17 @@
               <a:buNone/>
             </a:pPr>
             <a:r>
-              <a:rPr lang="en-US" sz="1300" dirty="0">
+              <a:rPr lang="vi-VN" sz="1300" dirty="0">
                 <a:solidFill>
                   <a:srgbClr val="4A5A50"/>
                 </a:solidFill>
-                <a:latin typeface="Be Vietnam Pro" pitchFamily="34" charset="0"/>
-                <a:ea typeface="Be Vietnam Pro" pitchFamily="34" charset="-122"/>
-                <a:cs typeface="Be Vietnam Pro" pitchFamily="34" charset="-120"/>
+                <a:latin typeface="Arial" pitchFamily="34" charset="0"/>
+                <a:ea typeface="Arial" pitchFamily="34" charset="-122"/>
+                <a:cs typeface="Arial" pitchFamily="34" charset="-120"/>
               </a:rPr>
               <a:t>Đoạn ghi hình trên thẻ nhớ xếp theo giờ, lùi tiến từng ngày.</a:t>
             </a:r>
-            <a:endParaRPr lang="en-US" sz="1300" dirty="0"/>
+            <a:endParaRPr lang="vi-VN" sz="1300" dirty="0"/>
           </a:p>
         </p:txBody>
       </p:sp>
@@ -10939,17 +11267,17 @@
               <a:buNone/>
             </a:pPr>
             <a:r>
-              <a:rPr lang="en-US" sz="1600" b="1" dirty="0">
+              <a:rPr lang="vi-VN" sz="1600" b="1" dirty="0">
                 <a:solidFill>
                   <a:srgbClr val="13261D"/>
                 </a:solidFill>
-                <a:latin typeface="Be Vietnam Pro" pitchFamily="34" charset="0"/>
-                <a:ea typeface="Be Vietnam Pro" pitchFamily="34" charset="-122"/>
-                <a:cs typeface="Be Vietnam Pro" pitchFamily="34" charset="-120"/>
+                <a:latin typeface="Arial" pitchFamily="34" charset="0"/>
+                <a:ea typeface="Arial" pitchFamily="34" charset="-122"/>
+                <a:cs typeface="Arial" pitchFamily="34" charset="-120"/>
               </a:rPr>
               <a:t>Bảo trì bẫy</a:t>
             </a:r>
-            <a:endParaRPr lang="en-US" sz="1600" dirty="0"/>
+            <a:endParaRPr lang="vi-VN" sz="1600" dirty="0"/>
           </a:p>
         </p:txBody>
       </p:sp>
@@ -10983,17 +11311,17 @@
               <a:buNone/>
             </a:pPr>
             <a:r>
-              <a:rPr lang="en-US" sz="1300" dirty="0">
+              <a:rPr lang="vi-VN" sz="1300" dirty="0">
                 <a:solidFill>
                   <a:srgbClr val="4A5A50"/>
                 </a:solidFill>
-                <a:latin typeface="Be Vietnam Pro" pitchFamily="34" charset="0"/>
-                <a:ea typeface="Be Vietnam Pro" pitchFamily="34" charset="-122"/>
-                <a:cs typeface="Be Vietnam Pro" pitchFamily="34" charset="-120"/>
+                <a:latin typeface="Arial" pitchFamily="34" charset="0"/>
+                <a:ea typeface="Arial" pitchFamily="34" charset="-122"/>
+                <a:cs typeface="Arial" pitchFamily="34" charset="-120"/>
               </a:rPr>
               <a:t>Ghi nhận thay tấm keo, nhắc thay khi đến hạn.</a:t>
             </a:r>
-            <a:endParaRPr lang="en-US" sz="1300" dirty="0"/>
+            <a:endParaRPr lang="vi-VN" sz="1300" dirty="0"/>
           </a:p>
         </p:txBody>
       </p:sp>
@@ -11027,17 +11355,17 @@
               <a:buNone/>
             </a:pPr>
             <a:r>
-              <a:rPr lang="en-US" sz="1200" dirty="0">
+              <a:rPr lang="vi-VN" sz="1200" dirty="0">
                 <a:solidFill>
                   <a:srgbClr val="6B7B70"/>
                 </a:solidFill>
-                <a:latin typeface="Be Vietnam Pro" pitchFamily="34" charset="0"/>
-                <a:ea typeface="Be Vietnam Pro" pitchFamily="34" charset="-122"/>
-                <a:cs typeface="Be Vietnam Pro" pitchFamily="34" charset="-120"/>
+                <a:latin typeface="Arial" pitchFamily="34" charset="0"/>
+                <a:ea typeface="Arial" pitchFamily="34" charset="-122"/>
+                <a:cs typeface="Arial" pitchFamily="34" charset="-120"/>
               </a:rPr>
               <a:t>FlyBot · 8</a:t>
             </a:r>
-            <a:endParaRPr lang="en-US" sz="1200" dirty="0"/>
+            <a:endParaRPr lang="vi-VN" sz="1200" dirty="0"/>
           </a:p>
         </p:txBody>
       </p:sp>
@@ -11103,17 +11431,17 @@
               <a:buNone/>
             </a:pPr>
             <a:r>
-              <a:rPr lang="en-US" sz="1196" b="1" spc="150" kern="0" dirty="0">
+              <a:rPr lang="vi-VN" sz="1196" b="1" spc="150" kern="0" dirty="0">
                 <a:solidFill>
                   <a:srgbClr val="1D7A50"/>
                 </a:solidFill>
-                <a:latin typeface="Be Vietnam Pro" pitchFamily="34" charset="0"/>
-                <a:ea typeface="Be Vietnam Pro" pitchFamily="34" charset="-122"/>
-                <a:cs typeface="Be Vietnam Pro" pitchFamily="34" charset="-120"/>
+                <a:latin typeface="Arial" pitchFamily="34" charset="0"/>
+                <a:ea typeface="Arial" pitchFamily="34" charset="-122"/>
+                <a:cs typeface="Arial" pitchFamily="34" charset="-120"/>
               </a:rPr>
               <a:t>CẢNH BÁO</a:t>
             </a:r>
-            <a:endParaRPr lang="en-US" sz="1196" dirty="0"/>
+            <a:endParaRPr lang="vi-VN" sz="1196" dirty="0"/>
           </a:p>
         </p:txBody>
       </p:sp>
@@ -11149,17 +11477,17 @@
               <a:buNone/>
             </a:pPr>
             <a:r>
-              <a:rPr lang="en-US" sz="3190" b="1" i="0" dirty="0">
+              <a:rPr lang="vi-VN" sz="3190" b="1" i="0" dirty="0">
                 <a:solidFill>
                   <a:srgbClr val="13261D"/>
                 </a:solidFill>
-                <a:latin typeface="Be Vietnam Pro" pitchFamily="34" charset="0"/>
-                <a:ea typeface="Be Vietnam Pro" pitchFamily="34" charset="-122"/>
-                <a:cs typeface="Be Vietnam Pro" pitchFamily="34" charset="-120"/>
+                <a:latin typeface="Arial" pitchFamily="34" charset="0"/>
+                <a:ea typeface="Arial" pitchFamily="34" charset="-122"/>
+                <a:cs typeface="Arial" pitchFamily="34" charset="-120"/>
               </a:rPr>
               <a:t>Biết ngay khi cần ra vườn</a:t>
             </a:r>
-            <a:endParaRPr lang="en-US" sz="3190" dirty="0"/>
+            <a:endParaRPr lang="vi-VN" sz="3190" dirty="0"/>
           </a:p>
         </p:txBody>
       </p:sp>
@@ -11272,17 +11600,17 @@
               <a:buNone/>
             </a:pPr>
             <a:r>
-              <a:rPr lang="en-US" sz="1600" b="1" dirty="0">
+              <a:rPr lang="vi-VN" sz="1600" b="1" dirty="0">
                 <a:solidFill>
                   <a:srgbClr val="13261D"/>
                 </a:solidFill>
-                <a:latin typeface="Be Vietnam Pro" pitchFamily="34" charset="0"/>
-                <a:ea typeface="Be Vietnam Pro" pitchFamily="34" charset="-122"/>
-                <a:cs typeface="Be Vietnam Pro" pitchFamily="34" charset="-120"/>
+                <a:latin typeface="Arial" pitchFamily="34" charset="0"/>
+                <a:ea typeface="Arial" pitchFamily="34" charset="-122"/>
+                <a:cs typeface="Arial" pitchFamily="34" charset="-120"/>
               </a:rPr>
               <a:t>Đúng lúc</a:t>
             </a:r>
-            <a:endParaRPr lang="en-US" sz="1600" dirty="0"/>
+            <a:endParaRPr lang="vi-VN" sz="1600" dirty="0"/>
           </a:p>
         </p:txBody>
       </p:sp>
@@ -11316,17 +11644,17 @@
               <a:buNone/>
             </a:pPr>
             <a:r>
-              <a:rPr lang="en-US" sz="1300" dirty="0">
+              <a:rPr lang="vi-VN" sz="1300" dirty="0">
                 <a:solidFill>
                   <a:srgbClr val="4A5A50"/>
                 </a:solidFill>
-                <a:latin typeface="Be Vietnam Pro" pitchFamily="34" charset="0"/>
-                <a:ea typeface="Be Vietnam Pro" pitchFamily="34" charset="-122"/>
-                <a:cs typeface="Be Vietnam Pro" pitchFamily="34" charset="-120"/>
+                <a:latin typeface="Arial" pitchFamily="34" charset="0"/>
+                <a:ea typeface="Arial" pitchFamily="34" charset="-122"/>
+                <a:cs typeface="Arial" pitchFamily="34" charset="-120"/>
               </a:rPr>
               <a:t>Vượt ngưỡng từng bẫy, tăng đột biến, camera mất kết nối, đến hạn thay tấm.</a:t>
             </a:r>
-            <a:endParaRPr lang="en-US" sz="1300" dirty="0"/>
+            <a:endParaRPr lang="vi-VN" sz="1300" dirty="0"/>
           </a:p>
         </p:txBody>
       </p:sp>
@@ -11360,17 +11688,17 @@
               <a:buNone/>
             </a:pPr>
             <a:r>
-              <a:rPr lang="en-US" sz="1600" b="1" dirty="0">
+              <a:rPr lang="vi-VN" sz="1600" b="1" dirty="0">
                 <a:solidFill>
                   <a:srgbClr val="13261D"/>
                 </a:solidFill>
-                <a:latin typeface="Be Vietnam Pro" pitchFamily="34" charset="0"/>
-                <a:ea typeface="Be Vietnam Pro" pitchFamily="34" charset="-122"/>
-                <a:cs typeface="Be Vietnam Pro" pitchFamily="34" charset="-120"/>
+                <a:latin typeface="Arial" pitchFamily="34" charset="0"/>
+                <a:ea typeface="Arial" pitchFamily="34" charset="-122"/>
+                <a:cs typeface="Arial" pitchFamily="34" charset="-120"/>
               </a:rPr>
               <a:t>Đúng kênh</a:t>
             </a:r>
-            <a:endParaRPr lang="en-US" sz="1600" dirty="0"/>
+            <a:endParaRPr lang="vi-VN" sz="1600" dirty="0"/>
           </a:p>
         </p:txBody>
       </p:sp>
@@ -11404,17 +11732,17 @@
               <a:buNone/>
             </a:pPr>
             <a:r>
-              <a:rPr lang="en-US" sz="1300" dirty="0">
+              <a:rPr lang="vi-VN" sz="1300" dirty="0">
                 <a:solidFill>
                   <a:srgbClr val="4A5A50"/>
                 </a:solidFill>
-                <a:latin typeface="Be Vietnam Pro" pitchFamily="34" charset="0"/>
-                <a:ea typeface="Be Vietnam Pro" pitchFamily="34" charset="-122"/>
-                <a:cs typeface="Be Vietnam Pro" pitchFamily="34" charset="-120"/>
+                <a:latin typeface="Arial" pitchFamily="34" charset="0"/>
+                <a:ea typeface="Arial" pitchFamily="34" charset="-122"/>
+                <a:cs typeface="Arial" pitchFamily="34" charset="-120"/>
               </a:rPr>
               <a:t>Trong ứng dụng, thông báo đẩy, email, Telegram; bản tin sáng 6:30 nếu bật.</a:t>
             </a:r>
-            <a:endParaRPr lang="en-US" sz="1300" dirty="0"/>
+            <a:endParaRPr lang="vi-VN" sz="1300" dirty="0"/>
           </a:p>
         </p:txBody>
       </p:sp>
@@ -11448,17 +11776,17 @@
               <a:buNone/>
             </a:pPr>
             <a:r>
-              <a:rPr lang="en-US" sz="1600" b="1" dirty="0">
+              <a:rPr lang="vi-VN" sz="1600" b="1" dirty="0">
                 <a:solidFill>
                   <a:srgbClr val="13261D"/>
                 </a:solidFill>
-                <a:latin typeface="Be Vietnam Pro" pitchFamily="34" charset="0"/>
-                <a:ea typeface="Be Vietnam Pro" pitchFamily="34" charset="-122"/>
-                <a:cs typeface="Be Vietnam Pro" pitchFamily="34" charset="-120"/>
+                <a:latin typeface="Arial" pitchFamily="34" charset="0"/>
+                <a:ea typeface="Arial" pitchFamily="34" charset="-122"/>
+                <a:cs typeface="Arial" pitchFamily="34" charset="-120"/>
               </a:rPr>
               <a:t>Không làm phiền</a:t>
             </a:r>
-            <a:endParaRPr lang="en-US" sz="1600" dirty="0"/>
+            <a:endParaRPr lang="vi-VN" sz="1600" dirty="0"/>
           </a:p>
         </p:txBody>
       </p:sp>
@@ -11492,17 +11820,17 @@
               <a:buNone/>
             </a:pPr>
             <a:r>
-              <a:rPr lang="en-US" sz="1300" dirty="0">
+              <a:rPr lang="vi-VN" sz="1300" dirty="0">
                 <a:solidFill>
                   <a:srgbClr val="4A5A50"/>
                 </a:solidFill>
-                <a:latin typeface="Be Vietnam Pro" pitchFamily="34" charset="0"/>
-                <a:ea typeface="Be Vietnam Pro" pitchFamily="34" charset="-122"/>
-                <a:cs typeface="Be Vietnam Pro" pitchFamily="34" charset="-120"/>
+                <a:latin typeface="Arial" pitchFamily="34" charset="0"/>
+                <a:ea typeface="Arial" pitchFamily="34" charset="-122"/>
+                <a:cs typeface="Arial" pitchFamily="34" charset="-120"/>
               </a:rPr>
               <a:t>Chọn loại cảnh báo, giờ yên lặng và thời gian chờ giữa hai lần báo.</a:t>
             </a:r>
-            <a:endParaRPr lang="en-US" sz="1300" dirty="0"/>
+            <a:endParaRPr lang="vi-VN" sz="1300" dirty="0"/>
           </a:p>
         </p:txBody>
       </p:sp>
@@ -11536,17 +11864,17 @@
               <a:buNone/>
             </a:pPr>
             <a:r>
-              <a:rPr lang="en-US" sz="1200" dirty="0">
+              <a:rPr lang="vi-VN" sz="1200" dirty="0">
                 <a:solidFill>
                   <a:srgbClr val="6B7B70"/>
                 </a:solidFill>
-                <a:latin typeface="Be Vietnam Pro" pitchFamily="34" charset="0"/>
-                <a:ea typeface="Be Vietnam Pro" pitchFamily="34" charset="-122"/>
-                <a:cs typeface="Be Vietnam Pro" pitchFamily="34" charset="-120"/>
+                <a:latin typeface="Arial" pitchFamily="34" charset="0"/>
+                <a:ea typeface="Arial" pitchFamily="34" charset="-122"/>
+                <a:cs typeface="Arial" pitchFamily="34" charset="-120"/>
               </a:rPr>
               <a:t>FlyBot · 9</a:t>
             </a:r>
-            <a:endParaRPr lang="en-US" sz="1200" dirty="0"/>
+            <a:endParaRPr lang="vi-VN" sz="1200" dirty="0"/>
           </a:p>
         </p:txBody>
       </p:sp>
@@ -11601,7 +11929,7 @@
     </a:clrScheme>
     <a:fontScheme name="FlyBot – Giới thiệu ứng dụng">
       <a:majorFont>
-        <a:latin typeface="Be Vietnam Pro"/>
+        <a:latin typeface="Arial"/>
         <a:ea typeface=""/>
         <a:cs typeface=""/>
         <a:font script="Jpan" typeface="游ゴシック Light"/>
@@ -11653,7 +11981,7 @@
         <a:font script="Tfng" typeface="Ebrima"/>
       </a:majorFont>
       <a:minorFont>
-        <a:latin typeface="Be Vietnam Pro"/>
+        <a:latin typeface="Arial"/>
         <a:ea typeface=""/>
         <a:cs typeface=""/>
         <a:font script="Jpan" typeface="游ゴシック"/>

</xml_diff>